<commit_message>
add association rules pptx
</commit_message>
<xml_diff>
--- a/20242/Part 4-Associatin Rules Mining/beta/4-1-association_rules_mining.pptx
+++ b/20242/Part 4-Associatin Rules Mining/beta/4-1-association_rules_mining.pptx
@@ -5,7 +5,7 @@
     <p:sldMasterId id="2147483648" r:id="rId1"/>
   </p:sldMasterIdLst>
   <p:notesMasterIdLst>
-    <p:notesMasterId r:id="rId31"/>
+    <p:notesMasterId r:id="rId32"/>
   </p:notesMasterIdLst>
   <p:sldIdLst>
     <p:sldId id="483" r:id="rId2"/>
@@ -17,26 +17,27 @@
     <p:sldId id="490" r:id="rId8"/>
     <p:sldId id="513" r:id="rId9"/>
     <p:sldId id="523" r:id="rId10"/>
-    <p:sldId id="517" r:id="rId11"/>
-    <p:sldId id="518" r:id="rId12"/>
-    <p:sldId id="515" r:id="rId13"/>
-    <p:sldId id="514" r:id="rId14"/>
-    <p:sldId id="516" r:id="rId15"/>
-    <p:sldId id="497" r:id="rId16"/>
-    <p:sldId id="498" r:id="rId17"/>
-    <p:sldId id="499" r:id="rId18"/>
-    <p:sldId id="500" r:id="rId19"/>
-    <p:sldId id="501" r:id="rId20"/>
-    <p:sldId id="502" r:id="rId21"/>
-    <p:sldId id="503" r:id="rId22"/>
-    <p:sldId id="504" r:id="rId23"/>
-    <p:sldId id="505" r:id="rId24"/>
-    <p:sldId id="506" r:id="rId25"/>
-    <p:sldId id="507" r:id="rId26"/>
-    <p:sldId id="508" r:id="rId27"/>
-    <p:sldId id="509" r:id="rId28"/>
-    <p:sldId id="510" r:id="rId29"/>
-    <p:sldId id="511" r:id="rId30"/>
+    <p:sldId id="524" r:id="rId11"/>
+    <p:sldId id="517" r:id="rId12"/>
+    <p:sldId id="518" r:id="rId13"/>
+    <p:sldId id="515" r:id="rId14"/>
+    <p:sldId id="514" r:id="rId15"/>
+    <p:sldId id="516" r:id="rId16"/>
+    <p:sldId id="497" r:id="rId17"/>
+    <p:sldId id="498" r:id="rId18"/>
+    <p:sldId id="499" r:id="rId19"/>
+    <p:sldId id="500" r:id="rId20"/>
+    <p:sldId id="501" r:id="rId21"/>
+    <p:sldId id="502" r:id="rId22"/>
+    <p:sldId id="503" r:id="rId23"/>
+    <p:sldId id="504" r:id="rId24"/>
+    <p:sldId id="505" r:id="rId25"/>
+    <p:sldId id="506" r:id="rId26"/>
+    <p:sldId id="507" r:id="rId27"/>
+    <p:sldId id="508" r:id="rId28"/>
+    <p:sldId id="509" r:id="rId29"/>
+    <p:sldId id="510" r:id="rId30"/>
+    <p:sldId id="511" r:id="rId31"/>
   </p:sldIdLst>
   <p:sldSz cx="12192000" cy="6858000"/>
   <p:notesSz cx="6858000" cy="9144000"/>
@@ -152,13 +153,1254 @@
 <file path=ppt/revisionInfo.xml><?xml version="1.0" encoding="utf-8"?>
 <p1510:revInfo xmlns:a="http://schemas.openxmlformats.org/drawingml/2006/main" xmlns:r="http://schemas.openxmlformats.org/officeDocument/2006/relationships" xmlns:p1510="http://schemas.microsoft.com/office/powerpoint/2015/10/main">
   <p1510:revLst>
-    <p1510:client id="{7E2E8029-2718-4E74-A1E0-5ED48AB79672}" v="196" dt="2025-06-07T08:51:04.461"/>
+    <p1510:client id="{5A53F68D-5D62-2F91-0C34-5AF0710613BB}" v="270" dt="2025-06-18T07:34:46.145"/>
   </p1510:revLst>
 </p1510:revInfo>
 </file>
 
 <file path=ppt/changesInfos/changesInfo1.xml><?xml version="1.0" encoding="utf-8"?>
 <pc:chgInfo xmlns:a="http://schemas.openxmlformats.org/drawingml/2006/main" xmlns:r="http://schemas.openxmlformats.org/officeDocument/2006/relationships" xmlns:ac="http://schemas.microsoft.com/office/drawing/2013/main/command" xmlns:pc="http://schemas.microsoft.com/office/powerpoint/2013/main/command">
+  <pc:docChgLst>
+    <pc:chgData name="Mohammed Fasha" userId="cc64f42d-a1a6-4f08-b97b-0c37f877119f" providerId="ADAL" clId="{BECD4A7F-C1AF-4585-8C31-FE7D4FE3ED16}"/>
+    <pc:docChg chg="undo redo custSel addSld delSld modSld sldOrd">
+      <pc:chgData name="Mohammed Fasha" userId="cc64f42d-a1a6-4f08-b97b-0c37f877119f" providerId="ADAL" clId="{BECD4A7F-C1AF-4585-8C31-FE7D4FE3ED16}" dt="2025-01-05T16:36:16.605" v="1945" actId="1076"/>
+      <pc:docMkLst>
+        <pc:docMk/>
+      </pc:docMkLst>
+      <pc:sldChg chg="modSp mod">
+        <pc:chgData name="Mohammed Fasha" userId="cc64f42d-a1a6-4f08-b97b-0c37f877119f" providerId="ADAL" clId="{BECD4A7F-C1AF-4585-8C31-FE7D4FE3ED16}" dt="2024-12-30T18:47:27.683" v="988" actId="20577"/>
+        <pc:sldMkLst>
+          <pc:docMk/>
+          <pc:sldMk cId="2281221656" sldId="527"/>
+        </pc:sldMkLst>
+      </pc:sldChg>
+      <pc:sldChg chg="modSp mod">
+        <pc:chgData name="Mohammed Fasha" userId="cc64f42d-a1a6-4f08-b97b-0c37f877119f" providerId="ADAL" clId="{BECD4A7F-C1AF-4585-8C31-FE7D4FE3ED16}" dt="2024-12-27T13:59:26.893" v="366" actId="20577"/>
+        <pc:sldMkLst>
+          <pc:docMk/>
+          <pc:sldMk cId="3474268344" sldId="596"/>
+        </pc:sldMkLst>
+      </pc:sldChg>
+      <pc:sldChg chg="modSp mod">
+        <pc:chgData name="Mohammed Fasha" userId="cc64f42d-a1a6-4f08-b97b-0c37f877119f" providerId="ADAL" clId="{BECD4A7F-C1AF-4585-8C31-FE7D4FE3ED16}" dt="2024-12-30T18:44:34.649" v="884" actId="20577"/>
+        <pc:sldMkLst>
+          <pc:docMk/>
+          <pc:sldMk cId="916802035" sldId="651"/>
+        </pc:sldMkLst>
+      </pc:sldChg>
+      <pc:sldChg chg="del">
+        <pc:chgData name="Mohammed Fasha" userId="cc64f42d-a1a6-4f08-b97b-0c37f877119f" providerId="ADAL" clId="{BECD4A7F-C1AF-4585-8C31-FE7D4FE3ED16}" dt="2025-01-05T14:42:38.675" v="989" actId="2696"/>
+        <pc:sldMkLst>
+          <pc:docMk/>
+          <pc:sldMk cId="426516858" sldId="662"/>
+        </pc:sldMkLst>
+      </pc:sldChg>
+      <pc:sldChg chg="modSp add del mod">
+        <pc:chgData name="Mohammed Fasha" userId="cc64f42d-a1a6-4f08-b97b-0c37f877119f" providerId="ADAL" clId="{BECD4A7F-C1AF-4585-8C31-FE7D4FE3ED16}" dt="2025-01-05T16:34:59.233" v="1926" actId="20577"/>
+        <pc:sldMkLst>
+          <pc:docMk/>
+          <pc:sldMk cId="691538069" sldId="662"/>
+        </pc:sldMkLst>
+      </pc:sldChg>
+      <pc:sldChg chg="del">
+        <pc:chgData name="Mohammed Fasha" userId="cc64f42d-a1a6-4f08-b97b-0c37f877119f" providerId="ADAL" clId="{BECD4A7F-C1AF-4585-8C31-FE7D4FE3ED16}" dt="2025-01-05T14:42:38.675" v="989" actId="2696"/>
+        <pc:sldMkLst>
+          <pc:docMk/>
+          <pc:sldMk cId="895445062" sldId="663"/>
+        </pc:sldMkLst>
+      </pc:sldChg>
+      <pc:sldChg chg="add del">
+        <pc:chgData name="Mohammed Fasha" userId="cc64f42d-a1a6-4f08-b97b-0c37f877119f" providerId="ADAL" clId="{BECD4A7F-C1AF-4585-8C31-FE7D4FE3ED16}" dt="2025-01-05T14:43:16.100" v="993" actId="2696"/>
+        <pc:sldMkLst>
+          <pc:docMk/>
+          <pc:sldMk cId="3980180774" sldId="663"/>
+        </pc:sldMkLst>
+      </pc:sldChg>
+      <pc:sldChg chg="add del">
+        <pc:chgData name="Mohammed Fasha" userId="cc64f42d-a1a6-4f08-b97b-0c37f877119f" providerId="ADAL" clId="{BECD4A7F-C1AF-4585-8C31-FE7D4FE3ED16}" dt="2025-01-05T14:43:16.100" v="993" actId="2696"/>
+        <pc:sldMkLst>
+          <pc:docMk/>
+          <pc:sldMk cId="1728680596" sldId="664"/>
+        </pc:sldMkLst>
+      </pc:sldChg>
+      <pc:sldChg chg="del">
+        <pc:chgData name="Mohammed Fasha" userId="cc64f42d-a1a6-4f08-b97b-0c37f877119f" providerId="ADAL" clId="{BECD4A7F-C1AF-4585-8C31-FE7D4FE3ED16}" dt="2025-01-05T14:42:38.675" v="989" actId="2696"/>
+        <pc:sldMkLst>
+          <pc:docMk/>
+          <pc:sldMk cId="3900588277" sldId="664"/>
+        </pc:sldMkLst>
+      </pc:sldChg>
+      <pc:sldChg chg="del">
+        <pc:chgData name="Mohammed Fasha" userId="cc64f42d-a1a6-4f08-b97b-0c37f877119f" providerId="ADAL" clId="{BECD4A7F-C1AF-4585-8C31-FE7D4FE3ED16}" dt="2025-01-05T14:42:38.675" v="989" actId="2696"/>
+        <pc:sldMkLst>
+          <pc:docMk/>
+          <pc:sldMk cId="123002105" sldId="665"/>
+        </pc:sldMkLst>
+      </pc:sldChg>
+      <pc:sldChg chg="modSp add del mod">
+        <pc:chgData name="Mohammed Fasha" userId="cc64f42d-a1a6-4f08-b97b-0c37f877119f" providerId="ADAL" clId="{BECD4A7F-C1AF-4585-8C31-FE7D4FE3ED16}" dt="2025-01-05T15:05:12.729" v="1226" actId="21"/>
+        <pc:sldMkLst>
+          <pc:docMk/>
+          <pc:sldMk cId="148099094" sldId="665"/>
+        </pc:sldMkLst>
+      </pc:sldChg>
+      <pc:sldChg chg="del">
+        <pc:chgData name="Mohammed Fasha" userId="cc64f42d-a1a6-4f08-b97b-0c37f877119f" providerId="ADAL" clId="{BECD4A7F-C1AF-4585-8C31-FE7D4FE3ED16}" dt="2025-01-05T14:42:38.675" v="989" actId="2696"/>
+        <pc:sldMkLst>
+          <pc:docMk/>
+          <pc:sldMk cId="659863378" sldId="676"/>
+        </pc:sldMkLst>
+      </pc:sldChg>
+      <pc:sldChg chg="modSp add del mod">
+        <pc:chgData name="Mohammed Fasha" userId="cc64f42d-a1a6-4f08-b97b-0c37f877119f" providerId="ADAL" clId="{BECD4A7F-C1AF-4585-8C31-FE7D4FE3ED16}" dt="2025-01-05T14:55:27.595" v="1130" actId="255"/>
+        <pc:sldMkLst>
+          <pc:docMk/>
+          <pc:sldMk cId="1577854815" sldId="676"/>
+        </pc:sldMkLst>
+      </pc:sldChg>
+      <pc:sldChg chg="modSp add del mod">
+        <pc:chgData name="Mohammed Fasha" userId="cc64f42d-a1a6-4f08-b97b-0c37f877119f" providerId="ADAL" clId="{BECD4A7F-C1AF-4585-8C31-FE7D4FE3ED16}" dt="2025-01-05T14:55:43.754" v="1132" actId="1076"/>
+        <pc:sldMkLst>
+          <pc:docMk/>
+          <pc:sldMk cId="139882925" sldId="677"/>
+        </pc:sldMkLst>
+      </pc:sldChg>
+      <pc:sldChg chg="del">
+        <pc:chgData name="Mohammed Fasha" userId="cc64f42d-a1a6-4f08-b97b-0c37f877119f" providerId="ADAL" clId="{BECD4A7F-C1AF-4585-8C31-FE7D4FE3ED16}" dt="2025-01-05T14:42:38.675" v="989" actId="2696"/>
+        <pc:sldMkLst>
+          <pc:docMk/>
+          <pc:sldMk cId="2736863534" sldId="677"/>
+        </pc:sldMkLst>
+      </pc:sldChg>
+      <pc:sldChg chg="add del">
+        <pc:chgData name="Mohammed Fasha" userId="cc64f42d-a1a6-4f08-b97b-0c37f877119f" providerId="ADAL" clId="{BECD4A7F-C1AF-4585-8C31-FE7D4FE3ED16}" dt="2025-01-05T14:43:16.100" v="993" actId="2696"/>
+        <pc:sldMkLst>
+          <pc:docMk/>
+          <pc:sldMk cId="4146654093" sldId="678"/>
+        </pc:sldMkLst>
+      </pc:sldChg>
+      <pc:sldChg chg="del">
+        <pc:chgData name="Mohammed Fasha" userId="cc64f42d-a1a6-4f08-b97b-0c37f877119f" providerId="ADAL" clId="{BECD4A7F-C1AF-4585-8C31-FE7D4FE3ED16}" dt="2025-01-05T14:42:38.675" v="989" actId="2696"/>
+        <pc:sldMkLst>
+          <pc:docMk/>
+          <pc:sldMk cId="4228312762" sldId="678"/>
+        </pc:sldMkLst>
+      </pc:sldChg>
+      <pc:sldChg chg="del">
+        <pc:chgData name="Mohammed Fasha" userId="cc64f42d-a1a6-4f08-b97b-0c37f877119f" providerId="ADAL" clId="{BECD4A7F-C1AF-4585-8C31-FE7D4FE3ED16}" dt="2025-01-05T14:42:38.675" v="989" actId="2696"/>
+        <pc:sldMkLst>
+          <pc:docMk/>
+          <pc:sldMk cId="581717462" sldId="679"/>
+        </pc:sldMkLst>
+      </pc:sldChg>
+      <pc:sldChg chg="addSp delSp modSp add del mod chgLayout">
+        <pc:chgData name="Mohammed Fasha" userId="cc64f42d-a1a6-4f08-b97b-0c37f877119f" providerId="ADAL" clId="{BECD4A7F-C1AF-4585-8C31-FE7D4FE3ED16}" dt="2025-01-05T16:36:16.605" v="1945" actId="1076"/>
+        <pc:sldMkLst>
+          <pc:docMk/>
+          <pc:sldMk cId="3454522070" sldId="679"/>
+        </pc:sldMkLst>
+      </pc:sldChg>
+      <pc:sldChg chg="add del">
+        <pc:chgData name="Mohammed Fasha" userId="cc64f42d-a1a6-4f08-b97b-0c37f877119f" providerId="ADAL" clId="{BECD4A7F-C1AF-4585-8C31-FE7D4FE3ED16}" dt="2025-01-05T14:43:16.100" v="993" actId="2696"/>
+        <pc:sldMkLst>
+          <pc:docMk/>
+          <pc:sldMk cId="2856814121" sldId="681"/>
+        </pc:sldMkLst>
+      </pc:sldChg>
+      <pc:sldChg chg="del">
+        <pc:chgData name="Mohammed Fasha" userId="cc64f42d-a1a6-4f08-b97b-0c37f877119f" providerId="ADAL" clId="{BECD4A7F-C1AF-4585-8C31-FE7D4FE3ED16}" dt="2025-01-05T14:42:38.675" v="989" actId="2696"/>
+        <pc:sldMkLst>
+          <pc:docMk/>
+          <pc:sldMk cId="3083966018" sldId="681"/>
+        </pc:sldMkLst>
+      </pc:sldChg>
+      <pc:sldChg chg="modSp mod">
+        <pc:chgData name="Mohammed Fasha" userId="cc64f42d-a1a6-4f08-b97b-0c37f877119f" providerId="ADAL" clId="{BECD4A7F-C1AF-4585-8C31-FE7D4FE3ED16}" dt="2025-01-05T14:42:50.596" v="990" actId="14100"/>
+        <pc:sldMkLst>
+          <pc:docMk/>
+          <pc:sldMk cId="1697141369" sldId="695"/>
+        </pc:sldMkLst>
+      </pc:sldChg>
+      <pc:sldChg chg="addSp delSp modSp add del mod">
+        <pc:chgData name="Mohammed Fasha" userId="cc64f42d-a1a6-4f08-b97b-0c37f877119f" providerId="ADAL" clId="{BECD4A7F-C1AF-4585-8C31-FE7D4FE3ED16}" dt="2025-01-05T14:54:31.375" v="1125" actId="14100"/>
+        <pc:sldMkLst>
+          <pc:docMk/>
+          <pc:sldMk cId="265576630" sldId="698"/>
+        </pc:sldMkLst>
+      </pc:sldChg>
+      <pc:sldChg chg="del">
+        <pc:chgData name="Mohammed Fasha" userId="cc64f42d-a1a6-4f08-b97b-0c37f877119f" providerId="ADAL" clId="{BECD4A7F-C1AF-4585-8C31-FE7D4FE3ED16}" dt="2025-01-05T14:42:38.675" v="989" actId="2696"/>
+        <pc:sldMkLst>
+          <pc:docMk/>
+          <pc:sldMk cId="991725834" sldId="698"/>
+        </pc:sldMkLst>
+      </pc:sldChg>
+      <pc:sldChg chg="del">
+        <pc:chgData name="Mohammed Fasha" userId="cc64f42d-a1a6-4f08-b97b-0c37f877119f" providerId="ADAL" clId="{BECD4A7F-C1AF-4585-8C31-FE7D4FE3ED16}" dt="2025-01-05T14:42:38.675" v="989" actId="2696"/>
+        <pc:sldMkLst>
+          <pc:docMk/>
+          <pc:sldMk cId="3109561867" sldId="700"/>
+        </pc:sldMkLst>
+      </pc:sldChg>
+      <pc:sldChg chg="addSp delSp modSp add del mod">
+        <pc:chgData name="Mohammed Fasha" userId="cc64f42d-a1a6-4f08-b97b-0c37f877119f" providerId="ADAL" clId="{BECD4A7F-C1AF-4585-8C31-FE7D4FE3ED16}" dt="2025-01-05T16:00:05.564" v="1529" actId="20577"/>
+        <pc:sldMkLst>
+          <pc:docMk/>
+          <pc:sldMk cId="4247717824" sldId="700"/>
+        </pc:sldMkLst>
+      </pc:sldChg>
+      <pc:sldChg chg="addSp delSp modSp add mod">
+        <pc:chgData name="Mohammed Fasha" userId="cc64f42d-a1a6-4f08-b97b-0c37f877119f" providerId="ADAL" clId="{BECD4A7F-C1AF-4585-8C31-FE7D4FE3ED16}" dt="2025-01-05T14:53:29.185" v="1101" actId="21"/>
+        <pc:sldMkLst>
+          <pc:docMk/>
+          <pc:sldMk cId="67871309" sldId="709"/>
+        </pc:sldMkLst>
+      </pc:sldChg>
+      <pc:sldChg chg="modSp add mod">
+        <pc:chgData name="Mohammed Fasha" userId="cc64f42d-a1a6-4f08-b97b-0c37f877119f" providerId="ADAL" clId="{BECD4A7F-C1AF-4585-8C31-FE7D4FE3ED16}" dt="2025-01-05T15:31:09.113" v="1385" actId="6549"/>
+        <pc:sldMkLst>
+          <pc:docMk/>
+          <pc:sldMk cId="4114896152" sldId="710"/>
+        </pc:sldMkLst>
+      </pc:sldChg>
+      <pc:sldChg chg="addSp modSp add mod">
+        <pc:chgData name="Mohammed Fasha" userId="cc64f42d-a1a6-4f08-b97b-0c37f877119f" providerId="ADAL" clId="{BECD4A7F-C1AF-4585-8C31-FE7D4FE3ED16}" dt="2025-01-05T15:27:36.027" v="1348" actId="20577"/>
+        <pc:sldMkLst>
+          <pc:docMk/>
+          <pc:sldMk cId="3794385322" sldId="711"/>
+        </pc:sldMkLst>
+      </pc:sldChg>
+      <pc:sldChg chg="add del">
+        <pc:chgData name="Mohammed Fasha" userId="cc64f42d-a1a6-4f08-b97b-0c37f877119f" providerId="ADAL" clId="{BECD4A7F-C1AF-4585-8C31-FE7D4FE3ED16}" dt="2025-01-05T14:57:43.613" v="1146" actId="2696"/>
+        <pc:sldMkLst>
+          <pc:docMk/>
+          <pc:sldMk cId="501127302" sldId="712"/>
+        </pc:sldMkLst>
+      </pc:sldChg>
+      <pc:sldChg chg="modSp add mod">
+        <pc:chgData name="Mohammed Fasha" userId="cc64f42d-a1a6-4f08-b97b-0c37f877119f" providerId="ADAL" clId="{BECD4A7F-C1AF-4585-8C31-FE7D4FE3ED16}" dt="2025-01-05T15:32:23.870" v="1388"/>
+        <pc:sldMkLst>
+          <pc:docMk/>
+          <pc:sldMk cId="3701206727" sldId="712"/>
+        </pc:sldMkLst>
+      </pc:sldChg>
+      <pc:sldChg chg="addSp modSp add mod">
+        <pc:chgData name="Mohammed Fasha" userId="cc64f42d-a1a6-4f08-b97b-0c37f877119f" providerId="ADAL" clId="{BECD4A7F-C1AF-4585-8C31-FE7D4FE3ED16}" dt="2025-01-05T16:06:36.028" v="1538" actId="1076"/>
+        <pc:sldMkLst>
+          <pc:docMk/>
+          <pc:sldMk cId="1499972066" sldId="713"/>
+        </pc:sldMkLst>
+      </pc:sldChg>
+      <pc:sldChg chg="addSp delSp modSp add mod">
+        <pc:chgData name="Mohammed Fasha" userId="cc64f42d-a1a6-4f08-b97b-0c37f877119f" providerId="ADAL" clId="{BECD4A7F-C1AF-4585-8C31-FE7D4FE3ED16}" dt="2025-01-05T16:19:08.436" v="1705" actId="1036"/>
+        <pc:sldMkLst>
+          <pc:docMk/>
+          <pc:sldMk cId="1270641495" sldId="714"/>
+        </pc:sldMkLst>
+      </pc:sldChg>
+      <pc:sldChg chg="addSp modSp new mod">
+        <pc:chgData name="Mohammed Fasha" userId="cc64f42d-a1a6-4f08-b97b-0c37f877119f" providerId="ADAL" clId="{BECD4A7F-C1AF-4585-8C31-FE7D4FE3ED16}" dt="2025-01-05T16:23:44.632" v="1736" actId="12"/>
+        <pc:sldMkLst>
+          <pc:docMk/>
+          <pc:sldMk cId="1096386322" sldId="715"/>
+        </pc:sldMkLst>
+      </pc:sldChg>
+      <pc:sldChg chg="modSp new mod">
+        <pc:chgData name="Mohammed Fasha" userId="cc64f42d-a1a6-4f08-b97b-0c37f877119f" providerId="ADAL" clId="{BECD4A7F-C1AF-4585-8C31-FE7D4FE3ED16}" dt="2025-01-05T16:34:02.360" v="1902" actId="27636"/>
+        <pc:sldMkLst>
+          <pc:docMk/>
+          <pc:sldMk cId="1784058309" sldId="716"/>
+        </pc:sldMkLst>
+      </pc:sldChg>
+      <pc:sldChg chg="modSp add mod ord">
+        <pc:chgData name="Mohammed Fasha" userId="cc64f42d-a1a6-4f08-b97b-0c37f877119f" providerId="ADAL" clId="{BECD4A7F-C1AF-4585-8C31-FE7D4FE3ED16}" dt="2025-01-05T16:27:20.520" v="1803"/>
+        <pc:sldMkLst>
+          <pc:docMk/>
+          <pc:sldMk cId="3139017106" sldId="717"/>
+        </pc:sldMkLst>
+      </pc:sldChg>
+      <pc:sldChg chg="addSp delSp modSp new mod">
+        <pc:chgData name="Mohammed Fasha" userId="cc64f42d-a1a6-4f08-b97b-0c37f877119f" providerId="ADAL" clId="{BECD4A7F-C1AF-4585-8C31-FE7D4FE3ED16}" dt="2025-01-05T16:32:45.446" v="1897" actId="20577"/>
+        <pc:sldMkLst>
+          <pc:docMk/>
+          <pc:sldMk cId="3043812923" sldId="718"/>
+        </pc:sldMkLst>
+      </pc:sldChg>
+    </pc:docChg>
+  </pc:docChgLst>
+  <pc:docChgLst>
+    <pc:chgData name="Mohammed Fasha" userId="S::mohammed.fasha@uop.edu.jo::cc64f42d-a1a6-4f08-b97b-0c37f877119f" providerId="AD" clId="Web-{5A53F68D-5D62-2F91-0C34-5AF0710613BB}"/>
+    <pc:docChg chg="addSld modSld">
+      <pc:chgData name="Mohammed Fasha" userId="S::mohammed.fasha@uop.edu.jo::cc64f42d-a1a6-4f08-b97b-0c37f877119f" providerId="AD" clId="Web-{5A53F68D-5D62-2F91-0C34-5AF0710613BB}" dt="2025-06-18T07:34:46.145" v="255" actId="20577"/>
+      <pc:docMkLst>
+        <pc:docMk/>
+      </pc:docMkLst>
+      <pc:sldChg chg="modSp">
+        <pc:chgData name="Mohammed Fasha" userId="S::mohammed.fasha@uop.edu.jo::cc64f42d-a1a6-4f08-b97b-0c37f877119f" providerId="AD" clId="Web-{5A53F68D-5D62-2F91-0C34-5AF0710613BB}" dt="2025-06-18T07:34:46.145" v="255" actId="20577"/>
+        <pc:sldMkLst>
+          <pc:docMk/>
+          <pc:sldMk cId="1855355283" sldId="498"/>
+        </pc:sldMkLst>
+        <pc:spChg chg="mod">
+          <ac:chgData name="Mohammed Fasha" userId="S::mohammed.fasha@uop.edu.jo::cc64f42d-a1a6-4f08-b97b-0c37f877119f" providerId="AD" clId="Web-{5A53F68D-5D62-2F91-0C34-5AF0710613BB}" dt="2025-06-18T07:34:46.145" v="255" actId="20577"/>
+          <ac:spMkLst>
+            <pc:docMk/>
+            <pc:sldMk cId="1855355283" sldId="498"/>
+            <ac:spMk id="3" creationId="{EE397667-A7E4-7E53-67C9-F8B9D8DAF6D5}"/>
+          </ac:spMkLst>
+        </pc:spChg>
+      </pc:sldChg>
+      <pc:sldChg chg="modSp">
+        <pc:chgData name="Mohammed Fasha" userId="S::mohammed.fasha@uop.edu.jo::cc64f42d-a1a6-4f08-b97b-0c37f877119f" providerId="AD" clId="Web-{5A53F68D-5D62-2F91-0C34-5AF0710613BB}" dt="2025-06-18T07:33:42.518" v="245" actId="20577"/>
+        <pc:sldMkLst>
+          <pc:docMk/>
+          <pc:sldMk cId="3589465999" sldId="514"/>
+        </pc:sldMkLst>
+        <pc:spChg chg="mod">
+          <ac:chgData name="Mohammed Fasha" userId="S::mohammed.fasha@uop.edu.jo::cc64f42d-a1a6-4f08-b97b-0c37f877119f" providerId="AD" clId="Web-{5A53F68D-5D62-2F91-0C34-5AF0710613BB}" dt="2025-06-18T07:32:02.797" v="218" actId="20577"/>
+          <ac:spMkLst>
+            <pc:docMk/>
+            <pc:sldMk cId="3589465999" sldId="514"/>
+            <ac:spMk id="2" creationId="{88A29053-B25D-8437-7DDD-113C9833833C}"/>
+          </ac:spMkLst>
+        </pc:spChg>
+        <pc:spChg chg="mod">
+          <ac:chgData name="Mohammed Fasha" userId="S::mohammed.fasha@uop.edu.jo::cc64f42d-a1a6-4f08-b97b-0c37f877119f" providerId="AD" clId="Web-{5A53F68D-5D62-2F91-0C34-5AF0710613BB}" dt="2025-06-18T07:33:42.518" v="245" actId="20577"/>
+          <ac:spMkLst>
+            <pc:docMk/>
+            <pc:sldMk cId="3589465999" sldId="514"/>
+            <ac:spMk id="3" creationId="{5B93E470-126F-0470-F370-550A166C8CE3}"/>
+          </ac:spMkLst>
+        </pc:spChg>
+      </pc:sldChg>
+      <pc:sldChg chg="modSp">
+        <pc:chgData name="Mohammed Fasha" userId="S::mohammed.fasha@uop.edu.jo::cc64f42d-a1a6-4f08-b97b-0c37f877119f" providerId="AD" clId="Web-{5A53F68D-5D62-2F91-0C34-5AF0710613BB}" dt="2025-06-18T07:32:07.031" v="219" actId="20577"/>
+        <pc:sldMkLst>
+          <pc:docMk/>
+          <pc:sldMk cId="2311531301" sldId="515"/>
+        </pc:sldMkLst>
+        <pc:spChg chg="mod">
+          <ac:chgData name="Mohammed Fasha" userId="S::mohammed.fasha@uop.edu.jo::cc64f42d-a1a6-4f08-b97b-0c37f877119f" providerId="AD" clId="Web-{5A53F68D-5D62-2F91-0C34-5AF0710613BB}" dt="2025-06-18T07:32:07.031" v="219" actId="20577"/>
+          <ac:spMkLst>
+            <pc:docMk/>
+            <pc:sldMk cId="2311531301" sldId="515"/>
+            <ac:spMk id="2" creationId="{DC04C7CB-A0FB-53BD-F5B2-69AE96A0E5A0}"/>
+          </ac:spMkLst>
+        </pc:spChg>
+      </pc:sldChg>
+      <pc:sldChg chg="modSp">
+        <pc:chgData name="Mohammed Fasha" userId="S::mohammed.fasha@uop.edu.jo::cc64f42d-a1a6-4f08-b97b-0c37f877119f" providerId="AD" clId="Web-{5A53F68D-5D62-2F91-0C34-5AF0710613BB}" dt="2025-06-18T07:34:15.676" v="252" actId="14100"/>
+        <pc:sldMkLst>
+          <pc:docMk/>
+          <pc:sldMk cId="1201106649" sldId="516"/>
+        </pc:sldMkLst>
+        <pc:spChg chg="mod">
+          <ac:chgData name="Mohammed Fasha" userId="S::mohammed.fasha@uop.edu.jo::cc64f42d-a1a6-4f08-b97b-0c37f877119f" providerId="AD" clId="Web-{5A53F68D-5D62-2F91-0C34-5AF0710613BB}" dt="2025-06-18T07:34:04.910" v="248" actId="20577"/>
+          <ac:spMkLst>
+            <pc:docMk/>
+            <pc:sldMk cId="1201106649" sldId="516"/>
+            <ac:spMk id="2" creationId="{0200F449-8EB2-4A35-0E5D-148ACC5A1F7D}"/>
+          </ac:spMkLst>
+        </pc:spChg>
+        <pc:spChg chg="mod">
+          <ac:chgData name="Mohammed Fasha" userId="S::mohammed.fasha@uop.edu.jo::cc64f42d-a1a6-4f08-b97b-0c37f877119f" providerId="AD" clId="Web-{5A53F68D-5D62-2F91-0C34-5AF0710613BB}" dt="2025-06-18T07:34:15.676" v="252" actId="14100"/>
+          <ac:spMkLst>
+            <pc:docMk/>
+            <pc:sldMk cId="1201106649" sldId="516"/>
+            <ac:spMk id="10" creationId="{CBD069FD-7B37-85AA-7C66-0FC15C990DD8}"/>
+          </ac:spMkLst>
+        </pc:spChg>
+      </pc:sldChg>
+      <pc:sldChg chg="modSp">
+        <pc:chgData name="Mohammed Fasha" userId="S::mohammed.fasha@uop.edu.jo::cc64f42d-a1a6-4f08-b97b-0c37f877119f" providerId="AD" clId="Web-{5A53F68D-5D62-2F91-0C34-5AF0710613BB}" dt="2025-06-18T07:31:30.389" v="215" actId="20577"/>
+        <pc:sldMkLst>
+          <pc:docMk/>
+          <pc:sldMk cId="834475357" sldId="517"/>
+        </pc:sldMkLst>
+        <pc:spChg chg="mod">
+          <ac:chgData name="Mohammed Fasha" userId="S::mohammed.fasha@uop.edu.jo::cc64f42d-a1a6-4f08-b97b-0c37f877119f" providerId="AD" clId="Web-{5A53F68D-5D62-2F91-0C34-5AF0710613BB}" dt="2025-06-18T07:28:32.493" v="127" actId="20577"/>
+          <ac:spMkLst>
+            <pc:docMk/>
+            <pc:sldMk cId="834475357" sldId="517"/>
+            <ac:spMk id="2" creationId="{748EBE3E-0A49-2947-0CEC-18B7160B878C}"/>
+          </ac:spMkLst>
+        </pc:spChg>
+        <pc:spChg chg="mod">
+          <ac:chgData name="Mohammed Fasha" userId="S::mohammed.fasha@uop.edu.jo::cc64f42d-a1a6-4f08-b97b-0c37f877119f" providerId="AD" clId="Web-{5A53F68D-5D62-2F91-0C34-5AF0710613BB}" dt="2025-06-18T07:31:30.389" v="215" actId="20577"/>
+          <ac:spMkLst>
+            <pc:docMk/>
+            <pc:sldMk cId="834475357" sldId="517"/>
+            <ac:spMk id="3" creationId="{ACE394C5-CDB7-FD4D-AA66-701E1D158182}"/>
+          </ac:spMkLst>
+        </pc:spChg>
+      </pc:sldChg>
+      <pc:sldChg chg="addSp delSp modSp new">
+        <pc:chgData name="Mohammed Fasha" userId="S::mohammed.fasha@uop.edu.jo::cc64f42d-a1a6-4f08-b97b-0c37f877119f" providerId="AD" clId="Web-{5A53F68D-5D62-2F91-0C34-5AF0710613BB}" dt="2025-06-18T07:30:05.621" v="168"/>
+        <pc:sldMkLst>
+          <pc:docMk/>
+          <pc:sldMk cId="2757035436" sldId="524"/>
+        </pc:sldMkLst>
+        <pc:spChg chg="mod">
+          <ac:chgData name="Mohammed Fasha" userId="S::mohammed.fasha@uop.edu.jo::cc64f42d-a1a6-4f08-b97b-0c37f877119f" providerId="AD" clId="Web-{5A53F68D-5D62-2F91-0C34-5AF0710613BB}" dt="2025-06-18T07:27:14.553" v="64" actId="20577"/>
+          <ac:spMkLst>
+            <pc:docMk/>
+            <pc:sldMk cId="2757035436" sldId="524"/>
+            <ac:spMk id="2" creationId="{1462616C-41EE-2B5B-760C-E900F7CFDE29}"/>
+          </ac:spMkLst>
+        </pc:spChg>
+        <pc:spChg chg="del">
+          <ac:chgData name="Mohammed Fasha" userId="S::mohammed.fasha@uop.edu.jo::cc64f42d-a1a6-4f08-b97b-0c37f877119f" providerId="AD" clId="Web-{5A53F68D-5D62-2F91-0C34-5AF0710613BB}" dt="2025-06-18T07:26:35.287" v="1"/>
+          <ac:spMkLst>
+            <pc:docMk/>
+            <pc:sldMk cId="2757035436" sldId="524"/>
+            <ac:spMk id="3" creationId="{0249785F-B0B6-B72E-2196-10705E6D2A17}"/>
+          </ac:spMkLst>
+        </pc:spChg>
+        <pc:graphicFrameChg chg="add mod ord modGraphic">
+          <ac:chgData name="Mohammed Fasha" userId="S::mohammed.fasha@uop.edu.jo::cc64f42d-a1a6-4f08-b97b-0c37f877119f" providerId="AD" clId="Web-{5A53F68D-5D62-2F91-0C34-5AF0710613BB}" dt="2025-06-18T07:30:05.621" v="168"/>
+          <ac:graphicFrameMkLst>
+            <pc:docMk/>
+            <pc:sldMk cId="2757035436" sldId="524"/>
+            <ac:graphicFrameMk id="5" creationId="{D986A135-B943-08AB-BF49-B8AFBFF1A02E}"/>
+          </ac:graphicFrameMkLst>
+        </pc:graphicFrameChg>
+      </pc:sldChg>
+    </pc:docChg>
+  </pc:docChgLst>
+  <pc:docChgLst>
+    <pc:chgData name="Mohammed Fasha" userId="cc64f42d-a1a6-4f08-b97b-0c37f877119f" providerId="ADAL" clId="{25C05559-E4DC-4EE1-91BC-1444D09EE869}"/>
+    <pc:docChg chg="undo custSel addSld delSld modSld sldOrd">
+      <pc:chgData name="Mohammed Fasha" userId="cc64f42d-a1a6-4f08-b97b-0c37f877119f" providerId="ADAL" clId="{25C05559-E4DC-4EE1-91BC-1444D09EE869}" dt="2025-04-30T07:51:18.812" v="264" actId="47"/>
+      <pc:docMkLst>
+        <pc:docMk/>
+      </pc:docMkLst>
+      <pc:sldChg chg="modSp mod">
+        <pc:chgData name="Mohammed Fasha" userId="cc64f42d-a1a6-4f08-b97b-0c37f877119f" providerId="ADAL" clId="{25C05559-E4DC-4EE1-91BC-1444D09EE869}" dt="2025-04-16T06:14:55.232" v="16" actId="1076"/>
+        <pc:sldMkLst>
+          <pc:docMk/>
+          <pc:sldMk cId="1499958888" sldId="394"/>
+        </pc:sldMkLst>
+      </pc:sldChg>
+      <pc:sldChg chg="delSp modSp mod delAnim">
+        <pc:chgData name="Mohammed Fasha" userId="cc64f42d-a1a6-4f08-b97b-0c37f877119f" providerId="ADAL" clId="{25C05559-E4DC-4EE1-91BC-1444D09EE869}" dt="2025-04-16T06:43:36.666" v="20" actId="478"/>
+        <pc:sldMkLst>
+          <pc:docMk/>
+          <pc:sldMk cId="2905491798" sldId="440"/>
+        </pc:sldMkLst>
+      </pc:sldChg>
+      <pc:sldChg chg="modSp mod">
+        <pc:chgData name="Mohammed Fasha" userId="cc64f42d-a1a6-4f08-b97b-0c37f877119f" providerId="ADAL" clId="{25C05559-E4DC-4EE1-91BC-1444D09EE869}" dt="2025-04-09T06:23:26.187" v="0" actId="20577"/>
+        <pc:sldMkLst>
+          <pc:docMk/>
+          <pc:sldMk cId="2297456757" sldId="483"/>
+        </pc:sldMkLst>
+        <pc:spChg chg="mod">
+          <ac:chgData name="Mohammed Fasha" userId="cc64f42d-a1a6-4f08-b97b-0c37f877119f" providerId="ADAL" clId="{25C05559-E4DC-4EE1-91BC-1444D09EE869}" dt="2025-04-09T06:23:26.187" v="0" actId="20577"/>
+          <ac:spMkLst>
+            <pc:docMk/>
+            <pc:sldMk cId="2297456757" sldId="483"/>
+            <ac:spMk id="5" creationId="{89403830-E271-DAA0-8838-E295A84A8B5B}"/>
+          </ac:spMkLst>
+        </pc:spChg>
+      </pc:sldChg>
+      <pc:sldChg chg="ord">
+        <pc:chgData name="Mohammed Fasha" userId="cc64f42d-a1a6-4f08-b97b-0c37f877119f" providerId="ADAL" clId="{25C05559-E4DC-4EE1-91BC-1444D09EE869}" dt="2025-04-16T06:46:21.733" v="23" actId="20578"/>
+        <pc:sldMkLst>
+          <pc:docMk/>
+          <pc:sldMk cId="3480194047" sldId="599"/>
+        </pc:sldMkLst>
+      </pc:sldChg>
+      <pc:sldChg chg="modSp mod">
+        <pc:chgData name="Mohammed Fasha" userId="cc64f42d-a1a6-4f08-b97b-0c37f877119f" providerId="ADAL" clId="{25C05559-E4DC-4EE1-91BC-1444D09EE869}" dt="2025-04-16T06:46:47.902" v="27" actId="404"/>
+        <pc:sldMkLst>
+          <pc:docMk/>
+          <pc:sldMk cId="3146452721" sldId="600"/>
+        </pc:sldMkLst>
+      </pc:sldChg>
+      <pc:sldChg chg="delSp mod">
+        <pc:chgData name="Mohammed Fasha" userId="cc64f42d-a1a6-4f08-b97b-0c37f877119f" providerId="ADAL" clId="{25C05559-E4DC-4EE1-91BC-1444D09EE869}" dt="2025-04-16T06:47:57.131" v="35" actId="21"/>
+        <pc:sldMkLst>
+          <pc:docMk/>
+          <pc:sldMk cId="202107314" sldId="647"/>
+        </pc:sldMkLst>
+      </pc:sldChg>
+      <pc:sldChg chg="modSp mod">
+        <pc:chgData name="Mohammed Fasha" userId="cc64f42d-a1a6-4f08-b97b-0c37f877119f" providerId="ADAL" clId="{25C05559-E4DC-4EE1-91BC-1444D09EE869}" dt="2025-04-16T06:48:42.467" v="40" actId="14100"/>
+        <pc:sldMkLst>
+          <pc:docMk/>
+          <pc:sldMk cId="3454522070" sldId="679"/>
+        </pc:sldMkLst>
+      </pc:sldChg>
+      <pc:sldChg chg="modSp mod">
+        <pc:chgData name="Mohammed Fasha" userId="cc64f42d-a1a6-4f08-b97b-0c37f877119f" providerId="ADAL" clId="{25C05559-E4DC-4EE1-91BC-1444D09EE869}" dt="2025-04-16T06:49:10.468" v="48" actId="404"/>
+        <pc:sldMkLst>
+          <pc:docMk/>
+          <pc:sldMk cId="2856814121" sldId="681"/>
+        </pc:sldMkLst>
+      </pc:sldChg>
+      <pc:sldChg chg="modSp mod">
+        <pc:chgData name="Mohammed Fasha" userId="cc64f42d-a1a6-4f08-b97b-0c37f877119f" providerId="ADAL" clId="{25C05559-E4DC-4EE1-91BC-1444D09EE869}" dt="2025-04-16T06:48:55.287" v="46" actId="27636"/>
+        <pc:sldMkLst>
+          <pc:docMk/>
+          <pc:sldMk cId="265576630" sldId="698"/>
+        </pc:sldMkLst>
+      </pc:sldChg>
+      <pc:sldChg chg="modSp">
+        <pc:chgData name="Mohammed Fasha" userId="cc64f42d-a1a6-4f08-b97b-0c37f877119f" providerId="ADAL" clId="{25C05559-E4DC-4EE1-91BC-1444D09EE869}" dt="2025-04-16T06:48:02.658" v="36" actId="1076"/>
+        <pc:sldMkLst>
+          <pc:docMk/>
+          <pc:sldMk cId="3085160177" sldId="704"/>
+        </pc:sldMkLst>
+      </pc:sldChg>
+      <pc:sldChg chg="modSp mod">
+        <pc:chgData name="Mohammed Fasha" userId="cc64f42d-a1a6-4f08-b97b-0c37f877119f" providerId="ADAL" clId="{25C05559-E4DC-4EE1-91BC-1444D09EE869}" dt="2025-04-16T06:47:18.630" v="34" actId="1076"/>
+        <pc:sldMkLst>
+          <pc:docMk/>
+          <pc:sldMk cId="32004852" sldId="708"/>
+        </pc:sldMkLst>
+      </pc:sldChg>
+      <pc:sldChg chg="addSp delSp modSp mod">
+        <pc:chgData name="Mohammed Fasha" userId="cc64f42d-a1a6-4f08-b97b-0c37f877119f" providerId="ADAL" clId="{25C05559-E4DC-4EE1-91BC-1444D09EE869}" dt="2025-04-16T06:14:10.424" v="11" actId="167"/>
+        <pc:sldMkLst>
+          <pc:docMk/>
+          <pc:sldMk cId="3150550060" sldId="720"/>
+        </pc:sldMkLst>
+      </pc:sldChg>
+      <pc:sldChg chg="addSp modSp new mod">
+        <pc:chgData name="Mohammed Fasha" userId="cc64f42d-a1a6-4f08-b97b-0c37f877119f" providerId="ADAL" clId="{25C05559-E4DC-4EE1-91BC-1444D09EE869}" dt="2025-04-30T06:40:50.224" v="212" actId="6549"/>
+        <pc:sldMkLst>
+          <pc:docMk/>
+          <pc:sldMk cId="666527140" sldId="725"/>
+        </pc:sldMkLst>
+      </pc:sldChg>
+      <pc:sldChg chg="addSp delSp modSp new mod">
+        <pc:chgData name="Mohammed Fasha" userId="cc64f42d-a1a6-4f08-b97b-0c37f877119f" providerId="ADAL" clId="{25C05559-E4DC-4EE1-91BC-1444D09EE869}" dt="2025-04-30T07:05:36.135" v="263" actId="122"/>
+        <pc:sldMkLst>
+          <pc:docMk/>
+          <pc:sldMk cId="3660604927" sldId="726"/>
+        </pc:sldMkLst>
+      </pc:sldChg>
+      <pc:sldChg chg="add del">
+        <pc:chgData name="Mohammed Fasha" userId="cc64f42d-a1a6-4f08-b97b-0c37f877119f" providerId="ADAL" clId="{25C05559-E4DC-4EE1-91BC-1444D09EE869}" dt="2025-04-30T07:51:18.812" v="264" actId="47"/>
+        <pc:sldMkLst>
+          <pc:docMk/>
+          <pc:sldMk cId="2399550384" sldId="727"/>
+        </pc:sldMkLst>
+      </pc:sldChg>
+      <pc:sldChg chg="modSp add mod ord">
+        <pc:chgData name="Mohammed Fasha" userId="cc64f42d-a1a6-4f08-b97b-0c37f877119f" providerId="ADAL" clId="{25C05559-E4DC-4EE1-91BC-1444D09EE869}" dt="2025-04-30T06:47:23.280" v="238" actId="20577"/>
+        <pc:sldMkLst>
+          <pc:docMk/>
+          <pc:sldMk cId="4051640529" sldId="728"/>
+        </pc:sldMkLst>
+      </pc:sldChg>
+    </pc:docChg>
+  </pc:docChgLst>
+  <pc:docChgLst>
+    <pc:chgData name="Mohammed Fasha" userId="cc64f42d-a1a6-4f08-b97b-0c37f877119f" providerId="ADAL" clId="{4C71ED24-115E-432D-933D-C801DA3E52F1}"/>
+    <pc:docChg chg="delSld">
+      <pc:chgData name="Mohammed Fasha" userId="cc64f42d-a1a6-4f08-b97b-0c37f877119f" providerId="ADAL" clId="{4C71ED24-115E-432D-933D-C801DA3E52F1}" dt="2024-12-29T03:12:49.974" v="2" actId="47"/>
+      <pc:docMkLst>
+        <pc:docMk/>
+      </pc:docMkLst>
+      <pc:sldChg chg="del">
+        <pc:chgData name="Mohammed Fasha" userId="cc64f42d-a1a6-4f08-b97b-0c37f877119f" providerId="ADAL" clId="{4C71ED24-115E-432D-933D-C801DA3E52F1}" dt="2024-12-29T03:12:48.360" v="0" actId="47"/>
+        <pc:sldMkLst>
+          <pc:docMk/>
+          <pc:sldMk cId="2341000601" sldId="701"/>
+        </pc:sldMkLst>
+      </pc:sldChg>
+      <pc:sldChg chg="del">
+        <pc:chgData name="Mohammed Fasha" userId="cc64f42d-a1a6-4f08-b97b-0c37f877119f" providerId="ADAL" clId="{4C71ED24-115E-432D-933D-C801DA3E52F1}" dt="2024-12-29T03:12:49.133" v="1" actId="47"/>
+        <pc:sldMkLst>
+          <pc:docMk/>
+          <pc:sldMk cId="3519698944" sldId="702"/>
+        </pc:sldMkLst>
+      </pc:sldChg>
+      <pc:sldChg chg="del">
+        <pc:chgData name="Mohammed Fasha" userId="cc64f42d-a1a6-4f08-b97b-0c37f877119f" providerId="ADAL" clId="{4C71ED24-115E-432D-933D-C801DA3E52F1}" dt="2024-12-29T03:12:49.974" v="2" actId="47"/>
+        <pc:sldMkLst>
+          <pc:docMk/>
+          <pc:sldMk cId="3934257344" sldId="703"/>
+        </pc:sldMkLst>
+      </pc:sldChg>
+    </pc:docChg>
+  </pc:docChgLst>
+  <pc:docChgLst>
+    <pc:chgData name="Mohammed Fasha" userId="cc64f42d-a1a6-4f08-b97b-0c37f877119f" providerId="ADAL" clId="{FEC9C214-E726-4192-8176-A8C9AACEB478}"/>
+    <pc:docChg chg="custSel addSld delSld modSld">
+      <pc:chgData name="Mohammed Fasha" userId="cc64f42d-a1a6-4f08-b97b-0c37f877119f" providerId="ADAL" clId="{FEC9C214-E726-4192-8176-A8C9AACEB478}" dt="2025-05-16T05:43:36.510" v="126" actId="2696"/>
+      <pc:docMkLst>
+        <pc:docMk/>
+      </pc:docMkLst>
+      <pc:sldChg chg="del">
+        <pc:chgData name="Mohammed Fasha" userId="cc64f42d-a1a6-4f08-b97b-0c37f877119f" providerId="ADAL" clId="{FEC9C214-E726-4192-8176-A8C9AACEB478}" dt="2025-05-16T05:43:36.510" v="126" actId="2696"/>
+        <pc:sldMkLst>
+          <pc:docMk/>
+          <pc:sldMk cId="607684796" sldId="333"/>
+        </pc:sldMkLst>
+      </pc:sldChg>
+      <pc:sldChg chg="del">
+        <pc:chgData name="Mohammed Fasha" userId="cc64f42d-a1a6-4f08-b97b-0c37f877119f" providerId="ADAL" clId="{FEC9C214-E726-4192-8176-A8C9AACEB478}" dt="2025-05-16T05:43:36.510" v="126" actId="2696"/>
+        <pc:sldMkLst>
+          <pc:docMk/>
+          <pc:sldMk cId="587789057" sldId="423"/>
+        </pc:sldMkLst>
+      </pc:sldChg>
+      <pc:sldChg chg="del">
+        <pc:chgData name="Mohammed Fasha" userId="cc64f42d-a1a6-4f08-b97b-0c37f877119f" providerId="ADAL" clId="{FEC9C214-E726-4192-8176-A8C9AACEB478}" dt="2025-05-16T05:43:36.510" v="126" actId="2696"/>
+        <pc:sldMkLst>
+          <pc:docMk/>
+          <pc:sldMk cId="2127906749" sldId="427"/>
+        </pc:sldMkLst>
+      </pc:sldChg>
+      <pc:sldChg chg="del">
+        <pc:chgData name="Mohammed Fasha" userId="cc64f42d-a1a6-4f08-b97b-0c37f877119f" providerId="ADAL" clId="{FEC9C214-E726-4192-8176-A8C9AACEB478}" dt="2025-05-16T05:43:36.510" v="126" actId="2696"/>
+        <pc:sldMkLst>
+          <pc:docMk/>
+          <pc:sldMk cId="391491219" sldId="428"/>
+        </pc:sldMkLst>
+      </pc:sldChg>
+      <pc:sldChg chg="del">
+        <pc:chgData name="Mohammed Fasha" userId="cc64f42d-a1a6-4f08-b97b-0c37f877119f" providerId="ADAL" clId="{FEC9C214-E726-4192-8176-A8C9AACEB478}" dt="2025-05-16T05:43:36.510" v="126" actId="2696"/>
+        <pc:sldMkLst>
+          <pc:docMk/>
+          <pc:sldMk cId="3339445507" sldId="430"/>
+        </pc:sldMkLst>
+      </pc:sldChg>
+      <pc:sldChg chg="del">
+        <pc:chgData name="Mohammed Fasha" userId="cc64f42d-a1a6-4f08-b97b-0c37f877119f" providerId="ADAL" clId="{FEC9C214-E726-4192-8176-A8C9AACEB478}" dt="2025-05-16T05:43:36.510" v="126" actId="2696"/>
+        <pc:sldMkLst>
+          <pc:docMk/>
+          <pc:sldMk cId="3389046835" sldId="431"/>
+        </pc:sldMkLst>
+      </pc:sldChg>
+      <pc:sldChg chg="modSp mod">
+        <pc:chgData name="Mohammed Fasha" userId="cc64f42d-a1a6-4f08-b97b-0c37f877119f" providerId="ADAL" clId="{FEC9C214-E726-4192-8176-A8C9AACEB478}" dt="2025-05-16T05:42:48.998" v="99" actId="6549"/>
+        <pc:sldMkLst>
+          <pc:docMk/>
+          <pc:sldMk cId="4208461039" sldId="447"/>
+        </pc:sldMkLst>
+      </pc:sldChg>
+      <pc:sldChg chg="modSp mod">
+        <pc:chgData name="Mohammed Fasha" userId="cc64f42d-a1a6-4f08-b97b-0c37f877119f" providerId="ADAL" clId="{FEC9C214-E726-4192-8176-A8C9AACEB478}" dt="2025-05-16T05:43:13.101" v="125" actId="6549"/>
+        <pc:sldMkLst>
+          <pc:docMk/>
+          <pc:sldMk cId="2297456757" sldId="483"/>
+        </pc:sldMkLst>
+        <pc:spChg chg="mod">
+          <ac:chgData name="Mohammed Fasha" userId="cc64f42d-a1a6-4f08-b97b-0c37f877119f" providerId="ADAL" clId="{FEC9C214-E726-4192-8176-A8C9AACEB478}" dt="2025-05-16T05:43:13.101" v="125" actId="6549"/>
+          <ac:spMkLst>
+            <pc:docMk/>
+            <pc:sldMk cId="2297456757" sldId="483"/>
+            <ac:spMk id="5" creationId="{89403830-E271-DAA0-8838-E295A84A8B5B}"/>
+          </ac:spMkLst>
+        </pc:spChg>
+      </pc:sldChg>
+      <pc:sldChg chg="del">
+        <pc:chgData name="Mohammed Fasha" userId="cc64f42d-a1a6-4f08-b97b-0c37f877119f" providerId="ADAL" clId="{FEC9C214-E726-4192-8176-A8C9AACEB478}" dt="2025-05-16T05:43:36.510" v="126" actId="2696"/>
+        <pc:sldMkLst>
+          <pc:docMk/>
+          <pc:sldMk cId="1586650541" sldId="510"/>
+        </pc:sldMkLst>
+      </pc:sldChg>
+      <pc:sldChg chg="del">
+        <pc:chgData name="Mohammed Fasha" userId="cc64f42d-a1a6-4f08-b97b-0c37f877119f" providerId="ADAL" clId="{FEC9C214-E726-4192-8176-A8C9AACEB478}" dt="2025-05-16T05:43:36.510" v="126" actId="2696"/>
+        <pc:sldMkLst>
+          <pc:docMk/>
+          <pc:sldMk cId="1271956779" sldId="514"/>
+        </pc:sldMkLst>
+      </pc:sldChg>
+      <pc:sldChg chg="del">
+        <pc:chgData name="Mohammed Fasha" userId="cc64f42d-a1a6-4f08-b97b-0c37f877119f" providerId="ADAL" clId="{FEC9C214-E726-4192-8176-A8C9AACEB478}" dt="2025-05-16T05:43:36.510" v="126" actId="2696"/>
+        <pc:sldMkLst>
+          <pc:docMk/>
+          <pc:sldMk cId="2281221656" sldId="527"/>
+        </pc:sldMkLst>
+      </pc:sldChg>
+      <pc:sldChg chg="del">
+        <pc:chgData name="Mohammed Fasha" userId="cc64f42d-a1a6-4f08-b97b-0c37f877119f" providerId="ADAL" clId="{FEC9C214-E726-4192-8176-A8C9AACEB478}" dt="2025-05-16T05:43:36.510" v="126" actId="2696"/>
+        <pc:sldMkLst>
+          <pc:docMk/>
+          <pc:sldMk cId="2877973779" sldId="607"/>
+        </pc:sldMkLst>
+      </pc:sldChg>
+      <pc:sldChg chg="del">
+        <pc:chgData name="Mohammed Fasha" userId="cc64f42d-a1a6-4f08-b97b-0c37f877119f" providerId="ADAL" clId="{FEC9C214-E726-4192-8176-A8C9AACEB478}" dt="2025-05-16T05:43:36.510" v="126" actId="2696"/>
+        <pc:sldMkLst>
+          <pc:docMk/>
+          <pc:sldMk cId="21481256" sldId="611"/>
+        </pc:sldMkLst>
+      </pc:sldChg>
+      <pc:sldChg chg="del">
+        <pc:chgData name="Mohammed Fasha" userId="cc64f42d-a1a6-4f08-b97b-0c37f877119f" providerId="ADAL" clId="{FEC9C214-E726-4192-8176-A8C9AACEB478}" dt="2025-05-16T05:43:36.510" v="126" actId="2696"/>
+        <pc:sldMkLst>
+          <pc:docMk/>
+          <pc:sldMk cId="4040874025" sldId="612"/>
+        </pc:sldMkLst>
+      </pc:sldChg>
+      <pc:sldChg chg="del">
+        <pc:chgData name="Mohammed Fasha" userId="cc64f42d-a1a6-4f08-b97b-0c37f877119f" providerId="ADAL" clId="{FEC9C214-E726-4192-8176-A8C9AACEB478}" dt="2025-05-16T05:43:36.510" v="126" actId="2696"/>
+        <pc:sldMkLst>
+          <pc:docMk/>
+          <pc:sldMk cId="399592497" sldId="613"/>
+        </pc:sldMkLst>
+      </pc:sldChg>
+      <pc:sldChg chg="del">
+        <pc:chgData name="Mohammed Fasha" userId="cc64f42d-a1a6-4f08-b97b-0c37f877119f" providerId="ADAL" clId="{FEC9C214-E726-4192-8176-A8C9AACEB478}" dt="2025-05-16T05:43:36.510" v="126" actId="2696"/>
+        <pc:sldMkLst>
+          <pc:docMk/>
+          <pc:sldMk cId="3535314737" sldId="614"/>
+        </pc:sldMkLst>
+      </pc:sldChg>
+      <pc:sldChg chg="del">
+        <pc:chgData name="Mohammed Fasha" userId="cc64f42d-a1a6-4f08-b97b-0c37f877119f" providerId="ADAL" clId="{FEC9C214-E726-4192-8176-A8C9AACEB478}" dt="2025-05-16T05:43:36.510" v="126" actId="2696"/>
+        <pc:sldMkLst>
+          <pc:docMk/>
+          <pc:sldMk cId="627652750" sldId="615"/>
+        </pc:sldMkLst>
+      </pc:sldChg>
+      <pc:sldChg chg="del">
+        <pc:chgData name="Mohammed Fasha" userId="cc64f42d-a1a6-4f08-b97b-0c37f877119f" providerId="ADAL" clId="{FEC9C214-E726-4192-8176-A8C9AACEB478}" dt="2025-05-16T05:43:36.510" v="126" actId="2696"/>
+        <pc:sldMkLst>
+          <pc:docMk/>
+          <pc:sldMk cId="423212581" sldId="616"/>
+        </pc:sldMkLst>
+      </pc:sldChg>
+      <pc:sldChg chg="del">
+        <pc:chgData name="Mohammed Fasha" userId="cc64f42d-a1a6-4f08-b97b-0c37f877119f" providerId="ADAL" clId="{FEC9C214-E726-4192-8176-A8C9AACEB478}" dt="2025-05-16T05:43:36.510" v="126" actId="2696"/>
+        <pc:sldMkLst>
+          <pc:docMk/>
+          <pc:sldMk cId="3329135496" sldId="617"/>
+        </pc:sldMkLst>
+      </pc:sldChg>
+      <pc:sldChg chg="del">
+        <pc:chgData name="Mohammed Fasha" userId="cc64f42d-a1a6-4f08-b97b-0c37f877119f" providerId="ADAL" clId="{FEC9C214-E726-4192-8176-A8C9AACEB478}" dt="2025-05-16T05:43:36.510" v="126" actId="2696"/>
+        <pc:sldMkLst>
+          <pc:docMk/>
+          <pc:sldMk cId="1380276415" sldId="618"/>
+        </pc:sldMkLst>
+      </pc:sldChg>
+      <pc:sldChg chg="del">
+        <pc:chgData name="Mohammed Fasha" userId="cc64f42d-a1a6-4f08-b97b-0c37f877119f" providerId="ADAL" clId="{FEC9C214-E726-4192-8176-A8C9AACEB478}" dt="2025-05-16T05:43:36.510" v="126" actId="2696"/>
+        <pc:sldMkLst>
+          <pc:docMk/>
+          <pc:sldMk cId="246730148" sldId="619"/>
+        </pc:sldMkLst>
+      </pc:sldChg>
+      <pc:sldChg chg="del">
+        <pc:chgData name="Mohammed Fasha" userId="cc64f42d-a1a6-4f08-b97b-0c37f877119f" providerId="ADAL" clId="{FEC9C214-E726-4192-8176-A8C9AACEB478}" dt="2025-05-16T05:43:36.510" v="126" actId="2696"/>
+        <pc:sldMkLst>
+          <pc:docMk/>
+          <pc:sldMk cId="839834530" sldId="621"/>
+        </pc:sldMkLst>
+      </pc:sldChg>
+      <pc:sldChg chg="del">
+        <pc:chgData name="Mohammed Fasha" userId="cc64f42d-a1a6-4f08-b97b-0c37f877119f" providerId="ADAL" clId="{FEC9C214-E726-4192-8176-A8C9AACEB478}" dt="2025-05-16T05:43:36.510" v="126" actId="2696"/>
+        <pc:sldMkLst>
+          <pc:docMk/>
+          <pc:sldMk cId="3734309461" sldId="625"/>
+        </pc:sldMkLst>
+      </pc:sldChg>
+      <pc:sldChg chg="del">
+        <pc:chgData name="Mohammed Fasha" userId="cc64f42d-a1a6-4f08-b97b-0c37f877119f" providerId="ADAL" clId="{FEC9C214-E726-4192-8176-A8C9AACEB478}" dt="2025-05-16T05:43:36.510" v="126" actId="2696"/>
+        <pc:sldMkLst>
+          <pc:docMk/>
+          <pc:sldMk cId="4269580935" sldId="634"/>
+        </pc:sldMkLst>
+      </pc:sldChg>
+      <pc:sldChg chg="del">
+        <pc:chgData name="Mohammed Fasha" userId="cc64f42d-a1a6-4f08-b97b-0c37f877119f" providerId="ADAL" clId="{FEC9C214-E726-4192-8176-A8C9AACEB478}" dt="2025-05-16T05:43:36.510" v="126" actId="2696"/>
+        <pc:sldMkLst>
+          <pc:docMk/>
+          <pc:sldMk cId="2838240985" sldId="635"/>
+        </pc:sldMkLst>
+      </pc:sldChg>
+      <pc:sldChg chg="del">
+        <pc:chgData name="Mohammed Fasha" userId="cc64f42d-a1a6-4f08-b97b-0c37f877119f" providerId="ADAL" clId="{FEC9C214-E726-4192-8176-A8C9AACEB478}" dt="2025-05-16T05:43:36.510" v="126" actId="2696"/>
+        <pc:sldMkLst>
+          <pc:docMk/>
+          <pc:sldMk cId="1675291572" sldId="638"/>
+        </pc:sldMkLst>
+      </pc:sldChg>
+      <pc:sldChg chg="modSp del">
+        <pc:chgData name="Mohammed Fasha" userId="cc64f42d-a1a6-4f08-b97b-0c37f877119f" providerId="ADAL" clId="{FEC9C214-E726-4192-8176-A8C9AACEB478}" dt="2025-05-16T05:43:36.510" v="126" actId="2696"/>
+        <pc:sldMkLst>
+          <pc:docMk/>
+          <pc:sldMk cId="2145145303" sldId="640"/>
+        </pc:sldMkLst>
+      </pc:sldChg>
+      <pc:sldChg chg="del">
+        <pc:chgData name="Mohammed Fasha" userId="cc64f42d-a1a6-4f08-b97b-0c37f877119f" providerId="ADAL" clId="{FEC9C214-E726-4192-8176-A8C9AACEB478}" dt="2025-05-16T05:43:36.510" v="126" actId="2696"/>
+        <pc:sldMkLst>
+          <pc:docMk/>
+          <pc:sldMk cId="1135291414" sldId="643"/>
+        </pc:sldMkLst>
+      </pc:sldChg>
+      <pc:sldChg chg="del">
+        <pc:chgData name="Mohammed Fasha" userId="cc64f42d-a1a6-4f08-b97b-0c37f877119f" providerId="ADAL" clId="{FEC9C214-E726-4192-8176-A8C9AACEB478}" dt="2025-05-16T05:43:36.510" v="126" actId="2696"/>
+        <pc:sldMkLst>
+          <pc:docMk/>
+          <pc:sldMk cId="1030124935" sldId="644"/>
+        </pc:sldMkLst>
+      </pc:sldChg>
+      <pc:sldChg chg="del">
+        <pc:chgData name="Mohammed Fasha" userId="cc64f42d-a1a6-4f08-b97b-0c37f877119f" providerId="ADAL" clId="{FEC9C214-E726-4192-8176-A8C9AACEB478}" dt="2025-05-16T05:43:36.510" v="126" actId="2696"/>
+        <pc:sldMkLst>
+          <pc:docMk/>
+          <pc:sldMk cId="2168644593" sldId="645"/>
+        </pc:sldMkLst>
+      </pc:sldChg>
+      <pc:sldChg chg="del">
+        <pc:chgData name="Mohammed Fasha" userId="cc64f42d-a1a6-4f08-b97b-0c37f877119f" providerId="ADAL" clId="{FEC9C214-E726-4192-8176-A8C9AACEB478}" dt="2025-05-16T05:43:36.510" v="126" actId="2696"/>
+        <pc:sldMkLst>
+          <pc:docMk/>
+          <pc:sldMk cId="2743226386" sldId="646"/>
+        </pc:sldMkLst>
+      </pc:sldChg>
+      <pc:sldChg chg="del">
+        <pc:chgData name="Mohammed Fasha" userId="cc64f42d-a1a6-4f08-b97b-0c37f877119f" providerId="ADAL" clId="{FEC9C214-E726-4192-8176-A8C9AACEB478}" dt="2025-05-16T05:43:36.510" v="126" actId="2696"/>
+        <pc:sldMkLst>
+          <pc:docMk/>
+          <pc:sldMk cId="202107314" sldId="647"/>
+        </pc:sldMkLst>
+      </pc:sldChg>
+      <pc:sldChg chg="del">
+        <pc:chgData name="Mohammed Fasha" userId="cc64f42d-a1a6-4f08-b97b-0c37f877119f" providerId="ADAL" clId="{FEC9C214-E726-4192-8176-A8C9AACEB478}" dt="2025-05-16T05:43:36.510" v="126" actId="2696"/>
+        <pc:sldMkLst>
+          <pc:docMk/>
+          <pc:sldMk cId="662689605" sldId="649"/>
+        </pc:sldMkLst>
+      </pc:sldChg>
+      <pc:sldChg chg="del">
+        <pc:chgData name="Mohammed Fasha" userId="cc64f42d-a1a6-4f08-b97b-0c37f877119f" providerId="ADAL" clId="{FEC9C214-E726-4192-8176-A8C9AACEB478}" dt="2025-05-16T05:43:36.510" v="126" actId="2696"/>
+        <pc:sldMkLst>
+          <pc:docMk/>
+          <pc:sldMk cId="3942060319" sldId="650"/>
+        </pc:sldMkLst>
+      </pc:sldChg>
+      <pc:sldChg chg="del">
+        <pc:chgData name="Mohammed Fasha" userId="cc64f42d-a1a6-4f08-b97b-0c37f877119f" providerId="ADAL" clId="{FEC9C214-E726-4192-8176-A8C9AACEB478}" dt="2025-05-16T05:43:36.510" v="126" actId="2696"/>
+        <pc:sldMkLst>
+          <pc:docMk/>
+          <pc:sldMk cId="916802035" sldId="651"/>
+        </pc:sldMkLst>
+      </pc:sldChg>
+      <pc:sldChg chg="del">
+        <pc:chgData name="Mohammed Fasha" userId="cc64f42d-a1a6-4f08-b97b-0c37f877119f" providerId="ADAL" clId="{FEC9C214-E726-4192-8176-A8C9AACEB478}" dt="2025-05-16T05:43:36.510" v="126" actId="2696"/>
+        <pc:sldMkLst>
+          <pc:docMk/>
+          <pc:sldMk cId="3061130053" sldId="653"/>
+        </pc:sldMkLst>
+      </pc:sldChg>
+      <pc:sldChg chg="del">
+        <pc:chgData name="Mohammed Fasha" userId="cc64f42d-a1a6-4f08-b97b-0c37f877119f" providerId="ADAL" clId="{FEC9C214-E726-4192-8176-A8C9AACEB478}" dt="2025-05-16T05:43:36.510" v="126" actId="2696"/>
+        <pc:sldMkLst>
+          <pc:docMk/>
+          <pc:sldMk cId="3585687456" sldId="654"/>
+        </pc:sldMkLst>
+      </pc:sldChg>
+      <pc:sldChg chg="del">
+        <pc:chgData name="Mohammed Fasha" userId="cc64f42d-a1a6-4f08-b97b-0c37f877119f" providerId="ADAL" clId="{FEC9C214-E726-4192-8176-A8C9AACEB478}" dt="2025-05-16T05:43:36.510" v="126" actId="2696"/>
+        <pc:sldMkLst>
+          <pc:docMk/>
+          <pc:sldMk cId="2892622100" sldId="655"/>
+        </pc:sldMkLst>
+      </pc:sldChg>
+      <pc:sldChg chg="modSp del mod">
+        <pc:chgData name="Mohammed Fasha" userId="cc64f42d-a1a6-4f08-b97b-0c37f877119f" providerId="ADAL" clId="{FEC9C214-E726-4192-8176-A8C9AACEB478}" dt="2025-05-16T05:43:36.510" v="126" actId="2696"/>
+        <pc:sldMkLst>
+          <pc:docMk/>
+          <pc:sldMk cId="555764928" sldId="657"/>
+        </pc:sldMkLst>
+      </pc:sldChg>
+      <pc:sldChg chg="del">
+        <pc:chgData name="Mohammed Fasha" userId="cc64f42d-a1a6-4f08-b97b-0c37f877119f" providerId="ADAL" clId="{FEC9C214-E726-4192-8176-A8C9AACEB478}" dt="2025-05-16T05:43:36.510" v="126" actId="2696"/>
+        <pc:sldMkLst>
+          <pc:docMk/>
+          <pc:sldMk cId="1461426122" sldId="658"/>
+        </pc:sldMkLst>
+      </pc:sldChg>
+      <pc:sldChg chg="del">
+        <pc:chgData name="Mohammed Fasha" userId="cc64f42d-a1a6-4f08-b97b-0c37f877119f" providerId="ADAL" clId="{FEC9C214-E726-4192-8176-A8C9AACEB478}" dt="2025-05-16T05:43:36.510" v="126" actId="2696"/>
+        <pc:sldMkLst>
+          <pc:docMk/>
+          <pc:sldMk cId="2990045589" sldId="659"/>
+        </pc:sldMkLst>
+      </pc:sldChg>
+      <pc:sldChg chg="del">
+        <pc:chgData name="Mohammed Fasha" userId="cc64f42d-a1a6-4f08-b97b-0c37f877119f" providerId="ADAL" clId="{FEC9C214-E726-4192-8176-A8C9AACEB478}" dt="2025-05-16T05:43:36.510" v="126" actId="2696"/>
+        <pc:sldMkLst>
+          <pc:docMk/>
+          <pc:sldMk cId="2575039538" sldId="660"/>
+        </pc:sldMkLst>
+      </pc:sldChg>
+      <pc:sldChg chg="del">
+        <pc:chgData name="Mohammed Fasha" userId="cc64f42d-a1a6-4f08-b97b-0c37f877119f" providerId="ADAL" clId="{FEC9C214-E726-4192-8176-A8C9AACEB478}" dt="2025-05-16T05:43:36.510" v="126" actId="2696"/>
+        <pc:sldMkLst>
+          <pc:docMk/>
+          <pc:sldMk cId="1554491934" sldId="661"/>
+        </pc:sldMkLst>
+      </pc:sldChg>
+      <pc:sldChg chg="del">
+        <pc:chgData name="Mohammed Fasha" userId="cc64f42d-a1a6-4f08-b97b-0c37f877119f" providerId="ADAL" clId="{FEC9C214-E726-4192-8176-A8C9AACEB478}" dt="2025-05-16T05:43:36.510" v="126" actId="2696"/>
+        <pc:sldMkLst>
+          <pc:docMk/>
+          <pc:sldMk cId="691538069" sldId="662"/>
+        </pc:sldMkLst>
+      </pc:sldChg>
+      <pc:sldChg chg="del">
+        <pc:chgData name="Mohammed Fasha" userId="cc64f42d-a1a6-4f08-b97b-0c37f877119f" providerId="ADAL" clId="{FEC9C214-E726-4192-8176-A8C9AACEB478}" dt="2025-05-16T05:43:36.510" v="126" actId="2696"/>
+        <pc:sldMkLst>
+          <pc:docMk/>
+          <pc:sldMk cId="3980180774" sldId="663"/>
+        </pc:sldMkLst>
+      </pc:sldChg>
+      <pc:sldChg chg="del">
+        <pc:chgData name="Mohammed Fasha" userId="cc64f42d-a1a6-4f08-b97b-0c37f877119f" providerId="ADAL" clId="{FEC9C214-E726-4192-8176-A8C9AACEB478}" dt="2025-05-16T05:43:36.510" v="126" actId="2696"/>
+        <pc:sldMkLst>
+          <pc:docMk/>
+          <pc:sldMk cId="1728680596" sldId="664"/>
+        </pc:sldMkLst>
+      </pc:sldChg>
+      <pc:sldChg chg="del">
+        <pc:chgData name="Mohammed Fasha" userId="cc64f42d-a1a6-4f08-b97b-0c37f877119f" providerId="ADAL" clId="{FEC9C214-E726-4192-8176-A8C9AACEB478}" dt="2025-05-16T05:43:36.510" v="126" actId="2696"/>
+        <pc:sldMkLst>
+          <pc:docMk/>
+          <pc:sldMk cId="148099094" sldId="665"/>
+        </pc:sldMkLst>
+      </pc:sldChg>
+      <pc:sldChg chg="del">
+        <pc:chgData name="Mohammed Fasha" userId="cc64f42d-a1a6-4f08-b97b-0c37f877119f" providerId="ADAL" clId="{FEC9C214-E726-4192-8176-A8C9AACEB478}" dt="2025-05-16T05:43:36.510" v="126" actId="2696"/>
+        <pc:sldMkLst>
+          <pc:docMk/>
+          <pc:sldMk cId="898885298" sldId="667"/>
+        </pc:sldMkLst>
+      </pc:sldChg>
+      <pc:sldChg chg="del">
+        <pc:chgData name="Mohammed Fasha" userId="cc64f42d-a1a6-4f08-b97b-0c37f877119f" providerId="ADAL" clId="{FEC9C214-E726-4192-8176-A8C9AACEB478}" dt="2025-05-16T05:43:36.510" v="126" actId="2696"/>
+        <pc:sldMkLst>
+          <pc:docMk/>
+          <pc:sldMk cId="2652660250" sldId="668"/>
+        </pc:sldMkLst>
+      </pc:sldChg>
+      <pc:sldChg chg="del">
+        <pc:chgData name="Mohammed Fasha" userId="cc64f42d-a1a6-4f08-b97b-0c37f877119f" providerId="ADAL" clId="{FEC9C214-E726-4192-8176-A8C9AACEB478}" dt="2025-05-16T05:43:36.510" v="126" actId="2696"/>
+        <pc:sldMkLst>
+          <pc:docMk/>
+          <pc:sldMk cId="2680231355" sldId="669"/>
+        </pc:sldMkLst>
+      </pc:sldChg>
+      <pc:sldChg chg="modSp del mod">
+        <pc:chgData name="Mohammed Fasha" userId="cc64f42d-a1a6-4f08-b97b-0c37f877119f" providerId="ADAL" clId="{FEC9C214-E726-4192-8176-A8C9AACEB478}" dt="2025-05-16T05:43:36.510" v="126" actId="2696"/>
+        <pc:sldMkLst>
+          <pc:docMk/>
+          <pc:sldMk cId="1960150938" sldId="670"/>
+        </pc:sldMkLst>
+      </pc:sldChg>
+      <pc:sldChg chg="del">
+        <pc:chgData name="Mohammed Fasha" userId="cc64f42d-a1a6-4f08-b97b-0c37f877119f" providerId="ADAL" clId="{FEC9C214-E726-4192-8176-A8C9AACEB478}" dt="2025-05-16T05:43:36.510" v="126" actId="2696"/>
+        <pc:sldMkLst>
+          <pc:docMk/>
+          <pc:sldMk cId="3605011436" sldId="671"/>
+        </pc:sldMkLst>
+      </pc:sldChg>
+      <pc:sldChg chg="del">
+        <pc:chgData name="Mohammed Fasha" userId="cc64f42d-a1a6-4f08-b97b-0c37f877119f" providerId="ADAL" clId="{FEC9C214-E726-4192-8176-A8C9AACEB478}" dt="2025-05-16T05:43:36.510" v="126" actId="2696"/>
+        <pc:sldMkLst>
+          <pc:docMk/>
+          <pc:sldMk cId="1620993364" sldId="672"/>
+        </pc:sldMkLst>
+      </pc:sldChg>
+      <pc:sldChg chg="del">
+        <pc:chgData name="Mohammed Fasha" userId="cc64f42d-a1a6-4f08-b97b-0c37f877119f" providerId="ADAL" clId="{FEC9C214-E726-4192-8176-A8C9AACEB478}" dt="2025-05-16T05:43:36.510" v="126" actId="2696"/>
+        <pc:sldMkLst>
+          <pc:docMk/>
+          <pc:sldMk cId="2865119215" sldId="674"/>
+        </pc:sldMkLst>
+      </pc:sldChg>
+      <pc:sldChg chg="del">
+        <pc:chgData name="Mohammed Fasha" userId="cc64f42d-a1a6-4f08-b97b-0c37f877119f" providerId="ADAL" clId="{FEC9C214-E726-4192-8176-A8C9AACEB478}" dt="2025-05-16T05:43:36.510" v="126" actId="2696"/>
+        <pc:sldMkLst>
+          <pc:docMk/>
+          <pc:sldMk cId="2170303756" sldId="675"/>
+        </pc:sldMkLst>
+      </pc:sldChg>
+      <pc:sldChg chg="del">
+        <pc:chgData name="Mohammed Fasha" userId="cc64f42d-a1a6-4f08-b97b-0c37f877119f" providerId="ADAL" clId="{FEC9C214-E726-4192-8176-A8C9AACEB478}" dt="2025-05-16T05:43:36.510" v="126" actId="2696"/>
+        <pc:sldMkLst>
+          <pc:docMk/>
+          <pc:sldMk cId="1577854815" sldId="676"/>
+        </pc:sldMkLst>
+      </pc:sldChg>
+      <pc:sldChg chg="del">
+        <pc:chgData name="Mohammed Fasha" userId="cc64f42d-a1a6-4f08-b97b-0c37f877119f" providerId="ADAL" clId="{FEC9C214-E726-4192-8176-A8C9AACEB478}" dt="2025-05-16T05:43:36.510" v="126" actId="2696"/>
+        <pc:sldMkLst>
+          <pc:docMk/>
+          <pc:sldMk cId="139882925" sldId="677"/>
+        </pc:sldMkLst>
+      </pc:sldChg>
+      <pc:sldChg chg="del">
+        <pc:chgData name="Mohammed Fasha" userId="cc64f42d-a1a6-4f08-b97b-0c37f877119f" providerId="ADAL" clId="{FEC9C214-E726-4192-8176-A8C9AACEB478}" dt="2025-05-16T05:43:36.510" v="126" actId="2696"/>
+        <pc:sldMkLst>
+          <pc:docMk/>
+          <pc:sldMk cId="4146654093" sldId="678"/>
+        </pc:sldMkLst>
+      </pc:sldChg>
+      <pc:sldChg chg="del">
+        <pc:chgData name="Mohammed Fasha" userId="cc64f42d-a1a6-4f08-b97b-0c37f877119f" providerId="ADAL" clId="{FEC9C214-E726-4192-8176-A8C9AACEB478}" dt="2025-05-16T05:43:36.510" v="126" actId="2696"/>
+        <pc:sldMkLst>
+          <pc:docMk/>
+          <pc:sldMk cId="3454522070" sldId="679"/>
+        </pc:sldMkLst>
+      </pc:sldChg>
+      <pc:sldChg chg="del">
+        <pc:chgData name="Mohammed Fasha" userId="cc64f42d-a1a6-4f08-b97b-0c37f877119f" providerId="ADAL" clId="{FEC9C214-E726-4192-8176-A8C9AACEB478}" dt="2025-05-16T05:43:36.510" v="126" actId="2696"/>
+        <pc:sldMkLst>
+          <pc:docMk/>
+          <pc:sldMk cId="2856814121" sldId="681"/>
+        </pc:sldMkLst>
+      </pc:sldChg>
+      <pc:sldChg chg="del">
+        <pc:chgData name="Mohammed Fasha" userId="cc64f42d-a1a6-4f08-b97b-0c37f877119f" providerId="ADAL" clId="{FEC9C214-E726-4192-8176-A8C9AACEB478}" dt="2025-05-16T05:43:36.510" v="126" actId="2696"/>
+        <pc:sldMkLst>
+          <pc:docMk/>
+          <pc:sldMk cId="1377124484" sldId="682"/>
+        </pc:sldMkLst>
+      </pc:sldChg>
+      <pc:sldChg chg="del">
+        <pc:chgData name="Mohammed Fasha" userId="cc64f42d-a1a6-4f08-b97b-0c37f877119f" providerId="ADAL" clId="{FEC9C214-E726-4192-8176-A8C9AACEB478}" dt="2025-05-16T05:43:36.510" v="126" actId="2696"/>
+        <pc:sldMkLst>
+          <pc:docMk/>
+          <pc:sldMk cId="2630096202" sldId="683"/>
+        </pc:sldMkLst>
+      </pc:sldChg>
+      <pc:sldChg chg="del">
+        <pc:chgData name="Mohammed Fasha" userId="cc64f42d-a1a6-4f08-b97b-0c37f877119f" providerId="ADAL" clId="{FEC9C214-E726-4192-8176-A8C9AACEB478}" dt="2025-05-16T05:43:36.510" v="126" actId="2696"/>
+        <pc:sldMkLst>
+          <pc:docMk/>
+          <pc:sldMk cId="3328652623" sldId="684"/>
+        </pc:sldMkLst>
+      </pc:sldChg>
+      <pc:sldChg chg="del">
+        <pc:chgData name="Mohammed Fasha" userId="cc64f42d-a1a6-4f08-b97b-0c37f877119f" providerId="ADAL" clId="{FEC9C214-E726-4192-8176-A8C9AACEB478}" dt="2025-05-16T05:43:36.510" v="126" actId="2696"/>
+        <pc:sldMkLst>
+          <pc:docMk/>
+          <pc:sldMk cId="916102856" sldId="685"/>
+        </pc:sldMkLst>
+      </pc:sldChg>
+      <pc:sldChg chg="del">
+        <pc:chgData name="Mohammed Fasha" userId="cc64f42d-a1a6-4f08-b97b-0c37f877119f" providerId="ADAL" clId="{FEC9C214-E726-4192-8176-A8C9AACEB478}" dt="2025-05-16T05:43:36.510" v="126" actId="2696"/>
+        <pc:sldMkLst>
+          <pc:docMk/>
+          <pc:sldMk cId="2620697854" sldId="686"/>
+        </pc:sldMkLst>
+      </pc:sldChg>
+      <pc:sldChg chg="del">
+        <pc:chgData name="Mohammed Fasha" userId="cc64f42d-a1a6-4f08-b97b-0c37f877119f" providerId="ADAL" clId="{FEC9C214-E726-4192-8176-A8C9AACEB478}" dt="2025-05-16T05:43:36.510" v="126" actId="2696"/>
+        <pc:sldMkLst>
+          <pc:docMk/>
+          <pc:sldMk cId="140683555" sldId="687"/>
+        </pc:sldMkLst>
+      </pc:sldChg>
+      <pc:sldChg chg="del">
+        <pc:chgData name="Mohammed Fasha" userId="cc64f42d-a1a6-4f08-b97b-0c37f877119f" providerId="ADAL" clId="{FEC9C214-E726-4192-8176-A8C9AACEB478}" dt="2025-05-16T05:43:36.510" v="126" actId="2696"/>
+        <pc:sldMkLst>
+          <pc:docMk/>
+          <pc:sldMk cId="1788308240" sldId="688"/>
+        </pc:sldMkLst>
+      </pc:sldChg>
+      <pc:sldChg chg="del">
+        <pc:chgData name="Mohammed Fasha" userId="cc64f42d-a1a6-4f08-b97b-0c37f877119f" providerId="ADAL" clId="{FEC9C214-E726-4192-8176-A8C9AACEB478}" dt="2025-05-16T05:43:36.510" v="126" actId="2696"/>
+        <pc:sldMkLst>
+          <pc:docMk/>
+          <pc:sldMk cId="1660737293" sldId="689"/>
+        </pc:sldMkLst>
+      </pc:sldChg>
+      <pc:sldChg chg="del">
+        <pc:chgData name="Mohammed Fasha" userId="cc64f42d-a1a6-4f08-b97b-0c37f877119f" providerId="ADAL" clId="{FEC9C214-E726-4192-8176-A8C9AACEB478}" dt="2025-05-16T05:43:36.510" v="126" actId="2696"/>
+        <pc:sldMkLst>
+          <pc:docMk/>
+          <pc:sldMk cId="1987101698" sldId="690"/>
+        </pc:sldMkLst>
+      </pc:sldChg>
+      <pc:sldChg chg="del">
+        <pc:chgData name="Mohammed Fasha" userId="cc64f42d-a1a6-4f08-b97b-0c37f877119f" providerId="ADAL" clId="{FEC9C214-E726-4192-8176-A8C9AACEB478}" dt="2025-05-16T05:43:36.510" v="126" actId="2696"/>
+        <pc:sldMkLst>
+          <pc:docMk/>
+          <pc:sldMk cId="1982708772" sldId="692"/>
+        </pc:sldMkLst>
+      </pc:sldChg>
+      <pc:sldChg chg="del">
+        <pc:chgData name="Mohammed Fasha" userId="cc64f42d-a1a6-4f08-b97b-0c37f877119f" providerId="ADAL" clId="{FEC9C214-E726-4192-8176-A8C9AACEB478}" dt="2025-05-16T05:43:36.510" v="126" actId="2696"/>
+        <pc:sldMkLst>
+          <pc:docMk/>
+          <pc:sldMk cId="3424197979" sldId="694"/>
+        </pc:sldMkLst>
+      </pc:sldChg>
+      <pc:sldChg chg="del">
+        <pc:chgData name="Mohammed Fasha" userId="cc64f42d-a1a6-4f08-b97b-0c37f877119f" providerId="ADAL" clId="{FEC9C214-E726-4192-8176-A8C9AACEB478}" dt="2025-05-16T05:43:36.510" v="126" actId="2696"/>
+        <pc:sldMkLst>
+          <pc:docMk/>
+          <pc:sldMk cId="1697141369" sldId="695"/>
+        </pc:sldMkLst>
+      </pc:sldChg>
+      <pc:sldChg chg="del">
+        <pc:chgData name="Mohammed Fasha" userId="cc64f42d-a1a6-4f08-b97b-0c37f877119f" providerId="ADAL" clId="{FEC9C214-E726-4192-8176-A8C9AACEB478}" dt="2025-05-16T05:43:36.510" v="126" actId="2696"/>
+        <pc:sldMkLst>
+          <pc:docMk/>
+          <pc:sldMk cId="1317643237" sldId="696"/>
+        </pc:sldMkLst>
+      </pc:sldChg>
+      <pc:sldChg chg="del">
+        <pc:chgData name="Mohammed Fasha" userId="cc64f42d-a1a6-4f08-b97b-0c37f877119f" providerId="ADAL" clId="{FEC9C214-E726-4192-8176-A8C9AACEB478}" dt="2025-05-16T05:43:36.510" v="126" actId="2696"/>
+        <pc:sldMkLst>
+          <pc:docMk/>
+          <pc:sldMk cId="265576630" sldId="698"/>
+        </pc:sldMkLst>
+      </pc:sldChg>
+      <pc:sldChg chg="del">
+        <pc:chgData name="Mohammed Fasha" userId="cc64f42d-a1a6-4f08-b97b-0c37f877119f" providerId="ADAL" clId="{FEC9C214-E726-4192-8176-A8C9AACEB478}" dt="2025-05-16T05:43:36.510" v="126" actId="2696"/>
+        <pc:sldMkLst>
+          <pc:docMk/>
+          <pc:sldMk cId="4247717824" sldId="700"/>
+        </pc:sldMkLst>
+      </pc:sldChg>
+      <pc:sldChg chg="del">
+        <pc:chgData name="Mohammed Fasha" userId="cc64f42d-a1a6-4f08-b97b-0c37f877119f" providerId="ADAL" clId="{FEC9C214-E726-4192-8176-A8C9AACEB478}" dt="2025-05-16T05:43:36.510" v="126" actId="2696"/>
+        <pc:sldMkLst>
+          <pc:docMk/>
+          <pc:sldMk cId="3085160177" sldId="704"/>
+        </pc:sldMkLst>
+      </pc:sldChg>
+      <pc:sldChg chg="del">
+        <pc:chgData name="Mohammed Fasha" userId="cc64f42d-a1a6-4f08-b97b-0c37f877119f" providerId="ADAL" clId="{FEC9C214-E726-4192-8176-A8C9AACEB478}" dt="2025-05-16T05:43:36.510" v="126" actId="2696"/>
+        <pc:sldMkLst>
+          <pc:docMk/>
+          <pc:sldMk cId="1862107672" sldId="705"/>
+        </pc:sldMkLst>
+      </pc:sldChg>
+      <pc:sldChg chg="modSp del mod">
+        <pc:chgData name="Mohammed Fasha" userId="cc64f42d-a1a6-4f08-b97b-0c37f877119f" providerId="ADAL" clId="{FEC9C214-E726-4192-8176-A8C9AACEB478}" dt="2025-05-16T05:43:36.510" v="126" actId="2696"/>
+        <pc:sldMkLst>
+          <pc:docMk/>
+          <pc:sldMk cId="1142780366" sldId="706"/>
+        </pc:sldMkLst>
+      </pc:sldChg>
+      <pc:sldChg chg="del">
+        <pc:chgData name="Mohammed Fasha" userId="cc64f42d-a1a6-4f08-b97b-0c37f877119f" providerId="ADAL" clId="{FEC9C214-E726-4192-8176-A8C9AACEB478}" dt="2025-05-16T05:43:36.510" v="126" actId="2696"/>
+        <pc:sldMkLst>
+          <pc:docMk/>
+          <pc:sldMk cId="67871309" sldId="709"/>
+        </pc:sldMkLst>
+      </pc:sldChg>
+      <pc:sldChg chg="del">
+        <pc:chgData name="Mohammed Fasha" userId="cc64f42d-a1a6-4f08-b97b-0c37f877119f" providerId="ADAL" clId="{FEC9C214-E726-4192-8176-A8C9AACEB478}" dt="2025-05-16T05:43:36.510" v="126" actId="2696"/>
+        <pc:sldMkLst>
+          <pc:docMk/>
+          <pc:sldMk cId="4114896152" sldId="710"/>
+        </pc:sldMkLst>
+      </pc:sldChg>
+      <pc:sldChg chg="del">
+        <pc:chgData name="Mohammed Fasha" userId="cc64f42d-a1a6-4f08-b97b-0c37f877119f" providerId="ADAL" clId="{FEC9C214-E726-4192-8176-A8C9AACEB478}" dt="2025-05-16T05:43:36.510" v="126" actId="2696"/>
+        <pc:sldMkLst>
+          <pc:docMk/>
+          <pc:sldMk cId="3794385322" sldId="711"/>
+        </pc:sldMkLst>
+      </pc:sldChg>
+      <pc:sldChg chg="del">
+        <pc:chgData name="Mohammed Fasha" userId="cc64f42d-a1a6-4f08-b97b-0c37f877119f" providerId="ADAL" clId="{FEC9C214-E726-4192-8176-A8C9AACEB478}" dt="2025-05-16T05:43:36.510" v="126" actId="2696"/>
+        <pc:sldMkLst>
+          <pc:docMk/>
+          <pc:sldMk cId="3701206727" sldId="712"/>
+        </pc:sldMkLst>
+      </pc:sldChg>
+      <pc:sldChg chg="del">
+        <pc:chgData name="Mohammed Fasha" userId="cc64f42d-a1a6-4f08-b97b-0c37f877119f" providerId="ADAL" clId="{FEC9C214-E726-4192-8176-A8C9AACEB478}" dt="2025-05-16T05:43:36.510" v="126" actId="2696"/>
+        <pc:sldMkLst>
+          <pc:docMk/>
+          <pc:sldMk cId="1499972066" sldId="713"/>
+        </pc:sldMkLst>
+      </pc:sldChg>
+      <pc:sldChg chg="del">
+        <pc:chgData name="Mohammed Fasha" userId="cc64f42d-a1a6-4f08-b97b-0c37f877119f" providerId="ADAL" clId="{FEC9C214-E726-4192-8176-A8C9AACEB478}" dt="2025-05-16T05:43:36.510" v="126" actId="2696"/>
+        <pc:sldMkLst>
+          <pc:docMk/>
+          <pc:sldMk cId="1270641495" sldId="714"/>
+        </pc:sldMkLst>
+      </pc:sldChg>
+      <pc:sldChg chg="modSp del mod">
+        <pc:chgData name="Mohammed Fasha" userId="cc64f42d-a1a6-4f08-b97b-0c37f877119f" providerId="ADAL" clId="{FEC9C214-E726-4192-8176-A8C9AACEB478}" dt="2025-05-16T05:43:36.510" v="126" actId="2696"/>
+        <pc:sldMkLst>
+          <pc:docMk/>
+          <pc:sldMk cId="1096386322" sldId="715"/>
+        </pc:sldMkLst>
+      </pc:sldChg>
+      <pc:sldChg chg="modSp del mod">
+        <pc:chgData name="Mohammed Fasha" userId="cc64f42d-a1a6-4f08-b97b-0c37f877119f" providerId="ADAL" clId="{FEC9C214-E726-4192-8176-A8C9AACEB478}" dt="2025-05-16T05:43:36.510" v="126" actId="2696"/>
+        <pc:sldMkLst>
+          <pc:docMk/>
+          <pc:sldMk cId="1784058309" sldId="716"/>
+        </pc:sldMkLst>
+      </pc:sldChg>
+      <pc:sldChg chg="modSp del mod">
+        <pc:chgData name="Mohammed Fasha" userId="cc64f42d-a1a6-4f08-b97b-0c37f877119f" providerId="ADAL" clId="{FEC9C214-E726-4192-8176-A8C9AACEB478}" dt="2025-05-16T05:43:36.510" v="126" actId="2696"/>
+        <pc:sldMkLst>
+          <pc:docMk/>
+          <pc:sldMk cId="3139017106" sldId="717"/>
+        </pc:sldMkLst>
+      </pc:sldChg>
+      <pc:sldChg chg="del">
+        <pc:chgData name="Mohammed Fasha" userId="cc64f42d-a1a6-4f08-b97b-0c37f877119f" providerId="ADAL" clId="{FEC9C214-E726-4192-8176-A8C9AACEB478}" dt="2025-05-16T05:43:36.510" v="126" actId="2696"/>
+        <pc:sldMkLst>
+          <pc:docMk/>
+          <pc:sldMk cId="3043812923" sldId="718"/>
+        </pc:sldMkLst>
+      </pc:sldChg>
+      <pc:sldChg chg="modSp del mod">
+        <pc:chgData name="Mohammed Fasha" userId="cc64f42d-a1a6-4f08-b97b-0c37f877119f" providerId="ADAL" clId="{FEC9C214-E726-4192-8176-A8C9AACEB478}" dt="2025-05-12T03:04:56.963" v="45" actId="2696"/>
+        <pc:sldMkLst>
+          <pc:docMk/>
+          <pc:sldMk cId="666527140" sldId="725"/>
+        </pc:sldMkLst>
+      </pc:sldChg>
+      <pc:sldChg chg="add del">
+        <pc:chgData name="Mohammed Fasha" userId="cc64f42d-a1a6-4f08-b97b-0c37f877119f" providerId="ADAL" clId="{FEC9C214-E726-4192-8176-A8C9AACEB478}" dt="2025-05-16T05:43:36.510" v="126" actId="2696"/>
+        <pc:sldMkLst>
+          <pc:docMk/>
+          <pc:sldMk cId="2280465272" sldId="725"/>
+        </pc:sldMkLst>
+      </pc:sldChg>
+      <pc:sldChg chg="del">
+        <pc:chgData name="Mohammed Fasha" userId="cc64f42d-a1a6-4f08-b97b-0c37f877119f" providerId="ADAL" clId="{FEC9C214-E726-4192-8176-A8C9AACEB478}" dt="2025-05-16T05:43:36.510" v="126" actId="2696"/>
+        <pc:sldMkLst>
+          <pc:docMk/>
+          <pc:sldMk cId="3660604927" sldId="726"/>
+        </pc:sldMkLst>
+      </pc:sldChg>
+      <pc:sldChg chg="del">
+        <pc:chgData name="Mohammed Fasha" userId="cc64f42d-a1a6-4f08-b97b-0c37f877119f" providerId="ADAL" clId="{FEC9C214-E726-4192-8176-A8C9AACEB478}" dt="2025-05-16T05:43:36.510" v="126" actId="2696"/>
+        <pc:sldMkLst>
+          <pc:docMk/>
+          <pc:sldMk cId="4051640529" sldId="728"/>
+        </pc:sldMkLst>
+      </pc:sldChg>
+      <pc:sldChg chg="modSp new del mod">
+        <pc:chgData name="Mohammed Fasha" userId="cc64f42d-a1a6-4f08-b97b-0c37f877119f" providerId="ADAL" clId="{FEC9C214-E726-4192-8176-A8C9AACEB478}" dt="2025-05-12T03:11:40.927" v="51" actId="47"/>
+        <pc:sldMkLst>
+          <pc:docMk/>
+          <pc:sldMk cId="1223704259" sldId="729"/>
+        </pc:sldMkLst>
+      </pc:sldChg>
+      <pc:sldChg chg="add del">
+        <pc:chgData name="Mohammed Fasha" userId="cc64f42d-a1a6-4f08-b97b-0c37f877119f" providerId="ADAL" clId="{FEC9C214-E726-4192-8176-A8C9AACEB478}" dt="2025-05-12T03:06:57.298" v="49"/>
+        <pc:sldMkLst>
+          <pc:docMk/>
+          <pc:sldMk cId="3927078588" sldId="730"/>
+        </pc:sldMkLst>
+      </pc:sldChg>
+    </pc:docChg>
+  </pc:docChgLst>
   <pc:docChgLst>
     <pc:chgData name="Mohammed Fasha" userId="cc64f42d-a1a6-4f08-b97b-0c37f877119f" providerId="ADAL" clId="{5980B3BB-4EB6-4E37-92BF-3A2A8F4B2C7A}"/>
     <pc:docChg chg="custSel modSld">
@@ -171,6 +1413,99 @@
         <pc:sldMkLst>
           <pc:docMk/>
           <pc:sldMk cId="2297456757" sldId="483"/>
+        </pc:sldMkLst>
+      </pc:sldChg>
+    </pc:docChg>
+  </pc:docChgLst>
+  <pc:docChgLst>
+    <pc:chgData name="Mohammed Fasha" userId="cc64f42d-a1a6-4f08-b97b-0c37f877119f" providerId="ADAL" clId="{2E5FBF59-3168-4932-9518-582502FE1AD5}"/>
+    <pc:docChg chg="undo custSel delSld modSld">
+      <pc:chgData name="Mohammed Fasha" userId="cc64f42d-a1a6-4f08-b97b-0c37f877119f" providerId="ADAL" clId="{2E5FBF59-3168-4932-9518-582502FE1AD5}" dt="2024-12-24T08:08:19.987" v="550" actId="20577"/>
+      <pc:docMkLst>
+        <pc:docMk/>
+      </pc:docMkLst>
+      <pc:sldChg chg="delSp">
+        <pc:chgData name="Mohammed Fasha" userId="cc64f42d-a1a6-4f08-b97b-0c37f877119f" providerId="ADAL" clId="{2E5FBF59-3168-4932-9518-582502FE1AD5}" dt="2024-11-19T07:40:47.121" v="208" actId="478"/>
+        <pc:sldMkLst>
+          <pc:docMk/>
+          <pc:sldMk cId="391491219" sldId="428"/>
+        </pc:sldMkLst>
+      </pc:sldChg>
+      <pc:sldChg chg="modSp">
+        <pc:chgData name="Mohammed Fasha" userId="cc64f42d-a1a6-4f08-b97b-0c37f877119f" providerId="ADAL" clId="{2E5FBF59-3168-4932-9518-582502FE1AD5}" dt="2024-12-03T07:43:58.007" v="456" actId="1076"/>
+        <pc:sldMkLst>
+          <pc:docMk/>
+          <pc:sldMk cId="3339445507" sldId="430"/>
+        </pc:sldMkLst>
+      </pc:sldChg>
+      <pc:sldChg chg="modSp">
+        <pc:chgData name="Mohammed Fasha" userId="cc64f42d-a1a6-4f08-b97b-0c37f877119f" providerId="ADAL" clId="{2E5FBF59-3168-4932-9518-582502FE1AD5}" dt="2024-12-03T07:45:08.136" v="474" actId="20577"/>
+        <pc:sldMkLst>
+          <pc:docMk/>
+          <pc:sldMk cId="3389046835" sldId="431"/>
+        </pc:sldMkLst>
+      </pc:sldChg>
+      <pc:sldChg chg="modSp">
+        <pc:chgData name="Mohammed Fasha" userId="cc64f42d-a1a6-4f08-b97b-0c37f877119f" providerId="ADAL" clId="{2E5FBF59-3168-4932-9518-582502FE1AD5}" dt="2024-11-10T06:33:09.727" v="37" actId="207"/>
+        <pc:sldMkLst>
+          <pc:docMk/>
+          <pc:sldMk cId="2726994946" sldId="479"/>
+        </pc:sldMkLst>
+      </pc:sldChg>
+      <pc:sldChg chg="modSp">
+        <pc:chgData name="Mohammed Fasha" userId="cc64f42d-a1a6-4f08-b97b-0c37f877119f" providerId="ADAL" clId="{2E5FBF59-3168-4932-9518-582502FE1AD5}" dt="2024-11-19T07:44:28.766" v="211" actId="20577"/>
+        <pc:sldMkLst>
+          <pc:docMk/>
+          <pc:sldMk cId="2297456757" sldId="483"/>
+        </pc:sldMkLst>
+      </pc:sldChg>
+      <pc:sldChg chg="modSp">
+        <pc:chgData name="Mohammed Fasha" userId="cc64f42d-a1a6-4f08-b97b-0c37f877119f" providerId="ADAL" clId="{2E5FBF59-3168-4932-9518-582502FE1AD5}" dt="2024-11-10T06:45:09.392" v="40" actId="20577"/>
+        <pc:sldMkLst>
+          <pc:docMk/>
+          <pc:sldMk cId="3474268344" sldId="596"/>
+        </pc:sldMkLst>
+      </pc:sldChg>
+      <pc:sldChg chg="modSp">
+        <pc:chgData name="Mohammed Fasha" userId="cc64f42d-a1a6-4f08-b97b-0c37f877119f" providerId="ADAL" clId="{2E5FBF59-3168-4932-9518-582502FE1AD5}" dt="2024-12-03T07:47:21.561" v="476" actId="6549"/>
+        <pc:sldMkLst>
+          <pc:docMk/>
+          <pc:sldMk cId="399592497" sldId="613"/>
+        </pc:sldMkLst>
+      </pc:sldChg>
+      <pc:sldChg chg="modSp">
+        <pc:chgData name="Mohammed Fasha" userId="cc64f42d-a1a6-4f08-b97b-0c37f877119f" providerId="ADAL" clId="{2E5FBF59-3168-4932-9518-582502FE1AD5}" dt="2024-12-03T07:49:02.980" v="478" actId="207"/>
+        <pc:sldMkLst>
+          <pc:docMk/>
+          <pc:sldMk cId="3329135496" sldId="617"/>
+        </pc:sldMkLst>
+      </pc:sldChg>
+      <pc:sldChg chg="modSp">
+        <pc:chgData name="Mohammed Fasha" userId="cc64f42d-a1a6-4f08-b97b-0c37f877119f" providerId="ADAL" clId="{2E5FBF59-3168-4932-9518-582502FE1AD5}" dt="2024-12-24T08:05:16.608" v="482" actId="403"/>
+        <pc:sldMkLst>
+          <pc:docMk/>
+          <pc:sldMk cId="2990045589" sldId="659"/>
+        </pc:sldMkLst>
+      </pc:sldChg>
+      <pc:sldChg chg="modSp">
+        <pc:chgData name="Mohammed Fasha" userId="cc64f42d-a1a6-4f08-b97b-0c37f877119f" providerId="ADAL" clId="{2E5FBF59-3168-4932-9518-582502FE1AD5}" dt="2024-12-24T08:08:19.987" v="550" actId="20577"/>
+        <pc:sldMkLst>
+          <pc:docMk/>
+          <pc:sldMk cId="2680231355" sldId="669"/>
+        </pc:sldMkLst>
+      </pc:sldChg>
+      <pc:sldChg chg="addSp modSp">
+        <pc:chgData name="Mohammed Fasha" userId="cc64f42d-a1a6-4f08-b97b-0c37f877119f" providerId="ADAL" clId="{2E5FBF59-3168-4932-9518-582502FE1AD5}" dt="2024-12-24T08:05:52.910" v="488" actId="1076"/>
+        <pc:sldMkLst>
+          <pc:docMk/>
+          <pc:sldMk cId="916102856" sldId="685"/>
+        </pc:sldMkLst>
+      </pc:sldChg>
+      <pc:sldChg chg="modSp">
+        <pc:chgData name="Mohammed Fasha" userId="cc64f42d-a1a6-4f08-b97b-0c37f877119f" providerId="ADAL" clId="{2E5FBF59-3168-4932-9518-582502FE1AD5}" dt="2024-11-19T07:03:29.557" v="206" actId="207"/>
+        <pc:sldMkLst>
+          <pc:docMk/>
+          <pc:sldMk cId="32004852" sldId="708"/>
         </pc:sldMkLst>
       </pc:sldChg>
     </pc:docChg>
@@ -1523,6 +2858,30 @@
     </pc:docChg>
   </pc:docChgLst>
   <pc:docChgLst>
+    <pc:chgData name="Mohammed Fasha" userId="cc64f42d-a1a6-4f08-b97b-0c37f877119f" providerId="ADAL" clId="{6804A8E6-8D7F-46E3-B091-66A8F6B926BF}"/>
+    <pc:docChg chg="custSel modMainMaster">
+      <pc:chgData name="Mohammed Fasha" userId="cc64f42d-a1a6-4f08-b97b-0c37f877119f" providerId="ADAL" clId="{6804A8E6-8D7F-46E3-B091-66A8F6B926BF}" dt="2024-11-09T05:15:35.019" v="2" actId="1076"/>
+      <pc:docMkLst>
+        <pc:docMk/>
+      </pc:docMkLst>
+      <pc:sldMasterChg chg="delSp mod modSldLayout">
+        <pc:chgData name="Mohammed Fasha" userId="cc64f42d-a1a6-4f08-b97b-0c37f877119f" providerId="ADAL" clId="{6804A8E6-8D7F-46E3-B091-66A8F6B926BF}" dt="2024-11-09T05:15:35.019" v="2" actId="1076"/>
+        <pc:sldMasterMkLst>
+          <pc:docMk/>
+          <pc:sldMasterMk cId="742811419" sldId="2147483648"/>
+        </pc:sldMasterMkLst>
+        <pc:sldLayoutChg chg="addSp modSp mod">
+          <pc:chgData name="Mohammed Fasha" userId="cc64f42d-a1a6-4f08-b97b-0c37f877119f" providerId="ADAL" clId="{6804A8E6-8D7F-46E3-B091-66A8F6B926BF}" dt="2024-11-09T05:15:35.019" v="2" actId="1076"/>
+          <pc:sldLayoutMkLst>
+            <pc:docMk/>
+            <pc:sldMasterMk cId="742811419" sldId="2147483648"/>
+            <pc:sldLayoutMk cId="4063788262" sldId="2147483649"/>
+          </pc:sldLayoutMkLst>
+        </pc:sldLayoutChg>
+      </pc:sldMasterChg>
+    </pc:docChg>
+  </pc:docChgLst>
+  <pc:docChgLst>
     <pc:chgData name="Mohammed Fasha" userId="cc64f42d-a1a6-4f08-b97b-0c37f877119f" providerId="ADAL" clId="{19B6BCF0-69C5-47B4-98CC-B0941D29A039}"/>
     <pc:docChg chg="undo redo custSel addSld delSld modSld sldOrd modMainMaster">
       <pc:chgData name="Mohammed Fasha" userId="cc64f42d-a1a6-4f08-b97b-0c37f877119f" providerId="ADAL" clId="{19B6BCF0-69C5-47B4-98CC-B0941D29A039}" dt="2025-04-09T04:34:39.336" v="631" actId="1076"/>
@@ -1810,1225 +3169,6 @@
               <ac:spMk id="3" creationId="{93FDCCF6-2612-A73C-C264-680D14569853}"/>
             </ac:spMkLst>
           </pc:spChg>
-        </pc:sldLayoutChg>
-      </pc:sldMasterChg>
-    </pc:docChg>
-  </pc:docChgLst>
-  <pc:docChgLst>
-    <pc:chgData name="Mohammed Fasha" userId="cc64f42d-a1a6-4f08-b97b-0c37f877119f" providerId="ADAL" clId="{4C71ED24-115E-432D-933D-C801DA3E52F1}"/>
-    <pc:docChg chg="delSld">
-      <pc:chgData name="Mohammed Fasha" userId="cc64f42d-a1a6-4f08-b97b-0c37f877119f" providerId="ADAL" clId="{4C71ED24-115E-432D-933D-C801DA3E52F1}" dt="2024-12-29T03:12:49.974" v="2" actId="47"/>
-      <pc:docMkLst>
-        <pc:docMk/>
-      </pc:docMkLst>
-      <pc:sldChg chg="del">
-        <pc:chgData name="Mohammed Fasha" userId="cc64f42d-a1a6-4f08-b97b-0c37f877119f" providerId="ADAL" clId="{4C71ED24-115E-432D-933D-C801DA3E52F1}" dt="2024-12-29T03:12:48.360" v="0" actId="47"/>
-        <pc:sldMkLst>
-          <pc:docMk/>
-          <pc:sldMk cId="2341000601" sldId="701"/>
-        </pc:sldMkLst>
-      </pc:sldChg>
-      <pc:sldChg chg="del">
-        <pc:chgData name="Mohammed Fasha" userId="cc64f42d-a1a6-4f08-b97b-0c37f877119f" providerId="ADAL" clId="{4C71ED24-115E-432D-933D-C801DA3E52F1}" dt="2024-12-29T03:12:49.133" v="1" actId="47"/>
-        <pc:sldMkLst>
-          <pc:docMk/>
-          <pc:sldMk cId="3519698944" sldId="702"/>
-        </pc:sldMkLst>
-      </pc:sldChg>
-      <pc:sldChg chg="del">
-        <pc:chgData name="Mohammed Fasha" userId="cc64f42d-a1a6-4f08-b97b-0c37f877119f" providerId="ADAL" clId="{4C71ED24-115E-432D-933D-C801DA3E52F1}" dt="2024-12-29T03:12:49.974" v="2" actId="47"/>
-        <pc:sldMkLst>
-          <pc:docMk/>
-          <pc:sldMk cId="3934257344" sldId="703"/>
-        </pc:sldMkLst>
-      </pc:sldChg>
-    </pc:docChg>
-  </pc:docChgLst>
-  <pc:docChgLst>
-    <pc:chgData name="Mohammed Fasha" userId="cc64f42d-a1a6-4f08-b97b-0c37f877119f" providerId="ADAL" clId="{BECD4A7F-C1AF-4585-8C31-FE7D4FE3ED16}"/>
-    <pc:docChg chg="undo redo custSel addSld delSld modSld sldOrd">
-      <pc:chgData name="Mohammed Fasha" userId="cc64f42d-a1a6-4f08-b97b-0c37f877119f" providerId="ADAL" clId="{BECD4A7F-C1AF-4585-8C31-FE7D4FE3ED16}" dt="2025-01-05T16:36:16.605" v="1945" actId="1076"/>
-      <pc:docMkLst>
-        <pc:docMk/>
-      </pc:docMkLst>
-      <pc:sldChg chg="modSp mod">
-        <pc:chgData name="Mohammed Fasha" userId="cc64f42d-a1a6-4f08-b97b-0c37f877119f" providerId="ADAL" clId="{BECD4A7F-C1AF-4585-8C31-FE7D4FE3ED16}" dt="2024-12-30T18:47:27.683" v="988" actId="20577"/>
-        <pc:sldMkLst>
-          <pc:docMk/>
-          <pc:sldMk cId="2281221656" sldId="527"/>
-        </pc:sldMkLst>
-      </pc:sldChg>
-      <pc:sldChg chg="modSp mod">
-        <pc:chgData name="Mohammed Fasha" userId="cc64f42d-a1a6-4f08-b97b-0c37f877119f" providerId="ADAL" clId="{BECD4A7F-C1AF-4585-8C31-FE7D4FE3ED16}" dt="2024-12-27T13:59:26.893" v="366" actId="20577"/>
-        <pc:sldMkLst>
-          <pc:docMk/>
-          <pc:sldMk cId="3474268344" sldId="596"/>
-        </pc:sldMkLst>
-      </pc:sldChg>
-      <pc:sldChg chg="modSp mod">
-        <pc:chgData name="Mohammed Fasha" userId="cc64f42d-a1a6-4f08-b97b-0c37f877119f" providerId="ADAL" clId="{BECD4A7F-C1AF-4585-8C31-FE7D4FE3ED16}" dt="2024-12-30T18:44:34.649" v="884" actId="20577"/>
-        <pc:sldMkLst>
-          <pc:docMk/>
-          <pc:sldMk cId="916802035" sldId="651"/>
-        </pc:sldMkLst>
-      </pc:sldChg>
-      <pc:sldChg chg="del">
-        <pc:chgData name="Mohammed Fasha" userId="cc64f42d-a1a6-4f08-b97b-0c37f877119f" providerId="ADAL" clId="{BECD4A7F-C1AF-4585-8C31-FE7D4FE3ED16}" dt="2025-01-05T14:42:38.675" v="989" actId="2696"/>
-        <pc:sldMkLst>
-          <pc:docMk/>
-          <pc:sldMk cId="426516858" sldId="662"/>
-        </pc:sldMkLst>
-      </pc:sldChg>
-      <pc:sldChg chg="modSp add del mod">
-        <pc:chgData name="Mohammed Fasha" userId="cc64f42d-a1a6-4f08-b97b-0c37f877119f" providerId="ADAL" clId="{BECD4A7F-C1AF-4585-8C31-FE7D4FE3ED16}" dt="2025-01-05T16:34:59.233" v="1926" actId="20577"/>
-        <pc:sldMkLst>
-          <pc:docMk/>
-          <pc:sldMk cId="691538069" sldId="662"/>
-        </pc:sldMkLst>
-      </pc:sldChg>
-      <pc:sldChg chg="del">
-        <pc:chgData name="Mohammed Fasha" userId="cc64f42d-a1a6-4f08-b97b-0c37f877119f" providerId="ADAL" clId="{BECD4A7F-C1AF-4585-8C31-FE7D4FE3ED16}" dt="2025-01-05T14:42:38.675" v="989" actId="2696"/>
-        <pc:sldMkLst>
-          <pc:docMk/>
-          <pc:sldMk cId="895445062" sldId="663"/>
-        </pc:sldMkLst>
-      </pc:sldChg>
-      <pc:sldChg chg="add del">
-        <pc:chgData name="Mohammed Fasha" userId="cc64f42d-a1a6-4f08-b97b-0c37f877119f" providerId="ADAL" clId="{BECD4A7F-C1AF-4585-8C31-FE7D4FE3ED16}" dt="2025-01-05T14:43:16.100" v="993" actId="2696"/>
-        <pc:sldMkLst>
-          <pc:docMk/>
-          <pc:sldMk cId="3980180774" sldId="663"/>
-        </pc:sldMkLst>
-      </pc:sldChg>
-      <pc:sldChg chg="add del">
-        <pc:chgData name="Mohammed Fasha" userId="cc64f42d-a1a6-4f08-b97b-0c37f877119f" providerId="ADAL" clId="{BECD4A7F-C1AF-4585-8C31-FE7D4FE3ED16}" dt="2025-01-05T14:43:16.100" v="993" actId="2696"/>
-        <pc:sldMkLst>
-          <pc:docMk/>
-          <pc:sldMk cId="1728680596" sldId="664"/>
-        </pc:sldMkLst>
-      </pc:sldChg>
-      <pc:sldChg chg="del">
-        <pc:chgData name="Mohammed Fasha" userId="cc64f42d-a1a6-4f08-b97b-0c37f877119f" providerId="ADAL" clId="{BECD4A7F-C1AF-4585-8C31-FE7D4FE3ED16}" dt="2025-01-05T14:42:38.675" v="989" actId="2696"/>
-        <pc:sldMkLst>
-          <pc:docMk/>
-          <pc:sldMk cId="3900588277" sldId="664"/>
-        </pc:sldMkLst>
-      </pc:sldChg>
-      <pc:sldChg chg="del">
-        <pc:chgData name="Mohammed Fasha" userId="cc64f42d-a1a6-4f08-b97b-0c37f877119f" providerId="ADAL" clId="{BECD4A7F-C1AF-4585-8C31-FE7D4FE3ED16}" dt="2025-01-05T14:42:38.675" v="989" actId="2696"/>
-        <pc:sldMkLst>
-          <pc:docMk/>
-          <pc:sldMk cId="123002105" sldId="665"/>
-        </pc:sldMkLst>
-      </pc:sldChg>
-      <pc:sldChg chg="modSp add del mod">
-        <pc:chgData name="Mohammed Fasha" userId="cc64f42d-a1a6-4f08-b97b-0c37f877119f" providerId="ADAL" clId="{BECD4A7F-C1AF-4585-8C31-FE7D4FE3ED16}" dt="2025-01-05T15:05:12.729" v="1226" actId="21"/>
-        <pc:sldMkLst>
-          <pc:docMk/>
-          <pc:sldMk cId="148099094" sldId="665"/>
-        </pc:sldMkLst>
-      </pc:sldChg>
-      <pc:sldChg chg="del">
-        <pc:chgData name="Mohammed Fasha" userId="cc64f42d-a1a6-4f08-b97b-0c37f877119f" providerId="ADAL" clId="{BECD4A7F-C1AF-4585-8C31-FE7D4FE3ED16}" dt="2025-01-05T14:42:38.675" v="989" actId="2696"/>
-        <pc:sldMkLst>
-          <pc:docMk/>
-          <pc:sldMk cId="659863378" sldId="676"/>
-        </pc:sldMkLst>
-      </pc:sldChg>
-      <pc:sldChg chg="modSp add del mod">
-        <pc:chgData name="Mohammed Fasha" userId="cc64f42d-a1a6-4f08-b97b-0c37f877119f" providerId="ADAL" clId="{BECD4A7F-C1AF-4585-8C31-FE7D4FE3ED16}" dt="2025-01-05T14:55:27.595" v="1130" actId="255"/>
-        <pc:sldMkLst>
-          <pc:docMk/>
-          <pc:sldMk cId="1577854815" sldId="676"/>
-        </pc:sldMkLst>
-      </pc:sldChg>
-      <pc:sldChg chg="modSp add del mod">
-        <pc:chgData name="Mohammed Fasha" userId="cc64f42d-a1a6-4f08-b97b-0c37f877119f" providerId="ADAL" clId="{BECD4A7F-C1AF-4585-8C31-FE7D4FE3ED16}" dt="2025-01-05T14:55:43.754" v="1132" actId="1076"/>
-        <pc:sldMkLst>
-          <pc:docMk/>
-          <pc:sldMk cId="139882925" sldId="677"/>
-        </pc:sldMkLst>
-      </pc:sldChg>
-      <pc:sldChg chg="del">
-        <pc:chgData name="Mohammed Fasha" userId="cc64f42d-a1a6-4f08-b97b-0c37f877119f" providerId="ADAL" clId="{BECD4A7F-C1AF-4585-8C31-FE7D4FE3ED16}" dt="2025-01-05T14:42:38.675" v="989" actId="2696"/>
-        <pc:sldMkLst>
-          <pc:docMk/>
-          <pc:sldMk cId="2736863534" sldId="677"/>
-        </pc:sldMkLst>
-      </pc:sldChg>
-      <pc:sldChg chg="add del">
-        <pc:chgData name="Mohammed Fasha" userId="cc64f42d-a1a6-4f08-b97b-0c37f877119f" providerId="ADAL" clId="{BECD4A7F-C1AF-4585-8C31-FE7D4FE3ED16}" dt="2025-01-05T14:43:16.100" v="993" actId="2696"/>
-        <pc:sldMkLst>
-          <pc:docMk/>
-          <pc:sldMk cId="4146654093" sldId="678"/>
-        </pc:sldMkLst>
-      </pc:sldChg>
-      <pc:sldChg chg="del">
-        <pc:chgData name="Mohammed Fasha" userId="cc64f42d-a1a6-4f08-b97b-0c37f877119f" providerId="ADAL" clId="{BECD4A7F-C1AF-4585-8C31-FE7D4FE3ED16}" dt="2025-01-05T14:42:38.675" v="989" actId="2696"/>
-        <pc:sldMkLst>
-          <pc:docMk/>
-          <pc:sldMk cId="4228312762" sldId="678"/>
-        </pc:sldMkLst>
-      </pc:sldChg>
-      <pc:sldChg chg="del">
-        <pc:chgData name="Mohammed Fasha" userId="cc64f42d-a1a6-4f08-b97b-0c37f877119f" providerId="ADAL" clId="{BECD4A7F-C1AF-4585-8C31-FE7D4FE3ED16}" dt="2025-01-05T14:42:38.675" v="989" actId="2696"/>
-        <pc:sldMkLst>
-          <pc:docMk/>
-          <pc:sldMk cId="581717462" sldId="679"/>
-        </pc:sldMkLst>
-      </pc:sldChg>
-      <pc:sldChg chg="addSp delSp modSp add del mod chgLayout">
-        <pc:chgData name="Mohammed Fasha" userId="cc64f42d-a1a6-4f08-b97b-0c37f877119f" providerId="ADAL" clId="{BECD4A7F-C1AF-4585-8C31-FE7D4FE3ED16}" dt="2025-01-05T16:36:16.605" v="1945" actId="1076"/>
-        <pc:sldMkLst>
-          <pc:docMk/>
-          <pc:sldMk cId="3454522070" sldId="679"/>
-        </pc:sldMkLst>
-      </pc:sldChg>
-      <pc:sldChg chg="add del">
-        <pc:chgData name="Mohammed Fasha" userId="cc64f42d-a1a6-4f08-b97b-0c37f877119f" providerId="ADAL" clId="{BECD4A7F-C1AF-4585-8C31-FE7D4FE3ED16}" dt="2025-01-05T14:43:16.100" v="993" actId="2696"/>
-        <pc:sldMkLst>
-          <pc:docMk/>
-          <pc:sldMk cId="2856814121" sldId="681"/>
-        </pc:sldMkLst>
-      </pc:sldChg>
-      <pc:sldChg chg="del">
-        <pc:chgData name="Mohammed Fasha" userId="cc64f42d-a1a6-4f08-b97b-0c37f877119f" providerId="ADAL" clId="{BECD4A7F-C1AF-4585-8C31-FE7D4FE3ED16}" dt="2025-01-05T14:42:38.675" v="989" actId="2696"/>
-        <pc:sldMkLst>
-          <pc:docMk/>
-          <pc:sldMk cId="3083966018" sldId="681"/>
-        </pc:sldMkLst>
-      </pc:sldChg>
-      <pc:sldChg chg="modSp mod">
-        <pc:chgData name="Mohammed Fasha" userId="cc64f42d-a1a6-4f08-b97b-0c37f877119f" providerId="ADAL" clId="{BECD4A7F-C1AF-4585-8C31-FE7D4FE3ED16}" dt="2025-01-05T14:42:50.596" v="990" actId="14100"/>
-        <pc:sldMkLst>
-          <pc:docMk/>
-          <pc:sldMk cId="1697141369" sldId="695"/>
-        </pc:sldMkLst>
-      </pc:sldChg>
-      <pc:sldChg chg="addSp delSp modSp add del mod">
-        <pc:chgData name="Mohammed Fasha" userId="cc64f42d-a1a6-4f08-b97b-0c37f877119f" providerId="ADAL" clId="{BECD4A7F-C1AF-4585-8C31-FE7D4FE3ED16}" dt="2025-01-05T14:54:31.375" v="1125" actId="14100"/>
-        <pc:sldMkLst>
-          <pc:docMk/>
-          <pc:sldMk cId="265576630" sldId="698"/>
-        </pc:sldMkLst>
-      </pc:sldChg>
-      <pc:sldChg chg="del">
-        <pc:chgData name="Mohammed Fasha" userId="cc64f42d-a1a6-4f08-b97b-0c37f877119f" providerId="ADAL" clId="{BECD4A7F-C1AF-4585-8C31-FE7D4FE3ED16}" dt="2025-01-05T14:42:38.675" v="989" actId="2696"/>
-        <pc:sldMkLst>
-          <pc:docMk/>
-          <pc:sldMk cId="991725834" sldId="698"/>
-        </pc:sldMkLst>
-      </pc:sldChg>
-      <pc:sldChg chg="del">
-        <pc:chgData name="Mohammed Fasha" userId="cc64f42d-a1a6-4f08-b97b-0c37f877119f" providerId="ADAL" clId="{BECD4A7F-C1AF-4585-8C31-FE7D4FE3ED16}" dt="2025-01-05T14:42:38.675" v="989" actId="2696"/>
-        <pc:sldMkLst>
-          <pc:docMk/>
-          <pc:sldMk cId="3109561867" sldId="700"/>
-        </pc:sldMkLst>
-      </pc:sldChg>
-      <pc:sldChg chg="addSp delSp modSp add del mod">
-        <pc:chgData name="Mohammed Fasha" userId="cc64f42d-a1a6-4f08-b97b-0c37f877119f" providerId="ADAL" clId="{BECD4A7F-C1AF-4585-8C31-FE7D4FE3ED16}" dt="2025-01-05T16:00:05.564" v="1529" actId="20577"/>
-        <pc:sldMkLst>
-          <pc:docMk/>
-          <pc:sldMk cId="4247717824" sldId="700"/>
-        </pc:sldMkLst>
-      </pc:sldChg>
-      <pc:sldChg chg="addSp delSp modSp add mod">
-        <pc:chgData name="Mohammed Fasha" userId="cc64f42d-a1a6-4f08-b97b-0c37f877119f" providerId="ADAL" clId="{BECD4A7F-C1AF-4585-8C31-FE7D4FE3ED16}" dt="2025-01-05T14:53:29.185" v="1101" actId="21"/>
-        <pc:sldMkLst>
-          <pc:docMk/>
-          <pc:sldMk cId="67871309" sldId="709"/>
-        </pc:sldMkLst>
-      </pc:sldChg>
-      <pc:sldChg chg="modSp add mod">
-        <pc:chgData name="Mohammed Fasha" userId="cc64f42d-a1a6-4f08-b97b-0c37f877119f" providerId="ADAL" clId="{BECD4A7F-C1AF-4585-8C31-FE7D4FE3ED16}" dt="2025-01-05T15:31:09.113" v="1385" actId="6549"/>
-        <pc:sldMkLst>
-          <pc:docMk/>
-          <pc:sldMk cId="4114896152" sldId="710"/>
-        </pc:sldMkLst>
-      </pc:sldChg>
-      <pc:sldChg chg="addSp modSp add mod">
-        <pc:chgData name="Mohammed Fasha" userId="cc64f42d-a1a6-4f08-b97b-0c37f877119f" providerId="ADAL" clId="{BECD4A7F-C1AF-4585-8C31-FE7D4FE3ED16}" dt="2025-01-05T15:27:36.027" v="1348" actId="20577"/>
-        <pc:sldMkLst>
-          <pc:docMk/>
-          <pc:sldMk cId="3794385322" sldId="711"/>
-        </pc:sldMkLst>
-      </pc:sldChg>
-      <pc:sldChg chg="add del">
-        <pc:chgData name="Mohammed Fasha" userId="cc64f42d-a1a6-4f08-b97b-0c37f877119f" providerId="ADAL" clId="{BECD4A7F-C1AF-4585-8C31-FE7D4FE3ED16}" dt="2025-01-05T14:57:43.613" v="1146" actId="2696"/>
-        <pc:sldMkLst>
-          <pc:docMk/>
-          <pc:sldMk cId="501127302" sldId="712"/>
-        </pc:sldMkLst>
-      </pc:sldChg>
-      <pc:sldChg chg="modSp add mod">
-        <pc:chgData name="Mohammed Fasha" userId="cc64f42d-a1a6-4f08-b97b-0c37f877119f" providerId="ADAL" clId="{BECD4A7F-C1AF-4585-8C31-FE7D4FE3ED16}" dt="2025-01-05T15:32:23.870" v="1388"/>
-        <pc:sldMkLst>
-          <pc:docMk/>
-          <pc:sldMk cId="3701206727" sldId="712"/>
-        </pc:sldMkLst>
-      </pc:sldChg>
-      <pc:sldChg chg="addSp modSp add mod">
-        <pc:chgData name="Mohammed Fasha" userId="cc64f42d-a1a6-4f08-b97b-0c37f877119f" providerId="ADAL" clId="{BECD4A7F-C1AF-4585-8C31-FE7D4FE3ED16}" dt="2025-01-05T16:06:36.028" v="1538" actId="1076"/>
-        <pc:sldMkLst>
-          <pc:docMk/>
-          <pc:sldMk cId="1499972066" sldId="713"/>
-        </pc:sldMkLst>
-      </pc:sldChg>
-      <pc:sldChg chg="addSp delSp modSp add mod">
-        <pc:chgData name="Mohammed Fasha" userId="cc64f42d-a1a6-4f08-b97b-0c37f877119f" providerId="ADAL" clId="{BECD4A7F-C1AF-4585-8C31-FE7D4FE3ED16}" dt="2025-01-05T16:19:08.436" v="1705" actId="1036"/>
-        <pc:sldMkLst>
-          <pc:docMk/>
-          <pc:sldMk cId="1270641495" sldId="714"/>
-        </pc:sldMkLst>
-      </pc:sldChg>
-      <pc:sldChg chg="addSp modSp new mod">
-        <pc:chgData name="Mohammed Fasha" userId="cc64f42d-a1a6-4f08-b97b-0c37f877119f" providerId="ADAL" clId="{BECD4A7F-C1AF-4585-8C31-FE7D4FE3ED16}" dt="2025-01-05T16:23:44.632" v="1736" actId="12"/>
-        <pc:sldMkLst>
-          <pc:docMk/>
-          <pc:sldMk cId="1096386322" sldId="715"/>
-        </pc:sldMkLst>
-      </pc:sldChg>
-      <pc:sldChg chg="modSp new mod">
-        <pc:chgData name="Mohammed Fasha" userId="cc64f42d-a1a6-4f08-b97b-0c37f877119f" providerId="ADAL" clId="{BECD4A7F-C1AF-4585-8C31-FE7D4FE3ED16}" dt="2025-01-05T16:34:02.360" v="1902" actId="27636"/>
-        <pc:sldMkLst>
-          <pc:docMk/>
-          <pc:sldMk cId="1784058309" sldId="716"/>
-        </pc:sldMkLst>
-      </pc:sldChg>
-      <pc:sldChg chg="modSp add mod ord">
-        <pc:chgData name="Mohammed Fasha" userId="cc64f42d-a1a6-4f08-b97b-0c37f877119f" providerId="ADAL" clId="{BECD4A7F-C1AF-4585-8C31-FE7D4FE3ED16}" dt="2025-01-05T16:27:20.520" v="1803"/>
-        <pc:sldMkLst>
-          <pc:docMk/>
-          <pc:sldMk cId="3139017106" sldId="717"/>
-        </pc:sldMkLst>
-      </pc:sldChg>
-      <pc:sldChg chg="addSp delSp modSp new mod">
-        <pc:chgData name="Mohammed Fasha" userId="cc64f42d-a1a6-4f08-b97b-0c37f877119f" providerId="ADAL" clId="{BECD4A7F-C1AF-4585-8C31-FE7D4FE3ED16}" dt="2025-01-05T16:32:45.446" v="1897" actId="20577"/>
-        <pc:sldMkLst>
-          <pc:docMk/>
-          <pc:sldMk cId="3043812923" sldId="718"/>
-        </pc:sldMkLst>
-      </pc:sldChg>
-    </pc:docChg>
-  </pc:docChgLst>
-  <pc:docChgLst>
-    <pc:chgData name="Mohammed Fasha" userId="cc64f42d-a1a6-4f08-b97b-0c37f877119f" providerId="ADAL" clId="{FEC9C214-E726-4192-8176-A8C9AACEB478}"/>
-    <pc:docChg chg="custSel addSld delSld modSld">
-      <pc:chgData name="Mohammed Fasha" userId="cc64f42d-a1a6-4f08-b97b-0c37f877119f" providerId="ADAL" clId="{FEC9C214-E726-4192-8176-A8C9AACEB478}" dt="2025-05-16T05:43:36.510" v="126" actId="2696"/>
-      <pc:docMkLst>
-        <pc:docMk/>
-      </pc:docMkLst>
-      <pc:sldChg chg="del">
-        <pc:chgData name="Mohammed Fasha" userId="cc64f42d-a1a6-4f08-b97b-0c37f877119f" providerId="ADAL" clId="{FEC9C214-E726-4192-8176-A8C9AACEB478}" dt="2025-05-16T05:43:36.510" v="126" actId="2696"/>
-        <pc:sldMkLst>
-          <pc:docMk/>
-          <pc:sldMk cId="607684796" sldId="333"/>
-        </pc:sldMkLst>
-      </pc:sldChg>
-      <pc:sldChg chg="del">
-        <pc:chgData name="Mohammed Fasha" userId="cc64f42d-a1a6-4f08-b97b-0c37f877119f" providerId="ADAL" clId="{FEC9C214-E726-4192-8176-A8C9AACEB478}" dt="2025-05-16T05:43:36.510" v="126" actId="2696"/>
-        <pc:sldMkLst>
-          <pc:docMk/>
-          <pc:sldMk cId="587789057" sldId="423"/>
-        </pc:sldMkLst>
-      </pc:sldChg>
-      <pc:sldChg chg="del">
-        <pc:chgData name="Mohammed Fasha" userId="cc64f42d-a1a6-4f08-b97b-0c37f877119f" providerId="ADAL" clId="{FEC9C214-E726-4192-8176-A8C9AACEB478}" dt="2025-05-16T05:43:36.510" v="126" actId="2696"/>
-        <pc:sldMkLst>
-          <pc:docMk/>
-          <pc:sldMk cId="2127906749" sldId="427"/>
-        </pc:sldMkLst>
-      </pc:sldChg>
-      <pc:sldChg chg="del">
-        <pc:chgData name="Mohammed Fasha" userId="cc64f42d-a1a6-4f08-b97b-0c37f877119f" providerId="ADAL" clId="{FEC9C214-E726-4192-8176-A8C9AACEB478}" dt="2025-05-16T05:43:36.510" v="126" actId="2696"/>
-        <pc:sldMkLst>
-          <pc:docMk/>
-          <pc:sldMk cId="391491219" sldId="428"/>
-        </pc:sldMkLst>
-      </pc:sldChg>
-      <pc:sldChg chg="del">
-        <pc:chgData name="Mohammed Fasha" userId="cc64f42d-a1a6-4f08-b97b-0c37f877119f" providerId="ADAL" clId="{FEC9C214-E726-4192-8176-A8C9AACEB478}" dt="2025-05-16T05:43:36.510" v="126" actId="2696"/>
-        <pc:sldMkLst>
-          <pc:docMk/>
-          <pc:sldMk cId="3339445507" sldId="430"/>
-        </pc:sldMkLst>
-      </pc:sldChg>
-      <pc:sldChg chg="del">
-        <pc:chgData name="Mohammed Fasha" userId="cc64f42d-a1a6-4f08-b97b-0c37f877119f" providerId="ADAL" clId="{FEC9C214-E726-4192-8176-A8C9AACEB478}" dt="2025-05-16T05:43:36.510" v="126" actId="2696"/>
-        <pc:sldMkLst>
-          <pc:docMk/>
-          <pc:sldMk cId="3389046835" sldId="431"/>
-        </pc:sldMkLst>
-      </pc:sldChg>
-      <pc:sldChg chg="modSp mod">
-        <pc:chgData name="Mohammed Fasha" userId="cc64f42d-a1a6-4f08-b97b-0c37f877119f" providerId="ADAL" clId="{FEC9C214-E726-4192-8176-A8C9AACEB478}" dt="2025-05-16T05:42:48.998" v="99" actId="6549"/>
-        <pc:sldMkLst>
-          <pc:docMk/>
-          <pc:sldMk cId="4208461039" sldId="447"/>
-        </pc:sldMkLst>
-      </pc:sldChg>
-      <pc:sldChg chg="modSp mod">
-        <pc:chgData name="Mohammed Fasha" userId="cc64f42d-a1a6-4f08-b97b-0c37f877119f" providerId="ADAL" clId="{FEC9C214-E726-4192-8176-A8C9AACEB478}" dt="2025-05-16T05:43:13.101" v="125" actId="6549"/>
-        <pc:sldMkLst>
-          <pc:docMk/>
-          <pc:sldMk cId="2297456757" sldId="483"/>
-        </pc:sldMkLst>
-        <pc:spChg chg="mod">
-          <ac:chgData name="Mohammed Fasha" userId="cc64f42d-a1a6-4f08-b97b-0c37f877119f" providerId="ADAL" clId="{FEC9C214-E726-4192-8176-A8C9AACEB478}" dt="2025-05-16T05:43:13.101" v="125" actId="6549"/>
-          <ac:spMkLst>
-            <pc:docMk/>
-            <pc:sldMk cId="2297456757" sldId="483"/>
-            <ac:spMk id="5" creationId="{89403830-E271-DAA0-8838-E295A84A8B5B}"/>
-          </ac:spMkLst>
-        </pc:spChg>
-      </pc:sldChg>
-      <pc:sldChg chg="del">
-        <pc:chgData name="Mohammed Fasha" userId="cc64f42d-a1a6-4f08-b97b-0c37f877119f" providerId="ADAL" clId="{FEC9C214-E726-4192-8176-A8C9AACEB478}" dt="2025-05-16T05:43:36.510" v="126" actId="2696"/>
-        <pc:sldMkLst>
-          <pc:docMk/>
-          <pc:sldMk cId="1586650541" sldId="510"/>
-        </pc:sldMkLst>
-      </pc:sldChg>
-      <pc:sldChg chg="del">
-        <pc:chgData name="Mohammed Fasha" userId="cc64f42d-a1a6-4f08-b97b-0c37f877119f" providerId="ADAL" clId="{FEC9C214-E726-4192-8176-A8C9AACEB478}" dt="2025-05-16T05:43:36.510" v="126" actId="2696"/>
-        <pc:sldMkLst>
-          <pc:docMk/>
-          <pc:sldMk cId="1271956779" sldId="514"/>
-        </pc:sldMkLst>
-      </pc:sldChg>
-      <pc:sldChg chg="del">
-        <pc:chgData name="Mohammed Fasha" userId="cc64f42d-a1a6-4f08-b97b-0c37f877119f" providerId="ADAL" clId="{FEC9C214-E726-4192-8176-A8C9AACEB478}" dt="2025-05-16T05:43:36.510" v="126" actId="2696"/>
-        <pc:sldMkLst>
-          <pc:docMk/>
-          <pc:sldMk cId="2281221656" sldId="527"/>
-        </pc:sldMkLst>
-      </pc:sldChg>
-      <pc:sldChg chg="del">
-        <pc:chgData name="Mohammed Fasha" userId="cc64f42d-a1a6-4f08-b97b-0c37f877119f" providerId="ADAL" clId="{FEC9C214-E726-4192-8176-A8C9AACEB478}" dt="2025-05-16T05:43:36.510" v="126" actId="2696"/>
-        <pc:sldMkLst>
-          <pc:docMk/>
-          <pc:sldMk cId="2877973779" sldId="607"/>
-        </pc:sldMkLst>
-      </pc:sldChg>
-      <pc:sldChg chg="del">
-        <pc:chgData name="Mohammed Fasha" userId="cc64f42d-a1a6-4f08-b97b-0c37f877119f" providerId="ADAL" clId="{FEC9C214-E726-4192-8176-A8C9AACEB478}" dt="2025-05-16T05:43:36.510" v="126" actId="2696"/>
-        <pc:sldMkLst>
-          <pc:docMk/>
-          <pc:sldMk cId="21481256" sldId="611"/>
-        </pc:sldMkLst>
-      </pc:sldChg>
-      <pc:sldChg chg="del">
-        <pc:chgData name="Mohammed Fasha" userId="cc64f42d-a1a6-4f08-b97b-0c37f877119f" providerId="ADAL" clId="{FEC9C214-E726-4192-8176-A8C9AACEB478}" dt="2025-05-16T05:43:36.510" v="126" actId="2696"/>
-        <pc:sldMkLst>
-          <pc:docMk/>
-          <pc:sldMk cId="4040874025" sldId="612"/>
-        </pc:sldMkLst>
-      </pc:sldChg>
-      <pc:sldChg chg="del">
-        <pc:chgData name="Mohammed Fasha" userId="cc64f42d-a1a6-4f08-b97b-0c37f877119f" providerId="ADAL" clId="{FEC9C214-E726-4192-8176-A8C9AACEB478}" dt="2025-05-16T05:43:36.510" v="126" actId="2696"/>
-        <pc:sldMkLst>
-          <pc:docMk/>
-          <pc:sldMk cId="399592497" sldId="613"/>
-        </pc:sldMkLst>
-      </pc:sldChg>
-      <pc:sldChg chg="del">
-        <pc:chgData name="Mohammed Fasha" userId="cc64f42d-a1a6-4f08-b97b-0c37f877119f" providerId="ADAL" clId="{FEC9C214-E726-4192-8176-A8C9AACEB478}" dt="2025-05-16T05:43:36.510" v="126" actId="2696"/>
-        <pc:sldMkLst>
-          <pc:docMk/>
-          <pc:sldMk cId="3535314737" sldId="614"/>
-        </pc:sldMkLst>
-      </pc:sldChg>
-      <pc:sldChg chg="del">
-        <pc:chgData name="Mohammed Fasha" userId="cc64f42d-a1a6-4f08-b97b-0c37f877119f" providerId="ADAL" clId="{FEC9C214-E726-4192-8176-A8C9AACEB478}" dt="2025-05-16T05:43:36.510" v="126" actId="2696"/>
-        <pc:sldMkLst>
-          <pc:docMk/>
-          <pc:sldMk cId="627652750" sldId="615"/>
-        </pc:sldMkLst>
-      </pc:sldChg>
-      <pc:sldChg chg="del">
-        <pc:chgData name="Mohammed Fasha" userId="cc64f42d-a1a6-4f08-b97b-0c37f877119f" providerId="ADAL" clId="{FEC9C214-E726-4192-8176-A8C9AACEB478}" dt="2025-05-16T05:43:36.510" v="126" actId="2696"/>
-        <pc:sldMkLst>
-          <pc:docMk/>
-          <pc:sldMk cId="423212581" sldId="616"/>
-        </pc:sldMkLst>
-      </pc:sldChg>
-      <pc:sldChg chg="del">
-        <pc:chgData name="Mohammed Fasha" userId="cc64f42d-a1a6-4f08-b97b-0c37f877119f" providerId="ADAL" clId="{FEC9C214-E726-4192-8176-A8C9AACEB478}" dt="2025-05-16T05:43:36.510" v="126" actId="2696"/>
-        <pc:sldMkLst>
-          <pc:docMk/>
-          <pc:sldMk cId="3329135496" sldId="617"/>
-        </pc:sldMkLst>
-      </pc:sldChg>
-      <pc:sldChg chg="del">
-        <pc:chgData name="Mohammed Fasha" userId="cc64f42d-a1a6-4f08-b97b-0c37f877119f" providerId="ADAL" clId="{FEC9C214-E726-4192-8176-A8C9AACEB478}" dt="2025-05-16T05:43:36.510" v="126" actId="2696"/>
-        <pc:sldMkLst>
-          <pc:docMk/>
-          <pc:sldMk cId="1380276415" sldId="618"/>
-        </pc:sldMkLst>
-      </pc:sldChg>
-      <pc:sldChg chg="del">
-        <pc:chgData name="Mohammed Fasha" userId="cc64f42d-a1a6-4f08-b97b-0c37f877119f" providerId="ADAL" clId="{FEC9C214-E726-4192-8176-A8C9AACEB478}" dt="2025-05-16T05:43:36.510" v="126" actId="2696"/>
-        <pc:sldMkLst>
-          <pc:docMk/>
-          <pc:sldMk cId="246730148" sldId="619"/>
-        </pc:sldMkLst>
-      </pc:sldChg>
-      <pc:sldChg chg="del">
-        <pc:chgData name="Mohammed Fasha" userId="cc64f42d-a1a6-4f08-b97b-0c37f877119f" providerId="ADAL" clId="{FEC9C214-E726-4192-8176-A8C9AACEB478}" dt="2025-05-16T05:43:36.510" v="126" actId="2696"/>
-        <pc:sldMkLst>
-          <pc:docMk/>
-          <pc:sldMk cId="839834530" sldId="621"/>
-        </pc:sldMkLst>
-      </pc:sldChg>
-      <pc:sldChg chg="del">
-        <pc:chgData name="Mohammed Fasha" userId="cc64f42d-a1a6-4f08-b97b-0c37f877119f" providerId="ADAL" clId="{FEC9C214-E726-4192-8176-A8C9AACEB478}" dt="2025-05-16T05:43:36.510" v="126" actId="2696"/>
-        <pc:sldMkLst>
-          <pc:docMk/>
-          <pc:sldMk cId="3734309461" sldId="625"/>
-        </pc:sldMkLst>
-      </pc:sldChg>
-      <pc:sldChg chg="del">
-        <pc:chgData name="Mohammed Fasha" userId="cc64f42d-a1a6-4f08-b97b-0c37f877119f" providerId="ADAL" clId="{FEC9C214-E726-4192-8176-A8C9AACEB478}" dt="2025-05-16T05:43:36.510" v="126" actId="2696"/>
-        <pc:sldMkLst>
-          <pc:docMk/>
-          <pc:sldMk cId="4269580935" sldId="634"/>
-        </pc:sldMkLst>
-      </pc:sldChg>
-      <pc:sldChg chg="del">
-        <pc:chgData name="Mohammed Fasha" userId="cc64f42d-a1a6-4f08-b97b-0c37f877119f" providerId="ADAL" clId="{FEC9C214-E726-4192-8176-A8C9AACEB478}" dt="2025-05-16T05:43:36.510" v="126" actId="2696"/>
-        <pc:sldMkLst>
-          <pc:docMk/>
-          <pc:sldMk cId="2838240985" sldId="635"/>
-        </pc:sldMkLst>
-      </pc:sldChg>
-      <pc:sldChg chg="del">
-        <pc:chgData name="Mohammed Fasha" userId="cc64f42d-a1a6-4f08-b97b-0c37f877119f" providerId="ADAL" clId="{FEC9C214-E726-4192-8176-A8C9AACEB478}" dt="2025-05-16T05:43:36.510" v="126" actId="2696"/>
-        <pc:sldMkLst>
-          <pc:docMk/>
-          <pc:sldMk cId="1675291572" sldId="638"/>
-        </pc:sldMkLst>
-      </pc:sldChg>
-      <pc:sldChg chg="modSp del">
-        <pc:chgData name="Mohammed Fasha" userId="cc64f42d-a1a6-4f08-b97b-0c37f877119f" providerId="ADAL" clId="{FEC9C214-E726-4192-8176-A8C9AACEB478}" dt="2025-05-16T05:43:36.510" v="126" actId="2696"/>
-        <pc:sldMkLst>
-          <pc:docMk/>
-          <pc:sldMk cId="2145145303" sldId="640"/>
-        </pc:sldMkLst>
-      </pc:sldChg>
-      <pc:sldChg chg="del">
-        <pc:chgData name="Mohammed Fasha" userId="cc64f42d-a1a6-4f08-b97b-0c37f877119f" providerId="ADAL" clId="{FEC9C214-E726-4192-8176-A8C9AACEB478}" dt="2025-05-16T05:43:36.510" v="126" actId="2696"/>
-        <pc:sldMkLst>
-          <pc:docMk/>
-          <pc:sldMk cId="1135291414" sldId="643"/>
-        </pc:sldMkLst>
-      </pc:sldChg>
-      <pc:sldChg chg="del">
-        <pc:chgData name="Mohammed Fasha" userId="cc64f42d-a1a6-4f08-b97b-0c37f877119f" providerId="ADAL" clId="{FEC9C214-E726-4192-8176-A8C9AACEB478}" dt="2025-05-16T05:43:36.510" v="126" actId="2696"/>
-        <pc:sldMkLst>
-          <pc:docMk/>
-          <pc:sldMk cId="1030124935" sldId="644"/>
-        </pc:sldMkLst>
-      </pc:sldChg>
-      <pc:sldChg chg="del">
-        <pc:chgData name="Mohammed Fasha" userId="cc64f42d-a1a6-4f08-b97b-0c37f877119f" providerId="ADAL" clId="{FEC9C214-E726-4192-8176-A8C9AACEB478}" dt="2025-05-16T05:43:36.510" v="126" actId="2696"/>
-        <pc:sldMkLst>
-          <pc:docMk/>
-          <pc:sldMk cId="2168644593" sldId="645"/>
-        </pc:sldMkLst>
-      </pc:sldChg>
-      <pc:sldChg chg="del">
-        <pc:chgData name="Mohammed Fasha" userId="cc64f42d-a1a6-4f08-b97b-0c37f877119f" providerId="ADAL" clId="{FEC9C214-E726-4192-8176-A8C9AACEB478}" dt="2025-05-16T05:43:36.510" v="126" actId="2696"/>
-        <pc:sldMkLst>
-          <pc:docMk/>
-          <pc:sldMk cId="2743226386" sldId="646"/>
-        </pc:sldMkLst>
-      </pc:sldChg>
-      <pc:sldChg chg="del">
-        <pc:chgData name="Mohammed Fasha" userId="cc64f42d-a1a6-4f08-b97b-0c37f877119f" providerId="ADAL" clId="{FEC9C214-E726-4192-8176-A8C9AACEB478}" dt="2025-05-16T05:43:36.510" v="126" actId="2696"/>
-        <pc:sldMkLst>
-          <pc:docMk/>
-          <pc:sldMk cId="202107314" sldId="647"/>
-        </pc:sldMkLst>
-      </pc:sldChg>
-      <pc:sldChg chg="del">
-        <pc:chgData name="Mohammed Fasha" userId="cc64f42d-a1a6-4f08-b97b-0c37f877119f" providerId="ADAL" clId="{FEC9C214-E726-4192-8176-A8C9AACEB478}" dt="2025-05-16T05:43:36.510" v="126" actId="2696"/>
-        <pc:sldMkLst>
-          <pc:docMk/>
-          <pc:sldMk cId="662689605" sldId="649"/>
-        </pc:sldMkLst>
-      </pc:sldChg>
-      <pc:sldChg chg="del">
-        <pc:chgData name="Mohammed Fasha" userId="cc64f42d-a1a6-4f08-b97b-0c37f877119f" providerId="ADAL" clId="{FEC9C214-E726-4192-8176-A8C9AACEB478}" dt="2025-05-16T05:43:36.510" v="126" actId="2696"/>
-        <pc:sldMkLst>
-          <pc:docMk/>
-          <pc:sldMk cId="3942060319" sldId="650"/>
-        </pc:sldMkLst>
-      </pc:sldChg>
-      <pc:sldChg chg="del">
-        <pc:chgData name="Mohammed Fasha" userId="cc64f42d-a1a6-4f08-b97b-0c37f877119f" providerId="ADAL" clId="{FEC9C214-E726-4192-8176-A8C9AACEB478}" dt="2025-05-16T05:43:36.510" v="126" actId="2696"/>
-        <pc:sldMkLst>
-          <pc:docMk/>
-          <pc:sldMk cId="916802035" sldId="651"/>
-        </pc:sldMkLst>
-      </pc:sldChg>
-      <pc:sldChg chg="del">
-        <pc:chgData name="Mohammed Fasha" userId="cc64f42d-a1a6-4f08-b97b-0c37f877119f" providerId="ADAL" clId="{FEC9C214-E726-4192-8176-A8C9AACEB478}" dt="2025-05-16T05:43:36.510" v="126" actId="2696"/>
-        <pc:sldMkLst>
-          <pc:docMk/>
-          <pc:sldMk cId="3061130053" sldId="653"/>
-        </pc:sldMkLst>
-      </pc:sldChg>
-      <pc:sldChg chg="del">
-        <pc:chgData name="Mohammed Fasha" userId="cc64f42d-a1a6-4f08-b97b-0c37f877119f" providerId="ADAL" clId="{FEC9C214-E726-4192-8176-A8C9AACEB478}" dt="2025-05-16T05:43:36.510" v="126" actId="2696"/>
-        <pc:sldMkLst>
-          <pc:docMk/>
-          <pc:sldMk cId="3585687456" sldId="654"/>
-        </pc:sldMkLst>
-      </pc:sldChg>
-      <pc:sldChg chg="del">
-        <pc:chgData name="Mohammed Fasha" userId="cc64f42d-a1a6-4f08-b97b-0c37f877119f" providerId="ADAL" clId="{FEC9C214-E726-4192-8176-A8C9AACEB478}" dt="2025-05-16T05:43:36.510" v="126" actId="2696"/>
-        <pc:sldMkLst>
-          <pc:docMk/>
-          <pc:sldMk cId="2892622100" sldId="655"/>
-        </pc:sldMkLst>
-      </pc:sldChg>
-      <pc:sldChg chg="modSp del mod">
-        <pc:chgData name="Mohammed Fasha" userId="cc64f42d-a1a6-4f08-b97b-0c37f877119f" providerId="ADAL" clId="{FEC9C214-E726-4192-8176-A8C9AACEB478}" dt="2025-05-16T05:43:36.510" v="126" actId="2696"/>
-        <pc:sldMkLst>
-          <pc:docMk/>
-          <pc:sldMk cId="555764928" sldId="657"/>
-        </pc:sldMkLst>
-      </pc:sldChg>
-      <pc:sldChg chg="del">
-        <pc:chgData name="Mohammed Fasha" userId="cc64f42d-a1a6-4f08-b97b-0c37f877119f" providerId="ADAL" clId="{FEC9C214-E726-4192-8176-A8C9AACEB478}" dt="2025-05-16T05:43:36.510" v="126" actId="2696"/>
-        <pc:sldMkLst>
-          <pc:docMk/>
-          <pc:sldMk cId="1461426122" sldId="658"/>
-        </pc:sldMkLst>
-      </pc:sldChg>
-      <pc:sldChg chg="del">
-        <pc:chgData name="Mohammed Fasha" userId="cc64f42d-a1a6-4f08-b97b-0c37f877119f" providerId="ADAL" clId="{FEC9C214-E726-4192-8176-A8C9AACEB478}" dt="2025-05-16T05:43:36.510" v="126" actId="2696"/>
-        <pc:sldMkLst>
-          <pc:docMk/>
-          <pc:sldMk cId="2990045589" sldId="659"/>
-        </pc:sldMkLst>
-      </pc:sldChg>
-      <pc:sldChg chg="del">
-        <pc:chgData name="Mohammed Fasha" userId="cc64f42d-a1a6-4f08-b97b-0c37f877119f" providerId="ADAL" clId="{FEC9C214-E726-4192-8176-A8C9AACEB478}" dt="2025-05-16T05:43:36.510" v="126" actId="2696"/>
-        <pc:sldMkLst>
-          <pc:docMk/>
-          <pc:sldMk cId="2575039538" sldId="660"/>
-        </pc:sldMkLst>
-      </pc:sldChg>
-      <pc:sldChg chg="del">
-        <pc:chgData name="Mohammed Fasha" userId="cc64f42d-a1a6-4f08-b97b-0c37f877119f" providerId="ADAL" clId="{FEC9C214-E726-4192-8176-A8C9AACEB478}" dt="2025-05-16T05:43:36.510" v="126" actId="2696"/>
-        <pc:sldMkLst>
-          <pc:docMk/>
-          <pc:sldMk cId="1554491934" sldId="661"/>
-        </pc:sldMkLst>
-      </pc:sldChg>
-      <pc:sldChg chg="del">
-        <pc:chgData name="Mohammed Fasha" userId="cc64f42d-a1a6-4f08-b97b-0c37f877119f" providerId="ADAL" clId="{FEC9C214-E726-4192-8176-A8C9AACEB478}" dt="2025-05-16T05:43:36.510" v="126" actId="2696"/>
-        <pc:sldMkLst>
-          <pc:docMk/>
-          <pc:sldMk cId="691538069" sldId="662"/>
-        </pc:sldMkLst>
-      </pc:sldChg>
-      <pc:sldChg chg="del">
-        <pc:chgData name="Mohammed Fasha" userId="cc64f42d-a1a6-4f08-b97b-0c37f877119f" providerId="ADAL" clId="{FEC9C214-E726-4192-8176-A8C9AACEB478}" dt="2025-05-16T05:43:36.510" v="126" actId="2696"/>
-        <pc:sldMkLst>
-          <pc:docMk/>
-          <pc:sldMk cId="3980180774" sldId="663"/>
-        </pc:sldMkLst>
-      </pc:sldChg>
-      <pc:sldChg chg="del">
-        <pc:chgData name="Mohammed Fasha" userId="cc64f42d-a1a6-4f08-b97b-0c37f877119f" providerId="ADAL" clId="{FEC9C214-E726-4192-8176-A8C9AACEB478}" dt="2025-05-16T05:43:36.510" v="126" actId="2696"/>
-        <pc:sldMkLst>
-          <pc:docMk/>
-          <pc:sldMk cId="1728680596" sldId="664"/>
-        </pc:sldMkLst>
-      </pc:sldChg>
-      <pc:sldChg chg="del">
-        <pc:chgData name="Mohammed Fasha" userId="cc64f42d-a1a6-4f08-b97b-0c37f877119f" providerId="ADAL" clId="{FEC9C214-E726-4192-8176-A8C9AACEB478}" dt="2025-05-16T05:43:36.510" v="126" actId="2696"/>
-        <pc:sldMkLst>
-          <pc:docMk/>
-          <pc:sldMk cId="148099094" sldId="665"/>
-        </pc:sldMkLst>
-      </pc:sldChg>
-      <pc:sldChg chg="del">
-        <pc:chgData name="Mohammed Fasha" userId="cc64f42d-a1a6-4f08-b97b-0c37f877119f" providerId="ADAL" clId="{FEC9C214-E726-4192-8176-A8C9AACEB478}" dt="2025-05-16T05:43:36.510" v="126" actId="2696"/>
-        <pc:sldMkLst>
-          <pc:docMk/>
-          <pc:sldMk cId="898885298" sldId="667"/>
-        </pc:sldMkLst>
-      </pc:sldChg>
-      <pc:sldChg chg="del">
-        <pc:chgData name="Mohammed Fasha" userId="cc64f42d-a1a6-4f08-b97b-0c37f877119f" providerId="ADAL" clId="{FEC9C214-E726-4192-8176-A8C9AACEB478}" dt="2025-05-16T05:43:36.510" v="126" actId="2696"/>
-        <pc:sldMkLst>
-          <pc:docMk/>
-          <pc:sldMk cId="2652660250" sldId="668"/>
-        </pc:sldMkLst>
-      </pc:sldChg>
-      <pc:sldChg chg="del">
-        <pc:chgData name="Mohammed Fasha" userId="cc64f42d-a1a6-4f08-b97b-0c37f877119f" providerId="ADAL" clId="{FEC9C214-E726-4192-8176-A8C9AACEB478}" dt="2025-05-16T05:43:36.510" v="126" actId="2696"/>
-        <pc:sldMkLst>
-          <pc:docMk/>
-          <pc:sldMk cId="2680231355" sldId="669"/>
-        </pc:sldMkLst>
-      </pc:sldChg>
-      <pc:sldChg chg="modSp del mod">
-        <pc:chgData name="Mohammed Fasha" userId="cc64f42d-a1a6-4f08-b97b-0c37f877119f" providerId="ADAL" clId="{FEC9C214-E726-4192-8176-A8C9AACEB478}" dt="2025-05-16T05:43:36.510" v="126" actId="2696"/>
-        <pc:sldMkLst>
-          <pc:docMk/>
-          <pc:sldMk cId="1960150938" sldId="670"/>
-        </pc:sldMkLst>
-      </pc:sldChg>
-      <pc:sldChg chg="del">
-        <pc:chgData name="Mohammed Fasha" userId="cc64f42d-a1a6-4f08-b97b-0c37f877119f" providerId="ADAL" clId="{FEC9C214-E726-4192-8176-A8C9AACEB478}" dt="2025-05-16T05:43:36.510" v="126" actId="2696"/>
-        <pc:sldMkLst>
-          <pc:docMk/>
-          <pc:sldMk cId="3605011436" sldId="671"/>
-        </pc:sldMkLst>
-      </pc:sldChg>
-      <pc:sldChg chg="del">
-        <pc:chgData name="Mohammed Fasha" userId="cc64f42d-a1a6-4f08-b97b-0c37f877119f" providerId="ADAL" clId="{FEC9C214-E726-4192-8176-A8C9AACEB478}" dt="2025-05-16T05:43:36.510" v="126" actId="2696"/>
-        <pc:sldMkLst>
-          <pc:docMk/>
-          <pc:sldMk cId="1620993364" sldId="672"/>
-        </pc:sldMkLst>
-      </pc:sldChg>
-      <pc:sldChg chg="del">
-        <pc:chgData name="Mohammed Fasha" userId="cc64f42d-a1a6-4f08-b97b-0c37f877119f" providerId="ADAL" clId="{FEC9C214-E726-4192-8176-A8C9AACEB478}" dt="2025-05-16T05:43:36.510" v="126" actId="2696"/>
-        <pc:sldMkLst>
-          <pc:docMk/>
-          <pc:sldMk cId="2865119215" sldId="674"/>
-        </pc:sldMkLst>
-      </pc:sldChg>
-      <pc:sldChg chg="del">
-        <pc:chgData name="Mohammed Fasha" userId="cc64f42d-a1a6-4f08-b97b-0c37f877119f" providerId="ADAL" clId="{FEC9C214-E726-4192-8176-A8C9AACEB478}" dt="2025-05-16T05:43:36.510" v="126" actId="2696"/>
-        <pc:sldMkLst>
-          <pc:docMk/>
-          <pc:sldMk cId="2170303756" sldId="675"/>
-        </pc:sldMkLst>
-      </pc:sldChg>
-      <pc:sldChg chg="del">
-        <pc:chgData name="Mohammed Fasha" userId="cc64f42d-a1a6-4f08-b97b-0c37f877119f" providerId="ADAL" clId="{FEC9C214-E726-4192-8176-A8C9AACEB478}" dt="2025-05-16T05:43:36.510" v="126" actId="2696"/>
-        <pc:sldMkLst>
-          <pc:docMk/>
-          <pc:sldMk cId="1577854815" sldId="676"/>
-        </pc:sldMkLst>
-      </pc:sldChg>
-      <pc:sldChg chg="del">
-        <pc:chgData name="Mohammed Fasha" userId="cc64f42d-a1a6-4f08-b97b-0c37f877119f" providerId="ADAL" clId="{FEC9C214-E726-4192-8176-A8C9AACEB478}" dt="2025-05-16T05:43:36.510" v="126" actId="2696"/>
-        <pc:sldMkLst>
-          <pc:docMk/>
-          <pc:sldMk cId="139882925" sldId="677"/>
-        </pc:sldMkLst>
-      </pc:sldChg>
-      <pc:sldChg chg="del">
-        <pc:chgData name="Mohammed Fasha" userId="cc64f42d-a1a6-4f08-b97b-0c37f877119f" providerId="ADAL" clId="{FEC9C214-E726-4192-8176-A8C9AACEB478}" dt="2025-05-16T05:43:36.510" v="126" actId="2696"/>
-        <pc:sldMkLst>
-          <pc:docMk/>
-          <pc:sldMk cId="4146654093" sldId="678"/>
-        </pc:sldMkLst>
-      </pc:sldChg>
-      <pc:sldChg chg="del">
-        <pc:chgData name="Mohammed Fasha" userId="cc64f42d-a1a6-4f08-b97b-0c37f877119f" providerId="ADAL" clId="{FEC9C214-E726-4192-8176-A8C9AACEB478}" dt="2025-05-16T05:43:36.510" v="126" actId="2696"/>
-        <pc:sldMkLst>
-          <pc:docMk/>
-          <pc:sldMk cId="3454522070" sldId="679"/>
-        </pc:sldMkLst>
-      </pc:sldChg>
-      <pc:sldChg chg="del">
-        <pc:chgData name="Mohammed Fasha" userId="cc64f42d-a1a6-4f08-b97b-0c37f877119f" providerId="ADAL" clId="{FEC9C214-E726-4192-8176-A8C9AACEB478}" dt="2025-05-16T05:43:36.510" v="126" actId="2696"/>
-        <pc:sldMkLst>
-          <pc:docMk/>
-          <pc:sldMk cId="2856814121" sldId="681"/>
-        </pc:sldMkLst>
-      </pc:sldChg>
-      <pc:sldChg chg="del">
-        <pc:chgData name="Mohammed Fasha" userId="cc64f42d-a1a6-4f08-b97b-0c37f877119f" providerId="ADAL" clId="{FEC9C214-E726-4192-8176-A8C9AACEB478}" dt="2025-05-16T05:43:36.510" v="126" actId="2696"/>
-        <pc:sldMkLst>
-          <pc:docMk/>
-          <pc:sldMk cId="1377124484" sldId="682"/>
-        </pc:sldMkLst>
-      </pc:sldChg>
-      <pc:sldChg chg="del">
-        <pc:chgData name="Mohammed Fasha" userId="cc64f42d-a1a6-4f08-b97b-0c37f877119f" providerId="ADAL" clId="{FEC9C214-E726-4192-8176-A8C9AACEB478}" dt="2025-05-16T05:43:36.510" v="126" actId="2696"/>
-        <pc:sldMkLst>
-          <pc:docMk/>
-          <pc:sldMk cId="2630096202" sldId="683"/>
-        </pc:sldMkLst>
-      </pc:sldChg>
-      <pc:sldChg chg="del">
-        <pc:chgData name="Mohammed Fasha" userId="cc64f42d-a1a6-4f08-b97b-0c37f877119f" providerId="ADAL" clId="{FEC9C214-E726-4192-8176-A8C9AACEB478}" dt="2025-05-16T05:43:36.510" v="126" actId="2696"/>
-        <pc:sldMkLst>
-          <pc:docMk/>
-          <pc:sldMk cId="3328652623" sldId="684"/>
-        </pc:sldMkLst>
-      </pc:sldChg>
-      <pc:sldChg chg="del">
-        <pc:chgData name="Mohammed Fasha" userId="cc64f42d-a1a6-4f08-b97b-0c37f877119f" providerId="ADAL" clId="{FEC9C214-E726-4192-8176-A8C9AACEB478}" dt="2025-05-16T05:43:36.510" v="126" actId="2696"/>
-        <pc:sldMkLst>
-          <pc:docMk/>
-          <pc:sldMk cId="916102856" sldId="685"/>
-        </pc:sldMkLst>
-      </pc:sldChg>
-      <pc:sldChg chg="del">
-        <pc:chgData name="Mohammed Fasha" userId="cc64f42d-a1a6-4f08-b97b-0c37f877119f" providerId="ADAL" clId="{FEC9C214-E726-4192-8176-A8C9AACEB478}" dt="2025-05-16T05:43:36.510" v="126" actId="2696"/>
-        <pc:sldMkLst>
-          <pc:docMk/>
-          <pc:sldMk cId="2620697854" sldId="686"/>
-        </pc:sldMkLst>
-      </pc:sldChg>
-      <pc:sldChg chg="del">
-        <pc:chgData name="Mohammed Fasha" userId="cc64f42d-a1a6-4f08-b97b-0c37f877119f" providerId="ADAL" clId="{FEC9C214-E726-4192-8176-A8C9AACEB478}" dt="2025-05-16T05:43:36.510" v="126" actId="2696"/>
-        <pc:sldMkLst>
-          <pc:docMk/>
-          <pc:sldMk cId="140683555" sldId="687"/>
-        </pc:sldMkLst>
-      </pc:sldChg>
-      <pc:sldChg chg="del">
-        <pc:chgData name="Mohammed Fasha" userId="cc64f42d-a1a6-4f08-b97b-0c37f877119f" providerId="ADAL" clId="{FEC9C214-E726-4192-8176-A8C9AACEB478}" dt="2025-05-16T05:43:36.510" v="126" actId="2696"/>
-        <pc:sldMkLst>
-          <pc:docMk/>
-          <pc:sldMk cId="1788308240" sldId="688"/>
-        </pc:sldMkLst>
-      </pc:sldChg>
-      <pc:sldChg chg="del">
-        <pc:chgData name="Mohammed Fasha" userId="cc64f42d-a1a6-4f08-b97b-0c37f877119f" providerId="ADAL" clId="{FEC9C214-E726-4192-8176-A8C9AACEB478}" dt="2025-05-16T05:43:36.510" v="126" actId="2696"/>
-        <pc:sldMkLst>
-          <pc:docMk/>
-          <pc:sldMk cId="1660737293" sldId="689"/>
-        </pc:sldMkLst>
-      </pc:sldChg>
-      <pc:sldChg chg="del">
-        <pc:chgData name="Mohammed Fasha" userId="cc64f42d-a1a6-4f08-b97b-0c37f877119f" providerId="ADAL" clId="{FEC9C214-E726-4192-8176-A8C9AACEB478}" dt="2025-05-16T05:43:36.510" v="126" actId="2696"/>
-        <pc:sldMkLst>
-          <pc:docMk/>
-          <pc:sldMk cId="1987101698" sldId="690"/>
-        </pc:sldMkLst>
-      </pc:sldChg>
-      <pc:sldChg chg="del">
-        <pc:chgData name="Mohammed Fasha" userId="cc64f42d-a1a6-4f08-b97b-0c37f877119f" providerId="ADAL" clId="{FEC9C214-E726-4192-8176-A8C9AACEB478}" dt="2025-05-16T05:43:36.510" v="126" actId="2696"/>
-        <pc:sldMkLst>
-          <pc:docMk/>
-          <pc:sldMk cId="1982708772" sldId="692"/>
-        </pc:sldMkLst>
-      </pc:sldChg>
-      <pc:sldChg chg="del">
-        <pc:chgData name="Mohammed Fasha" userId="cc64f42d-a1a6-4f08-b97b-0c37f877119f" providerId="ADAL" clId="{FEC9C214-E726-4192-8176-A8C9AACEB478}" dt="2025-05-16T05:43:36.510" v="126" actId="2696"/>
-        <pc:sldMkLst>
-          <pc:docMk/>
-          <pc:sldMk cId="3424197979" sldId="694"/>
-        </pc:sldMkLst>
-      </pc:sldChg>
-      <pc:sldChg chg="del">
-        <pc:chgData name="Mohammed Fasha" userId="cc64f42d-a1a6-4f08-b97b-0c37f877119f" providerId="ADAL" clId="{FEC9C214-E726-4192-8176-A8C9AACEB478}" dt="2025-05-16T05:43:36.510" v="126" actId="2696"/>
-        <pc:sldMkLst>
-          <pc:docMk/>
-          <pc:sldMk cId="1697141369" sldId="695"/>
-        </pc:sldMkLst>
-      </pc:sldChg>
-      <pc:sldChg chg="del">
-        <pc:chgData name="Mohammed Fasha" userId="cc64f42d-a1a6-4f08-b97b-0c37f877119f" providerId="ADAL" clId="{FEC9C214-E726-4192-8176-A8C9AACEB478}" dt="2025-05-16T05:43:36.510" v="126" actId="2696"/>
-        <pc:sldMkLst>
-          <pc:docMk/>
-          <pc:sldMk cId="1317643237" sldId="696"/>
-        </pc:sldMkLst>
-      </pc:sldChg>
-      <pc:sldChg chg="del">
-        <pc:chgData name="Mohammed Fasha" userId="cc64f42d-a1a6-4f08-b97b-0c37f877119f" providerId="ADAL" clId="{FEC9C214-E726-4192-8176-A8C9AACEB478}" dt="2025-05-16T05:43:36.510" v="126" actId="2696"/>
-        <pc:sldMkLst>
-          <pc:docMk/>
-          <pc:sldMk cId="265576630" sldId="698"/>
-        </pc:sldMkLst>
-      </pc:sldChg>
-      <pc:sldChg chg="del">
-        <pc:chgData name="Mohammed Fasha" userId="cc64f42d-a1a6-4f08-b97b-0c37f877119f" providerId="ADAL" clId="{FEC9C214-E726-4192-8176-A8C9AACEB478}" dt="2025-05-16T05:43:36.510" v="126" actId="2696"/>
-        <pc:sldMkLst>
-          <pc:docMk/>
-          <pc:sldMk cId="4247717824" sldId="700"/>
-        </pc:sldMkLst>
-      </pc:sldChg>
-      <pc:sldChg chg="del">
-        <pc:chgData name="Mohammed Fasha" userId="cc64f42d-a1a6-4f08-b97b-0c37f877119f" providerId="ADAL" clId="{FEC9C214-E726-4192-8176-A8C9AACEB478}" dt="2025-05-16T05:43:36.510" v="126" actId="2696"/>
-        <pc:sldMkLst>
-          <pc:docMk/>
-          <pc:sldMk cId="3085160177" sldId="704"/>
-        </pc:sldMkLst>
-      </pc:sldChg>
-      <pc:sldChg chg="del">
-        <pc:chgData name="Mohammed Fasha" userId="cc64f42d-a1a6-4f08-b97b-0c37f877119f" providerId="ADAL" clId="{FEC9C214-E726-4192-8176-A8C9AACEB478}" dt="2025-05-16T05:43:36.510" v="126" actId="2696"/>
-        <pc:sldMkLst>
-          <pc:docMk/>
-          <pc:sldMk cId="1862107672" sldId="705"/>
-        </pc:sldMkLst>
-      </pc:sldChg>
-      <pc:sldChg chg="modSp del mod">
-        <pc:chgData name="Mohammed Fasha" userId="cc64f42d-a1a6-4f08-b97b-0c37f877119f" providerId="ADAL" clId="{FEC9C214-E726-4192-8176-A8C9AACEB478}" dt="2025-05-16T05:43:36.510" v="126" actId="2696"/>
-        <pc:sldMkLst>
-          <pc:docMk/>
-          <pc:sldMk cId="1142780366" sldId="706"/>
-        </pc:sldMkLst>
-      </pc:sldChg>
-      <pc:sldChg chg="del">
-        <pc:chgData name="Mohammed Fasha" userId="cc64f42d-a1a6-4f08-b97b-0c37f877119f" providerId="ADAL" clId="{FEC9C214-E726-4192-8176-A8C9AACEB478}" dt="2025-05-16T05:43:36.510" v="126" actId="2696"/>
-        <pc:sldMkLst>
-          <pc:docMk/>
-          <pc:sldMk cId="67871309" sldId="709"/>
-        </pc:sldMkLst>
-      </pc:sldChg>
-      <pc:sldChg chg="del">
-        <pc:chgData name="Mohammed Fasha" userId="cc64f42d-a1a6-4f08-b97b-0c37f877119f" providerId="ADAL" clId="{FEC9C214-E726-4192-8176-A8C9AACEB478}" dt="2025-05-16T05:43:36.510" v="126" actId="2696"/>
-        <pc:sldMkLst>
-          <pc:docMk/>
-          <pc:sldMk cId="4114896152" sldId="710"/>
-        </pc:sldMkLst>
-      </pc:sldChg>
-      <pc:sldChg chg="del">
-        <pc:chgData name="Mohammed Fasha" userId="cc64f42d-a1a6-4f08-b97b-0c37f877119f" providerId="ADAL" clId="{FEC9C214-E726-4192-8176-A8C9AACEB478}" dt="2025-05-16T05:43:36.510" v="126" actId="2696"/>
-        <pc:sldMkLst>
-          <pc:docMk/>
-          <pc:sldMk cId="3794385322" sldId="711"/>
-        </pc:sldMkLst>
-      </pc:sldChg>
-      <pc:sldChg chg="del">
-        <pc:chgData name="Mohammed Fasha" userId="cc64f42d-a1a6-4f08-b97b-0c37f877119f" providerId="ADAL" clId="{FEC9C214-E726-4192-8176-A8C9AACEB478}" dt="2025-05-16T05:43:36.510" v="126" actId="2696"/>
-        <pc:sldMkLst>
-          <pc:docMk/>
-          <pc:sldMk cId="3701206727" sldId="712"/>
-        </pc:sldMkLst>
-      </pc:sldChg>
-      <pc:sldChg chg="del">
-        <pc:chgData name="Mohammed Fasha" userId="cc64f42d-a1a6-4f08-b97b-0c37f877119f" providerId="ADAL" clId="{FEC9C214-E726-4192-8176-A8C9AACEB478}" dt="2025-05-16T05:43:36.510" v="126" actId="2696"/>
-        <pc:sldMkLst>
-          <pc:docMk/>
-          <pc:sldMk cId="1499972066" sldId="713"/>
-        </pc:sldMkLst>
-      </pc:sldChg>
-      <pc:sldChg chg="del">
-        <pc:chgData name="Mohammed Fasha" userId="cc64f42d-a1a6-4f08-b97b-0c37f877119f" providerId="ADAL" clId="{FEC9C214-E726-4192-8176-A8C9AACEB478}" dt="2025-05-16T05:43:36.510" v="126" actId="2696"/>
-        <pc:sldMkLst>
-          <pc:docMk/>
-          <pc:sldMk cId="1270641495" sldId="714"/>
-        </pc:sldMkLst>
-      </pc:sldChg>
-      <pc:sldChg chg="modSp del mod">
-        <pc:chgData name="Mohammed Fasha" userId="cc64f42d-a1a6-4f08-b97b-0c37f877119f" providerId="ADAL" clId="{FEC9C214-E726-4192-8176-A8C9AACEB478}" dt="2025-05-16T05:43:36.510" v="126" actId="2696"/>
-        <pc:sldMkLst>
-          <pc:docMk/>
-          <pc:sldMk cId="1096386322" sldId="715"/>
-        </pc:sldMkLst>
-      </pc:sldChg>
-      <pc:sldChg chg="modSp del mod">
-        <pc:chgData name="Mohammed Fasha" userId="cc64f42d-a1a6-4f08-b97b-0c37f877119f" providerId="ADAL" clId="{FEC9C214-E726-4192-8176-A8C9AACEB478}" dt="2025-05-16T05:43:36.510" v="126" actId="2696"/>
-        <pc:sldMkLst>
-          <pc:docMk/>
-          <pc:sldMk cId="1784058309" sldId="716"/>
-        </pc:sldMkLst>
-      </pc:sldChg>
-      <pc:sldChg chg="modSp del mod">
-        <pc:chgData name="Mohammed Fasha" userId="cc64f42d-a1a6-4f08-b97b-0c37f877119f" providerId="ADAL" clId="{FEC9C214-E726-4192-8176-A8C9AACEB478}" dt="2025-05-16T05:43:36.510" v="126" actId="2696"/>
-        <pc:sldMkLst>
-          <pc:docMk/>
-          <pc:sldMk cId="3139017106" sldId="717"/>
-        </pc:sldMkLst>
-      </pc:sldChg>
-      <pc:sldChg chg="del">
-        <pc:chgData name="Mohammed Fasha" userId="cc64f42d-a1a6-4f08-b97b-0c37f877119f" providerId="ADAL" clId="{FEC9C214-E726-4192-8176-A8C9AACEB478}" dt="2025-05-16T05:43:36.510" v="126" actId="2696"/>
-        <pc:sldMkLst>
-          <pc:docMk/>
-          <pc:sldMk cId="3043812923" sldId="718"/>
-        </pc:sldMkLst>
-      </pc:sldChg>
-      <pc:sldChg chg="modSp del mod">
-        <pc:chgData name="Mohammed Fasha" userId="cc64f42d-a1a6-4f08-b97b-0c37f877119f" providerId="ADAL" clId="{FEC9C214-E726-4192-8176-A8C9AACEB478}" dt="2025-05-12T03:04:56.963" v="45" actId="2696"/>
-        <pc:sldMkLst>
-          <pc:docMk/>
-          <pc:sldMk cId="666527140" sldId="725"/>
-        </pc:sldMkLst>
-      </pc:sldChg>
-      <pc:sldChg chg="add del">
-        <pc:chgData name="Mohammed Fasha" userId="cc64f42d-a1a6-4f08-b97b-0c37f877119f" providerId="ADAL" clId="{FEC9C214-E726-4192-8176-A8C9AACEB478}" dt="2025-05-16T05:43:36.510" v="126" actId="2696"/>
-        <pc:sldMkLst>
-          <pc:docMk/>
-          <pc:sldMk cId="2280465272" sldId="725"/>
-        </pc:sldMkLst>
-      </pc:sldChg>
-      <pc:sldChg chg="del">
-        <pc:chgData name="Mohammed Fasha" userId="cc64f42d-a1a6-4f08-b97b-0c37f877119f" providerId="ADAL" clId="{FEC9C214-E726-4192-8176-A8C9AACEB478}" dt="2025-05-16T05:43:36.510" v="126" actId="2696"/>
-        <pc:sldMkLst>
-          <pc:docMk/>
-          <pc:sldMk cId="3660604927" sldId="726"/>
-        </pc:sldMkLst>
-      </pc:sldChg>
-      <pc:sldChg chg="del">
-        <pc:chgData name="Mohammed Fasha" userId="cc64f42d-a1a6-4f08-b97b-0c37f877119f" providerId="ADAL" clId="{FEC9C214-E726-4192-8176-A8C9AACEB478}" dt="2025-05-16T05:43:36.510" v="126" actId="2696"/>
-        <pc:sldMkLst>
-          <pc:docMk/>
-          <pc:sldMk cId="4051640529" sldId="728"/>
-        </pc:sldMkLst>
-      </pc:sldChg>
-      <pc:sldChg chg="modSp new del mod">
-        <pc:chgData name="Mohammed Fasha" userId="cc64f42d-a1a6-4f08-b97b-0c37f877119f" providerId="ADAL" clId="{FEC9C214-E726-4192-8176-A8C9AACEB478}" dt="2025-05-12T03:11:40.927" v="51" actId="47"/>
-        <pc:sldMkLst>
-          <pc:docMk/>
-          <pc:sldMk cId="1223704259" sldId="729"/>
-        </pc:sldMkLst>
-      </pc:sldChg>
-      <pc:sldChg chg="add del">
-        <pc:chgData name="Mohammed Fasha" userId="cc64f42d-a1a6-4f08-b97b-0c37f877119f" providerId="ADAL" clId="{FEC9C214-E726-4192-8176-A8C9AACEB478}" dt="2025-05-12T03:06:57.298" v="49"/>
-        <pc:sldMkLst>
-          <pc:docMk/>
-          <pc:sldMk cId="3927078588" sldId="730"/>
-        </pc:sldMkLst>
-      </pc:sldChg>
-    </pc:docChg>
-  </pc:docChgLst>
-  <pc:docChgLst>
-    <pc:chgData name="Mohammed Fasha" userId="cc64f42d-a1a6-4f08-b97b-0c37f877119f" providerId="ADAL" clId="{2E5FBF59-3168-4932-9518-582502FE1AD5}"/>
-    <pc:docChg chg="undo custSel delSld modSld">
-      <pc:chgData name="Mohammed Fasha" userId="cc64f42d-a1a6-4f08-b97b-0c37f877119f" providerId="ADAL" clId="{2E5FBF59-3168-4932-9518-582502FE1AD5}" dt="2024-12-24T08:08:19.987" v="550" actId="20577"/>
-      <pc:docMkLst>
-        <pc:docMk/>
-      </pc:docMkLst>
-      <pc:sldChg chg="delSp">
-        <pc:chgData name="Mohammed Fasha" userId="cc64f42d-a1a6-4f08-b97b-0c37f877119f" providerId="ADAL" clId="{2E5FBF59-3168-4932-9518-582502FE1AD5}" dt="2024-11-19T07:40:47.121" v="208" actId="478"/>
-        <pc:sldMkLst>
-          <pc:docMk/>
-          <pc:sldMk cId="391491219" sldId="428"/>
-        </pc:sldMkLst>
-      </pc:sldChg>
-      <pc:sldChg chg="modSp">
-        <pc:chgData name="Mohammed Fasha" userId="cc64f42d-a1a6-4f08-b97b-0c37f877119f" providerId="ADAL" clId="{2E5FBF59-3168-4932-9518-582502FE1AD5}" dt="2024-12-03T07:43:58.007" v="456" actId="1076"/>
-        <pc:sldMkLst>
-          <pc:docMk/>
-          <pc:sldMk cId="3339445507" sldId="430"/>
-        </pc:sldMkLst>
-      </pc:sldChg>
-      <pc:sldChg chg="modSp">
-        <pc:chgData name="Mohammed Fasha" userId="cc64f42d-a1a6-4f08-b97b-0c37f877119f" providerId="ADAL" clId="{2E5FBF59-3168-4932-9518-582502FE1AD5}" dt="2024-12-03T07:45:08.136" v="474" actId="20577"/>
-        <pc:sldMkLst>
-          <pc:docMk/>
-          <pc:sldMk cId="3389046835" sldId="431"/>
-        </pc:sldMkLst>
-      </pc:sldChg>
-      <pc:sldChg chg="modSp">
-        <pc:chgData name="Mohammed Fasha" userId="cc64f42d-a1a6-4f08-b97b-0c37f877119f" providerId="ADAL" clId="{2E5FBF59-3168-4932-9518-582502FE1AD5}" dt="2024-11-10T06:33:09.727" v="37" actId="207"/>
-        <pc:sldMkLst>
-          <pc:docMk/>
-          <pc:sldMk cId="2726994946" sldId="479"/>
-        </pc:sldMkLst>
-      </pc:sldChg>
-      <pc:sldChg chg="modSp">
-        <pc:chgData name="Mohammed Fasha" userId="cc64f42d-a1a6-4f08-b97b-0c37f877119f" providerId="ADAL" clId="{2E5FBF59-3168-4932-9518-582502FE1AD5}" dt="2024-11-19T07:44:28.766" v="211" actId="20577"/>
-        <pc:sldMkLst>
-          <pc:docMk/>
-          <pc:sldMk cId="2297456757" sldId="483"/>
-        </pc:sldMkLst>
-      </pc:sldChg>
-      <pc:sldChg chg="modSp">
-        <pc:chgData name="Mohammed Fasha" userId="cc64f42d-a1a6-4f08-b97b-0c37f877119f" providerId="ADAL" clId="{2E5FBF59-3168-4932-9518-582502FE1AD5}" dt="2024-11-10T06:45:09.392" v="40" actId="20577"/>
-        <pc:sldMkLst>
-          <pc:docMk/>
-          <pc:sldMk cId="3474268344" sldId="596"/>
-        </pc:sldMkLst>
-      </pc:sldChg>
-      <pc:sldChg chg="modSp">
-        <pc:chgData name="Mohammed Fasha" userId="cc64f42d-a1a6-4f08-b97b-0c37f877119f" providerId="ADAL" clId="{2E5FBF59-3168-4932-9518-582502FE1AD5}" dt="2024-12-03T07:47:21.561" v="476" actId="6549"/>
-        <pc:sldMkLst>
-          <pc:docMk/>
-          <pc:sldMk cId="399592497" sldId="613"/>
-        </pc:sldMkLst>
-      </pc:sldChg>
-      <pc:sldChg chg="modSp">
-        <pc:chgData name="Mohammed Fasha" userId="cc64f42d-a1a6-4f08-b97b-0c37f877119f" providerId="ADAL" clId="{2E5FBF59-3168-4932-9518-582502FE1AD5}" dt="2024-12-03T07:49:02.980" v="478" actId="207"/>
-        <pc:sldMkLst>
-          <pc:docMk/>
-          <pc:sldMk cId="3329135496" sldId="617"/>
-        </pc:sldMkLst>
-      </pc:sldChg>
-      <pc:sldChg chg="modSp">
-        <pc:chgData name="Mohammed Fasha" userId="cc64f42d-a1a6-4f08-b97b-0c37f877119f" providerId="ADAL" clId="{2E5FBF59-3168-4932-9518-582502FE1AD5}" dt="2024-12-24T08:05:16.608" v="482" actId="403"/>
-        <pc:sldMkLst>
-          <pc:docMk/>
-          <pc:sldMk cId="2990045589" sldId="659"/>
-        </pc:sldMkLst>
-      </pc:sldChg>
-      <pc:sldChg chg="modSp">
-        <pc:chgData name="Mohammed Fasha" userId="cc64f42d-a1a6-4f08-b97b-0c37f877119f" providerId="ADAL" clId="{2E5FBF59-3168-4932-9518-582502FE1AD5}" dt="2024-12-24T08:08:19.987" v="550" actId="20577"/>
-        <pc:sldMkLst>
-          <pc:docMk/>
-          <pc:sldMk cId="2680231355" sldId="669"/>
-        </pc:sldMkLst>
-      </pc:sldChg>
-      <pc:sldChg chg="addSp modSp">
-        <pc:chgData name="Mohammed Fasha" userId="cc64f42d-a1a6-4f08-b97b-0c37f877119f" providerId="ADAL" clId="{2E5FBF59-3168-4932-9518-582502FE1AD5}" dt="2024-12-24T08:05:52.910" v="488" actId="1076"/>
-        <pc:sldMkLst>
-          <pc:docMk/>
-          <pc:sldMk cId="916102856" sldId="685"/>
-        </pc:sldMkLst>
-      </pc:sldChg>
-      <pc:sldChg chg="modSp">
-        <pc:chgData name="Mohammed Fasha" userId="cc64f42d-a1a6-4f08-b97b-0c37f877119f" providerId="ADAL" clId="{2E5FBF59-3168-4932-9518-582502FE1AD5}" dt="2024-11-19T07:03:29.557" v="206" actId="207"/>
-        <pc:sldMkLst>
-          <pc:docMk/>
-          <pc:sldMk cId="32004852" sldId="708"/>
-        </pc:sldMkLst>
-      </pc:sldChg>
-    </pc:docChg>
-  </pc:docChgLst>
-  <pc:docChgLst>
-    <pc:chgData name="Mohammed Fasha" userId="cc64f42d-a1a6-4f08-b97b-0c37f877119f" providerId="ADAL" clId="{25C05559-E4DC-4EE1-91BC-1444D09EE869}"/>
-    <pc:docChg chg="undo custSel addSld delSld modSld sldOrd">
-      <pc:chgData name="Mohammed Fasha" userId="cc64f42d-a1a6-4f08-b97b-0c37f877119f" providerId="ADAL" clId="{25C05559-E4DC-4EE1-91BC-1444D09EE869}" dt="2025-04-30T07:51:18.812" v="264" actId="47"/>
-      <pc:docMkLst>
-        <pc:docMk/>
-      </pc:docMkLst>
-      <pc:sldChg chg="modSp mod">
-        <pc:chgData name="Mohammed Fasha" userId="cc64f42d-a1a6-4f08-b97b-0c37f877119f" providerId="ADAL" clId="{25C05559-E4DC-4EE1-91BC-1444D09EE869}" dt="2025-04-16T06:14:55.232" v="16" actId="1076"/>
-        <pc:sldMkLst>
-          <pc:docMk/>
-          <pc:sldMk cId="1499958888" sldId="394"/>
-        </pc:sldMkLst>
-      </pc:sldChg>
-      <pc:sldChg chg="delSp modSp mod delAnim">
-        <pc:chgData name="Mohammed Fasha" userId="cc64f42d-a1a6-4f08-b97b-0c37f877119f" providerId="ADAL" clId="{25C05559-E4DC-4EE1-91BC-1444D09EE869}" dt="2025-04-16T06:43:36.666" v="20" actId="478"/>
-        <pc:sldMkLst>
-          <pc:docMk/>
-          <pc:sldMk cId="2905491798" sldId="440"/>
-        </pc:sldMkLst>
-      </pc:sldChg>
-      <pc:sldChg chg="modSp mod">
-        <pc:chgData name="Mohammed Fasha" userId="cc64f42d-a1a6-4f08-b97b-0c37f877119f" providerId="ADAL" clId="{25C05559-E4DC-4EE1-91BC-1444D09EE869}" dt="2025-04-09T06:23:26.187" v="0" actId="20577"/>
-        <pc:sldMkLst>
-          <pc:docMk/>
-          <pc:sldMk cId="2297456757" sldId="483"/>
-        </pc:sldMkLst>
-        <pc:spChg chg="mod">
-          <ac:chgData name="Mohammed Fasha" userId="cc64f42d-a1a6-4f08-b97b-0c37f877119f" providerId="ADAL" clId="{25C05559-E4DC-4EE1-91BC-1444D09EE869}" dt="2025-04-09T06:23:26.187" v="0" actId="20577"/>
-          <ac:spMkLst>
-            <pc:docMk/>
-            <pc:sldMk cId="2297456757" sldId="483"/>
-            <ac:spMk id="5" creationId="{89403830-E271-DAA0-8838-E295A84A8B5B}"/>
-          </ac:spMkLst>
-        </pc:spChg>
-      </pc:sldChg>
-      <pc:sldChg chg="ord">
-        <pc:chgData name="Mohammed Fasha" userId="cc64f42d-a1a6-4f08-b97b-0c37f877119f" providerId="ADAL" clId="{25C05559-E4DC-4EE1-91BC-1444D09EE869}" dt="2025-04-16T06:46:21.733" v="23" actId="20578"/>
-        <pc:sldMkLst>
-          <pc:docMk/>
-          <pc:sldMk cId="3480194047" sldId="599"/>
-        </pc:sldMkLst>
-      </pc:sldChg>
-      <pc:sldChg chg="modSp mod">
-        <pc:chgData name="Mohammed Fasha" userId="cc64f42d-a1a6-4f08-b97b-0c37f877119f" providerId="ADAL" clId="{25C05559-E4DC-4EE1-91BC-1444D09EE869}" dt="2025-04-16T06:46:47.902" v="27" actId="404"/>
-        <pc:sldMkLst>
-          <pc:docMk/>
-          <pc:sldMk cId="3146452721" sldId="600"/>
-        </pc:sldMkLst>
-      </pc:sldChg>
-      <pc:sldChg chg="delSp mod">
-        <pc:chgData name="Mohammed Fasha" userId="cc64f42d-a1a6-4f08-b97b-0c37f877119f" providerId="ADAL" clId="{25C05559-E4DC-4EE1-91BC-1444D09EE869}" dt="2025-04-16T06:47:57.131" v="35" actId="21"/>
-        <pc:sldMkLst>
-          <pc:docMk/>
-          <pc:sldMk cId="202107314" sldId="647"/>
-        </pc:sldMkLst>
-      </pc:sldChg>
-      <pc:sldChg chg="modSp mod">
-        <pc:chgData name="Mohammed Fasha" userId="cc64f42d-a1a6-4f08-b97b-0c37f877119f" providerId="ADAL" clId="{25C05559-E4DC-4EE1-91BC-1444D09EE869}" dt="2025-04-16T06:48:42.467" v="40" actId="14100"/>
-        <pc:sldMkLst>
-          <pc:docMk/>
-          <pc:sldMk cId="3454522070" sldId="679"/>
-        </pc:sldMkLst>
-      </pc:sldChg>
-      <pc:sldChg chg="modSp mod">
-        <pc:chgData name="Mohammed Fasha" userId="cc64f42d-a1a6-4f08-b97b-0c37f877119f" providerId="ADAL" clId="{25C05559-E4DC-4EE1-91BC-1444D09EE869}" dt="2025-04-16T06:49:10.468" v="48" actId="404"/>
-        <pc:sldMkLst>
-          <pc:docMk/>
-          <pc:sldMk cId="2856814121" sldId="681"/>
-        </pc:sldMkLst>
-      </pc:sldChg>
-      <pc:sldChg chg="modSp mod">
-        <pc:chgData name="Mohammed Fasha" userId="cc64f42d-a1a6-4f08-b97b-0c37f877119f" providerId="ADAL" clId="{25C05559-E4DC-4EE1-91BC-1444D09EE869}" dt="2025-04-16T06:48:55.287" v="46" actId="27636"/>
-        <pc:sldMkLst>
-          <pc:docMk/>
-          <pc:sldMk cId="265576630" sldId="698"/>
-        </pc:sldMkLst>
-      </pc:sldChg>
-      <pc:sldChg chg="modSp">
-        <pc:chgData name="Mohammed Fasha" userId="cc64f42d-a1a6-4f08-b97b-0c37f877119f" providerId="ADAL" clId="{25C05559-E4DC-4EE1-91BC-1444D09EE869}" dt="2025-04-16T06:48:02.658" v="36" actId="1076"/>
-        <pc:sldMkLst>
-          <pc:docMk/>
-          <pc:sldMk cId="3085160177" sldId="704"/>
-        </pc:sldMkLst>
-      </pc:sldChg>
-      <pc:sldChg chg="modSp mod">
-        <pc:chgData name="Mohammed Fasha" userId="cc64f42d-a1a6-4f08-b97b-0c37f877119f" providerId="ADAL" clId="{25C05559-E4DC-4EE1-91BC-1444D09EE869}" dt="2025-04-16T06:47:18.630" v="34" actId="1076"/>
-        <pc:sldMkLst>
-          <pc:docMk/>
-          <pc:sldMk cId="32004852" sldId="708"/>
-        </pc:sldMkLst>
-      </pc:sldChg>
-      <pc:sldChg chg="addSp delSp modSp mod">
-        <pc:chgData name="Mohammed Fasha" userId="cc64f42d-a1a6-4f08-b97b-0c37f877119f" providerId="ADAL" clId="{25C05559-E4DC-4EE1-91BC-1444D09EE869}" dt="2025-04-16T06:14:10.424" v="11" actId="167"/>
-        <pc:sldMkLst>
-          <pc:docMk/>
-          <pc:sldMk cId="3150550060" sldId="720"/>
-        </pc:sldMkLst>
-      </pc:sldChg>
-      <pc:sldChg chg="addSp modSp new mod">
-        <pc:chgData name="Mohammed Fasha" userId="cc64f42d-a1a6-4f08-b97b-0c37f877119f" providerId="ADAL" clId="{25C05559-E4DC-4EE1-91BC-1444D09EE869}" dt="2025-04-30T06:40:50.224" v="212" actId="6549"/>
-        <pc:sldMkLst>
-          <pc:docMk/>
-          <pc:sldMk cId="666527140" sldId="725"/>
-        </pc:sldMkLst>
-      </pc:sldChg>
-      <pc:sldChg chg="addSp delSp modSp new mod">
-        <pc:chgData name="Mohammed Fasha" userId="cc64f42d-a1a6-4f08-b97b-0c37f877119f" providerId="ADAL" clId="{25C05559-E4DC-4EE1-91BC-1444D09EE869}" dt="2025-04-30T07:05:36.135" v="263" actId="122"/>
-        <pc:sldMkLst>
-          <pc:docMk/>
-          <pc:sldMk cId="3660604927" sldId="726"/>
-        </pc:sldMkLst>
-      </pc:sldChg>
-      <pc:sldChg chg="add del">
-        <pc:chgData name="Mohammed Fasha" userId="cc64f42d-a1a6-4f08-b97b-0c37f877119f" providerId="ADAL" clId="{25C05559-E4DC-4EE1-91BC-1444D09EE869}" dt="2025-04-30T07:51:18.812" v="264" actId="47"/>
-        <pc:sldMkLst>
-          <pc:docMk/>
-          <pc:sldMk cId="2399550384" sldId="727"/>
-        </pc:sldMkLst>
-      </pc:sldChg>
-      <pc:sldChg chg="modSp add mod ord">
-        <pc:chgData name="Mohammed Fasha" userId="cc64f42d-a1a6-4f08-b97b-0c37f877119f" providerId="ADAL" clId="{25C05559-E4DC-4EE1-91BC-1444D09EE869}" dt="2025-04-30T06:47:23.280" v="238" actId="20577"/>
-        <pc:sldMkLst>
-          <pc:docMk/>
-          <pc:sldMk cId="4051640529" sldId="728"/>
-        </pc:sldMkLst>
-      </pc:sldChg>
-    </pc:docChg>
-  </pc:docChgLst>
-  <pc:docChgLst>
-    <pc:chgData name="Mohammed Fasha" userId="cc64f42d-a1a6-4f08-b97b-0c37f877119f" providerId="ADAL" clId="{6804A8E6-8D7F-46E3-B091-66A8F6B926BF}"/>
-    <pc:docChg chg="custSel modMainMaster">
-      <pc:chgData name="Mohammed Fasha" userId="cc64f42d-a1a6-4f08-b97b-0c37f877119f" providerId="ADAL" clId="{6804A8E6-8D7F-46E3-B091-66A8F6B926BF}" dt="2024-11-09T05:15:35.019" v="2" actId="1076"/>
-      <pc:docMkLst>
-        <pc:docMk/>
-      </pc:docMkLst>
-      <pc:sldMasterChg chg="delSp mod modSldLayout">
-        <pc:chgData name="Mohammed Fasha" userId="cc64f42d-a1a6-4f08-b97b-0c37f877119f" providerId="ADAL" clId="{6804A8E6-8D7F-46E3-B091-66A8F6B926BF}" dt="2024-11-09T05:15:35.019" v="2" actId="1076"/>
-        <pc:sldMasterMkLst>
-          <pc:docMk/>
-          <pc:sldMasterMk cId="742811419" sldId="2147483648"/>
-        </pc:sldMasterMkLst>
-        <pc:sldLayoutChg chg="addSp modSp mod">
-          <pc:chgData name="Mohammed Fasha" userId="cc64f42d-a1a6-4f08-b97b-0c37f877119f" providerId="ADAL" clId="{6804A8E6-8D7F-46E3-B091-66A8F6B926BF}" dt="2024-11-09T05:15:35.019" v="2" actId="1076"/>
-          <pc:sldLayoutMkLst>
-            <pc:docMk/>
-            <pc:sldMasterMk cId="742811419" sldId="2147483648"/>
-            <pc:sldLayoutMk cId="4063788262" sldId="2147483649"/>
-          </pc:sldLayoutMkLst>
         </pc:sldLayoutChg>
       </pc:sldMasterChg>
     </pc:docChg>
@@ -3118,7 +3258,7 @@
           <a:p>
             <a:fld id="{13BA03A4-B9F1-404C-8A74-B1AFD6480953}" type="datetimeFigureOut">
               <a:rPr lang="en-US" smtClean="0"/>
-              <a:t>6/7/2025</a:t>
+              <a:t>6/18/2025</a:t>
             </a:fld>
             <a:endParaRPr lang="en-US"/>
           </a:p>
@@ -3616,7 +3756,7 @@
           <a:p>
             <a:fld id="{0DB78E95-DE77-44D3-BDB9-E242948FB112}" type="datetimeFigureOut">
               <a:rPr lang="en-US" smtClean="0"/>
-              <a:t>6/7/2025</a:t>
+              <a:t>6/18/2025</a:t>
             </a:fld>
             <a:endParaRPr lang="en-US"/>
           </a:p>
@@ -3844,7 +3984,7 @@
           <a:p>
             <a:fld id="{0DB78E95-DE77-44D3-BDB9-E242948FB112}" type="datetimeFigureOut">
               <a:rPr lang="en-US" smtClean="0"/>
-              <a:t>6/7/2025</a:t>
+              <a:t>6/18/2025</a:t>
             </a:fld>
             <a:endParaRPr lang="en-US"/>
           </a:p>
@@ -4052,7 +4192,7 @@
           <a:p>
             <a:fld id="{0DB78E95-DE77-44D3-BDB9-E242948FB112}" type="datetimeFigureOut">
               <a:rPr lang="en-US" smtClean="0"/>
-              <a:t>6/7/2025</a:t>
+              <a:t>6/18/2025</a:t>
             </a:fld>
             <a:endParaRPr lang="en-US"/>
           </a:p>
@@ -4483,7 +4623,7 @@
           <a:p>
             <a:fld id="{0DB78E95-DE77-44D3-BDB9-E242948FB112}" type="datetimeFigureOut">
               <a:rPr lang="en-US" smtClean="0"/>
-              <a:t>6/7/2025</a:t>
+              <a:t>6/18/2025</a:t>
             </a:fld>
             <a:endParaRPr lang="en-US"/>
           </a:p>
@@ -4862,7 +5002,7 @@
           <a:p>
             <a:fld id="{0DB78E95-DE77-44D3-BDB9-E242948FB112}" type="datetimeFigureOut">
               <a:rPr lang="en-US" smtClean="0"/>
-              <a:t>6/7/2025</a:t>
+              <a:t>6/18/2025</a:t>
             </a:fld>
             <a:endParaRPr lang="en-US"/>
           </a:p>
@@ -5274,7 +5414,7 @@
           <a:p>
             <a:fld id="{0DB78E95-DE77-44D3-BDB9-E242948FB112}" type="datetimeFigureOut">
               <a:rPr lang="en-US" smtClean="0"/>
-              <a:t>6/7/2025</a:t>
+              <a:t>6/18/2025</a:t>
             </a:fld>
             <a:endParaRPr lang="en-US"/>
           </a:p>
@@ -5415,7 +5555,7 @@
           <a:p>
             <a:fld id="{0DB78E95-DE77-44D3-BDB9-E242948FB112}" type="datetimeFigureOut">
               <a:rPr lang="en-US" smtClean="0"/>
-              <a:t>6/7/2025</a:t>
+              <a:t>6/18/2025</a:t>
             </a:fld>
             <a:endParaRPr lang="en-US"/>
           </a:p>
@@ -5528,7 +5668,7 @@
           <a:p>
             <a:fld id="{0DB78E95-DE77-44D3-BDB9-E242948FB112}" type="datetimeFigureOut">
               <a:rPr lang="en-US" smtClean="0"/>
-              <a:t>6/7/2025</a:t>
+              <a:t>6/18/2025</a:t>
             </a:fld>
             <a:endParaRPr lang="en-US"/>
           </a:p>
@@ -5839,7 +5979,7 @@
           <a:p>
             <a:fld id="{0DB78E95-DE77-44D3-BDB9-E242948FB112}" type="datetimeFigureOut">
               <a:rPr lang="en-US" smtClean="0"/>
-              <a:t>6/7/2025</a:t>
+              <a:t>6/18/2025</a:t>
             </a:fld>
             <a:endParaRPr lang="en-US"/>
           </a:p>
@@ -6127,7 +6267,7 @@
           <a:p>
             <a:fld id="{0DB78E95-DE77-44D3-BDB9-E242948FB112}" type="datetimeFigureOut">
               <a:rPr lang="en-US" smtClean="0"/>
-              <a:t>6/7/2025</a:t>
+              <a:t>6/18/2025</a:t>
             </a:fld>
             <a:endParaRPr lang="en-US"/>
           </a:p>
@@ -6368,7 +6508,7 @@
           <a:p>
             <a:fld id="{0DB78E95-DE77-44D3-BDB9-E242948FB112}" type="datetimeFigureOut">
               <a:rPr lang="en-US" smtClean="0"/>
-              <a:t>6/7/2025</a:t>
+              <a:t>6/18/2025</a:t>
             </a:fld>
             <a:endParaRPr lang="en-US"/>
           </a:p>
@@ -7019,6 +7159,800 @@
           <p:cNvPr id="2" name="Title 1">
             <a:extLst>
               <a:ext uri="{FF2B5EF4-FFF2-40B4-BE49-F238E27FC236}">
+                <a16:creationId xmlns:a16="http://schemas.microsoft.com/office/drawing/2014/main" id="{1462616C-41EE-2B5B-760C-E900F7CFDE29}"/>
+              </a:ext>
+            </a:extLst>
+          </p:cNvPr>
+          <p:cNvSpPr>
+            <a:spLocks noGrp="1"/>
+          </p:cNvSpPr>
+          <p:nvPr>
+            <p:ph type="title"/>
+          </p:nvPr>
+        </p:nvSpPr>
+        <p:spPr/>
+        <p:txBody>
+          <a:bodyPr/>
+          <a:lstStyle/>
+          <a:p>
+            <a:r>
+              <a:rPr lang="en-US" dirty="0">
+                <a:ea typeface="Calibri Light"/>
+                <a:cs typeface="Calibri Light"/>
+              </a:rPr>
+              <a:t>The Importance of Confidence, Direction Matters</a:t>
+            </a:r>
+            <a:endParaRPr lang="en-US" dirty="0"/>
+          </a:p>
+        </p:txBody>
+      </p:sp>
+      <p:graphicFrame>
+        <p:nvGraphicFramePr>
+          <p:cNvPr id="5" name="Content Placeholder 4">
+            <a:extLst>
+              <a:ext uri="{FF2B5EF4-FFF2-40B4-BE49-F238E27FC236}">
+                <a16:creationId xmlns:a16="http://schemas.microsoft.com/office/drawing/2014/main" id="{D986A135-B943-08AB-BF49-B8AFBFF1A02E}"/>
+              </a:ext>
+            </a:extLst>
+          </p:cNvPr>
+          <p:cNvGraphicFramePr>
+            <a:graphicFrameLocks noGrp="1"/>
+          </p:cNvGraphicFramePr>
+          <p:nvPr>
+            <p:ph idx="1"/>
+            <p:extLst>
+              <p:ext uri="{D42A27DB-BD31-4B8C-83A1-F6EECF244321}">
+                <p14:modId xmlns:p14="http://schemas.microsoft.com/office/powerpoint/2010/main" val="4160585547"/>
+              </p:ext>
+            </p:extLst>
+          </p:nvPr>
+        </p:nvGraphicFramePr>
+        <p:xfrm>
+          <a:off x="838200" y="1706563"/>
+          <a:ext cx="10515599" cy="4450080"/>
+        </p:xfrm>
+        <a:graphic>
+          <a:graphicData uri="http://schemas.openxmlformats.org/drawingml/2006/table">
+            <a:tbl>
+              <a:tblPr bandRow="1">
+                <a:tableStyleId>{5940675A-B579-460E-94D1-54222C63F5DA}</a:tableStyleId>
+              </a:tblPr>
+              <a:tblGrid>
+                <a:gridCol w="1898468">
+                  <a:extLst>
+                    <a:ext uri="{9D8B030D-6E8A-4147-A177-3AD203B41FA5}">
+                      <a16:colId xmlns:a16="http://schemas.microsoft.com/office/drawing/2014/main" val="1099920249"/>
+                    </a:ext>
+                  </a:extLst>
+                </a:gridCol>
+                <a:gridCol w="3359331">
+                  <a:extLst>
+                    <a:ext uri="{9D8B030D-6E8A-4147-A177-3AD203B41FA5}">
+                      <a16:colId xmlns:a16="http://schemas.microsoft.com/office/drawing/2014/main" val="4200357428"/>
+                    </a:ext>
+                  </a:extLst>
+                </a:gridCol>
+                <a:gridCol w="2628900">
+                  <a:extLst>
+                    <a:ext uri="{9D8B030D-6E8A-4147-A177-3AD203B41FA5}">
+                      <a16:colId xmlns:a16="http://schemas.microsoft.com/office/drawing/2014/main" val="2556761527"/>
+                    </a:ext>
+                  </a:extLst>
+                </a:gridCol>
+                <a:gridCol w="2628900">
+                  <a:extLst>
+                    <a:ext uri="{9D8B030D-6E8A-4147-A177-3AD203B41FA5}">
+                      <a16:colId xmlns:a16="http://schemas.microsoft.com/office/drawing/2014/main" val="282503261"/>
+                    </a:ext>
+                  </a:extLst>
+                </a:gridCol>
+              </a:tblGrid>
+              <a:tr h="0">
+                <a:tc>
+                  <a:txBody>
+                    <a:bodyPr/>
+                    <a:lstStyle/>
+                    <a:p>
+                      <a:pPr algn="ctr">
+                        <a:buNone/>
+                      </a:pPr>
+                      <a:r>
+                        <a:rPr lang="en-US" sz="1400" dirty="0"/>
+                        <a:t>Domain</a:t>
+                      </a:r>
+                    </a:p>
+                  </a:txBody>
+                  <a:tcPr anchor="ctr">
+                    <a:solidFill>
+                      <a:schemeClr val="bg1">
+                        <a:lumMod val="85000"/>
+                      </a:schemeClr>
+                    </a:solidFill>
+                  </a:tcPr>
+                </a:tc>
+                <a:tc>
+                  <a:txBody>
+                    <a:bodyPr/>
+                    <a:lstStyle/>
+                    <a:p>
+                      <a:pPr algn="ctr">
+                        <a:buNone/>
+                      </a:pPr>
+                      <a:r>
+                        <a:rPr lang="en-US" sz="1400" dirty="0"/>
+                        <a:t>Rule A → B (Strong)</a:t>
+                      </a:r>
+                    </a:p>
+                  </a:txBody>
+                  <a:tcPr anchor="ctr">
+                    <a:solidFill>
+                      <a:schemeClr val="bg1">
+                        <a:lumMod val="85000"/>
+                      </a:schemeClr>
+                    </a:solidFill>
+                  </a:tcPr>
+                </a:tc>
+                <a:tc>
+                  <a:txBody>
+                    <a:bodyPr/>
+                    <a:lstStyle/>
+                    <a:p>
+                      <a:pPr algn="ctr">
+                        <a:buNone/>
+                      </a:pPr>
+                      <a:r>
+                        <a:rPr lang="en-US" sz="1400" dirty="0"/>
+                        <a:t>Rule B → A (Weak or Misleading)</a:t>
+                      </a:r>
+                    </a:p>
+                  </a:txBody>
+                  <a:tcPr anchor="ctr">
+                    <a:solidFill>
+                      <a:schemeClr val="bg1">
+                        <a:lumMod val="85000"/>
+                      </a:schemeClr>
+                    </a:solidFill>
+                  </a:tcPr>
+                </a:tc>
+                <a:tc>
+                  <a:txBody>
+                    <a:bodyPr/>
+                    <a:lstStyle/>
+                    <a:p>
+                      <a:pPr algn="ctr">
+                        <a:buNone/>
+                      </a:pPr>
+                      <a:r>
+                        <a:rPr lang="en-US" sz="1400" dirty="0"/>
+                        <a:t>Reason for Asymmetry</a:t>
+                      </a:r>
+                    </a:p>
+                  </a:txBody>
+                  <a:tcPr anchor="ctr">
+                    <a:solidFill>
+                      <a:schemeClr val="bg1">
+                        <a:lumMod val="85000"/>
+                      </a:schemeClr>
+                    </a:solidFill>
+                  </a:tcPr>
+                </a:tc>
+                <a:extLst>
+                  <a:ext uri="{0D108BD9-81ED-4DB2-BD59-A6C34878D82A}">
+                    <a16:rowId xmlns:a16="http://schemas.microsoft.com/office/drawing/2014/main" val="3976222607"/>
+                  </a:ext>
+                </a:extLst>
+              </a:tr>
+              <a:tr h="0">
+                <a:tc>
+                  <a:txBody>
+                    <a:bodyPr/>
+                    <a:lstStyle/>
+                    <a:p>
+                      <a:pPr>
+                        <a:buNone/>
+                      </a:pPr>
+                      <a:r>
+                        <a:rPr lang="en-US" sz="1400" dirty="0"/>
+                        <a:t>Retail</a:t>
+                      </a:r>
+                    </a:p>
+                  </a:txBody>
+                  <a:tcPr anchor="ctr"/>
+                </a:tc>
+                <a:tc>
+                  <a:txBody>
+                    <a:bodyPr/>
+                    <a:lstStyle/>
+                    <a:p>
+                      <a:pPr>
+                        <a:buNone/>
+                      </a:pPr>
+                      <a:r>
+                        <a:rPr lang="en-US" sz="1400" dirty="0"/>
+                        <a:t>Buys Smartphone → Buys Phone Case</a:t>
+                      </a:r>
+                    </a:p>
+                  </a:txBody>
+                  <a:tcPr anchor="ctr"/>
+                </a:tc>
+                <a:tc>
+                  <a:txBody>
+                    <a:bodyPr/>
+                    <a:lstStyle/>
+                    <a:p>
+                      <a:pPr>
+                        <a:buNone/>
+                      </a:pPr>
+                      <a:r>
+                        <a:rPr lang="en-US" sz="1400" dirty="0"/>
+                        <a:t>Buys Phone Case → Buys Smartphone</a:t>
+                      </a:r>
+                    </a:p>
+                  </a:txBody>
+                  <a:tcPr anchor="ctr"/>
+                </a:tc>
+                <a:tc>
+                  <a:txBody>
+                    <a:bodyPr/>
+                    <a:lstStyle/>
+                    <a:p>
+                      <a:pPr>
+                        <a:buNone/>
+                      </a:pPr>
+                      <a:r>
+                        <a:rPr lang="en-US" sz="1400" dirty="0"/>
+                        <a:t>Cases are often bought later or as replacements</a:t>
+                      </a:r>
+                    </a:p>
+                  </a:txBody>
+                  <a:tcPr anchor="ctr"/>
+                </a:tc>
+                <a:extLst>
+                  <a:ext uri="{0D108BD9-81ED-4DB2-BD59-A6C34878D82A}">
+                    <a16:rowId xmlns:a16="http://schemas.microsoft.com/office/drawing/2014/main" val="212492749"/>
+                  </a:ext>
+                </a:extLst>
+              </a:tr>
+              <a:tr h="0">
+                <a:tc>
+                  <a:txBody>
+                    <a:bodyPr/>
+                    <a:lstStyle/>
+                    <a:p>
+                      <a:pPr>
+                        <a:buNone/>
+                      </a:pPr>
+                      <a:r>
+                        <a:rPr lang="en-US" sz="1400" dirty="0"/>
+                        <a:t>Web Analytics</a:t>
+                      </a:r>
+                    </a:p>
+                  </a:txBody>
+                  <a:tcPr anchor="ctr"/>
+                </a:tc>
+                <a:tc>
+                  <a:txBody>
+                    <a:bodyPr/>
+                    <a:lstStyle/>
+                    <a:p>
+                      <a:pPr>
+                        <a:buNone/>
+                      </a:pPr>
+                      <a:r>
+                        <a:rPr lang="en-US" sz="1400" dirty="0"/>
+                        <a:t>Visits Product Page → Adds to Cart</a:t>
+                      </a:r>
+                    </a:p>
+                  </a:txBody>
+                  <a:tcPr anchor="ctr"/>
+                </a:tc>
+                <a:tc>
+                  <a:txBody>
+                    <a:bodyPr/>
+                    <a:lstStyle/>
+                    <a:p>
+                      <a:pPr>
+                        <a:buNone/>
+                      </a:pPr>
+                      <a:r>
+                        <a:rPr lang="en-US" sz="1400" dirty="0"/>
+                        <a:t>Adds to Cart → Visits Product Page</a:t>
+                      </a:r>
+                    </a:p>
+                  </a:txBody>
+                  <a:tcPr anchor="ctr"/>
+                </a:tc>
+                <a:tc>
+                  <a:txBody>
+                    <a:bodyPr/>
+                    <a:lstStyle/>
+                    <a:p>
+                      <a:pPr>
+                        <a:buNone/>
+                      </a:pPr>
+                      <a:r>
+                        <a:rPr lang="en-US" sz="1400" dirty="0"/>
+                        <a:t>Visit is required, but not all visits lead to cart</a:t>
+                      </a:r>
+                    </a:p>
+                  </a:txBody>
+                  <a:tcPr anchor="ctr"/>
+                </a:tc>
+                <a:extLst>
+                  <a:ext uri="{0D108BD9-81ED-4DB2-BD59-A6C34878D82A}">
+                    <a16:rowId xmlns:a16="http://schemas.microsoft.com/office/drawing/2014/main" val="3451002103"/>
+                  </a:ext>
+                </a:extLst>
+              </a:tr>
+              <a:tr h="0">
+                <a:tc>
+                  <a:txBody>
+                    <a:bodyPr/>
+                    <a:lstStyle/>
+                    <a:p>
+                      <a:pPr>
+                        <a:buNone/>
+                      </a:pPr>
+                      <a:r>
+                        <a:rPr lang="en-US" sz="1400" dirty="0"/>
+                        <a:t>Healthcare</a:t>
+                      </a:r>
+                    </a:p>
+                  </a:txBody>
+                  <a:tcPr anchor="ctr"/>
+                </a:tc>
+                <a:tc>
+                  <a:txBody>
+                    <a:bodyPr/>
+                    <a:lstStyle/>
+                    <a:p>
+                      <a:pPr>
+                        <a:buNone/>
+                      </a:pPr>
+                      <a:r>
+                        <a:rPr lang="en-US" sz="1400" dirty="0"/>
+                        <a:t>Diagnosed with Diabetes → Prescribed Insulin</a:t>
+                      </a:r>
+                    </a:p>
+                  </a:txBody>
+                  <a:tcPr anchor="ctr"/>
+                </a:tc>
+                <a:tc>
+                  <a:txBody>
+                    <a:bodyPr/>
+                    <a:lstStyle/>
+                    <a:p>
+                      <a:pPr>
+                        <a:buNone/>
+                      </a:pPr>
+                      <a:r>
+                        <a:rPr lang="en-US" sz="1400" dirty="0"/>
+                        <a:t>Prescribed Insulin → Diagnosed with Diabetes</a:t>
+                      </a:r>
+                    </a:p>
+                  </a:txBody>
+                  <a:tcPr anchor="ctr"/>
+                </a:tc>
+                <a:tc>
+                  <a:txBody>
+                    <a:bodyPr/>
+                    <a:lstStyle/>
+                    <a:p>
+                      <a:pPr>
+                        <a:buNone/>
+                      </a:pPr>
+                      <a:r>
+                        <a:rPr lang="en-US" sz="1400" dirty="0"/>
+                        <a:t>Insulin used for other conditions too</a:t>
+                      </a:r>
+                    </a:p>
+                  </a:txBody>
+                  <a:tcPr anchor="ctr"/>
+                </a:tc>
+                <a:extLst>
+                  <a:ext uri="{0D108BD9-81ED-4DB2-BD59-A6C34878D82A}">
+                    <a16:rowId xmlns:a16="http://schemas.microsoft.com/office/drawing/2014/main" val="4182332532"/>
+                  </a:ext>
+                </a:extLst>
+              </a:tr>
+              <a:tr h="0">
+                <a:tc>
+                  <a:txBody>
+                    <a:bodyPr/>
+                    <a:lstStyle/>
+                    <a:p>
+                      <a:pPr>
+                        <a:buNone/>
+                      </a:pPr>
+                      <a:r>
+                        <a:rPr lang="en-US" sz="1400" dirty="0"/>
+                        <a:t>Fraud Detection</a:t>
+                      </a:r>
+                    </a:p>
+                  </a:txBody>
+                  <a:tcPr anchor="ctr"/>
+                </a:tc>
+                <a:tc>
+                  <a:txBody>
+                    <a:bodyPr/>
+                    <a:lstStyle/>
+                    <a:p>
+                      <a:pPr>
+                        <a:buNone/>
+                      </a:pPr>
+                      <a:r>
+                        <a:rPr lang="en-US" sz="1400" dirty="0"/>
+                        <a:t>Unusual Login → Account Lock</a:t>
+                      </a:r>
+                    </a:p>
+                  </a:txBody>
+                  <a:tcPr anchor="ctr"/>
+                </a:tc>
+                <a:tc>
+                  <a:txBody>
+                    <a:bodyPr/>
+                    <a:lstStyle/>
+                    <a:p>
+                      <a:pPr>
+                        <a:buNone/>
+                      </a:pPr>
+                      <a:r>
+                        <a:rPr lang="en-US" sz="1400" dirty="0"/>
+                        <a:t>Account Lock → Unusual Login</a:t>
+                      </a:r>
+                    </a:p>
+                  </a:txBody>
+                  <a:tcPr anchor="ctr"/>
+                </a:tc>
+                <a:tc>
+                  <a:txBody>
+                    <a:bodyPr/>
+                    <a:lstStyle/>
+                    <a:p>
+                      <a:pPr>
+                        <a:buNone/>
+                      </a:pPr>
+                      <a:r>
+                        <a:rPr lang="en-US" sz="1400" dirty="0"/>
+                        <a:t>Locks triggered by various issues</a:t>
+                      </a:r>
+                    </a:p>
+                  </a:txBody>
+                  <a:tcPr anchor="ctr"/>
+                </a:tc>
+                <a:extLst>
+                  <a:ext uri="{0D108BD9-81ED-4DB2-BD59-A6C34878D82A}">
+                    <a16:rowId xmlns:a16="http://schemas.microsoft.com/office/drawing/2014/main" val="4036471077"/>
+                  </a:ext>
+                </a:extLst>
+              </a:tr>
+              <a:tr h="0">
+                <a:tc>
+                  <a:txBody>
+                    <a:bodyPr/>
+                    <a:lstStyle/>
+                    <a:p>
+                      <a:pPr>
+                        <a:buNone/>
+                      </a:pPr>
+                      <a:r>
+                        <a:rPr lang="en-US" sz="1400" dirty="0"/>
+                        <a:t>E-Learning</a:t>
+                      </a:r>
+                    </a:p>
+                  </a:txBody>
+                  <a:tcPr anchor="ctr"/>
+                </a:tc>
+                <a:tc>
+                  <a:txBody>
+                    <a:bodyPr/>
+                    <a:lstStyle/>
+                    <a:p>
+                      <a:pPr>
+                        <a:buNone/>
+                      </a:pPr>
+                      <a:r>
+                        <a:rPr lang="en-US" sz="1400"/>
+                        <a:t>Watches Lecture Video → Submits Homework</a:t>
+                      </a:r>
+                      <a:endParaRPr lang="en-US" sz="1400" dirty="0"/>
+                    </a:p>
+                  </a:txBody>
+                  <a:tcPr anchor="ctr"/>
+                </a:tc>
+                <a:tc>
+                  <a:txBody>
+                    <a:bodyPr/>
+                    <a:lstStyle/>
+                    <a:p>
+                      <a:pPr>
+                        <a:buNone/>
+                      </a:pPr>
+                      <a:r>
+                        <a:rPr lang="en-US" sz="1400" dirty="0"/>
+                        <a:t>Submits Homework → Watches Lecture Video</a:t>
+                      </a:r>
+                    </a:p>
+                  </a:txBody>
+                  <a:tcPr anchor="ctr"/>
+                </a:tc>
+                <a:tc>
+                  <a:txBody>
+                    <a:bodyPr/>
+                    <a:lstStyle/>
+                    <a:p>
+                      <a:pPr>
+                        <a:buNone/>
+                      </a:pPr>
+                      <a:r>
+                        <a:rPr lang="en-US" sz="1400" dirty="0"/>
+                        <a:t>Some students skip the video</a:t>
+                      </a:r>
+                    </a:p>
+                  </a:txBody>
+                  <a:tcPr anchor="ctr"/>
+                </a:tc>
+                <a:extLst>
+                  <a:ext uri="{0D108BD9-81ED-4DB2-BD59-A6C34878D82A}">
+                    <a16:rowId xmlns:a16="http://schemas.microsoft.com/office/drawing/2014/main" val="931208208"/>
+                  </a:ext>
+                </a:extLst>
+              </a:tr>
+              <a:tr h="0">
+                <a:tc>
+                  <a:txBody>
+                    <a:bodyPr/>
+                    <a:lstStyle/>
+                    <a:p>
+                      <a:pPr>
+                        <a:buNone/>
+                      </a:pPr>
+                      <a:r>
+                        <a:rPr lang="en-US" sz="1400" dirty="0"/>
+                        <a:t>Streaming Services</a:t>
+                      </a:r>
+                    </a:p>
+                  </a:txBody>
+                  <a:tcPr anchor="ctr"/>
+                </a:tc>
+                <a:tc>
+                  <a:txBody>
+                    <a:bodyPr/>
+                    <a:lstStyle/>
+                    <a:p>
+                      <a:pPr>
+                        <a:buNone/>
+                      </a:pPr>
+                      <a:r>
+                        <a:rPr lang="en-US" sz="1400"/>
+                        <a:t>Subscribes to Premium Plan → Watches Exclusive Shows</a:t>
+                      </a:r>
+                      <a:endParaRPr lang="en-US" sz="1400" dirty="0"/>
+                    </a:p>
+                  </a:txBody>
+                  <a:tcPr anchor="ctr"/>
+                </a:tc>
+                <a:tc>
+                  <a:txBody>
+                    <a:bodyPr/>
+                    <a:lstStyle/>
+                    <a:p>
+                      <a:pPr>
+                        <a:buNone/>
+                      </a:pPr>
+                      <a:r>
+                        <a:rPr lang="en-US" sz="1400" dirty="0"/>
+                        <a:t>Watches Exclusive Shows → Subscribes to Premium Plan</a:t>
+                      </a:r>
+                    </a:p>
+                  </a:txBody>
+                  <a:tcPr anchor="ctr"/>
+                </a:tc>
+                <a:tc>
+                  <a:txBody>
+                    <a:bodyPr/>
+                    <a:lstStyle/>
+                    <a:p>
+                      <a:pPr>
+                        <a:buNone/>
+                      </a:pPr>
+                      <a:r>
+                        <a:rPr lang="en-US" sz="1400" dirty="0"/>
+                        <a:t>Content may be shared or watched via someone else's account</a:t>
+                      </a:r>
+                    </a:p>
+                  </a:txBody>
+                  <a:tcPr anchor="ctr"/>
+                </a:tc>
+                <a:extLst>
+                  <a:ext uri="{0D108BD9-81ED-4DB2-BD59-A6C34878D82A}">
+                    <a16:rowId xmlns:a16="http://schemas.microsoft.com/office/drawing/2014/main" val="4023662678"/>
+                  </a:ext>
+                </a:extLst>
+              </a:tr>
+              <a:tr h="0">
+                <a:tc>
+                  <a:txBody>
+                    <a:bodyPr/>
+                    <a:lstStyle/>
+                    <a:p>
+                      <a:pPr>
+                        <a:buNone/>
+                      </a:pPr>
+                      <a:r>
+                        <a:rPr lang="en-US" sz="1400" dirty="0"/>
+                        <a:t>Finance</a:t>
+                      </a:r>
+                    </a:p>
+                  </a:txBody>
+                  <a:tcPr anchor="ctr"/>
+                </a:tc>
+                <a:tc>
+                  <a:txBody>
+                    <a:bodyPr/>
+                    <a:lstStyle/>
+                    <a:p>
+                      <a:pPr>
+                        <a:buNone/>
+                      </a:pPr>
+                      <a:r>
+                        <a:rPr lang="en-US" sz="1400"/>
+                        <a:t>Misses Loan Payment → Credit Score Drops</a:t>
+                      </a:r>
+                      <a:endParaRPr lang="en-US" sz="1400" dirty="0"/>
+                    </a:p>
+                  </a:txBody>
+                  <a:tcPr anchor="ctr"/>
+                </a:tc>
+                <a:tc>
+                  <a:txBody>
+                    <a:bodyPr/>
+                    <a:lstStyle/>
+                    <a:p>
+                      <a:pPr>
+                        <a:buNone/>
+                      </a:pPr>
+                      <a:r>
+                        <a:rPr lang="en-US" sz="1400" dirty="0"/>
+                        <a:t>Credit Score Drops → Misses Loan Payment</a:t>
+                      </a:r>
+                    </a:p>
+                  </a:txBody>
+                  <a:tcPr anchor="ctr"/>
+                </a:tc>
+                <a:tc>
+                  <a:txBody>
+                    <a:bodyPr/>
+                    <a:lstStyle/>
+                    <a:p>
+                      <a:pPr>
+                        <a:buNone/>
+                      </a:pPr>
+                      <a:r>
+                        <a:rPr lang="en-US" sz="1400" dirty="0"/>
+                        <a:t>Scores drop for many other financial behaviors</a:t>
+                      </a:r>
+                    </a:p>
+                  </a:txBody>
+                  <a:tcPr anchor="ctr"/>
+                </a:tc>
+                <a:extLst>
+                  <a:ext uri="{0D108BD9-81ED-4DB2-BD59-A6C34878D82A}">
+                    <a16:rowId xmlns:a16="http://schemas.microsoft.com/office/drawing/2014/main" val="895064090"/>
+                  </a:ext>
+                </a:extLst>
+              </a:tr>
+              <a:tr h="0">
+                <a:tc>
+                  <a:txBody>
+                    <a:bodyPr/>
+                    <a:lstStyle/>
+                    <a:p>
+                      <a:pPr>
+                        <a:buNone/>
+                      </a:pPr>
+                      <a:r>
+                        <a:rPr lang="en-US" sz="1400" dirty="0"/>
+                        <a:t>HR / Workforce</a:t>
+                      </a:r>
+                    </a:p>
+                  </a:txBody>
+                  <a:tcPr anchor="ctr"/>
+                </a:tc>
+                <a:tc>
+                  <a:txBody>
+                    <a:bodyPr/>
+                    <a:lstStyle/>
+                    <a:p>
+                      <a:pPr>
+                        <a:buNone/>
+                      </a:pPr>
+                      <a:r>
+                        <a:rPr lang="en-US" sz="1400"/>
+                        <a:t>Attends Training → Improved Job Performance</a:t>
+                      </a:r>
+                      <a:endParaRPr lang="en-US" sz="1400" dirty="0"/>
+                    </a:p>
+                  </a:txBody>
+                  <a:tcPr anchor="ctr"/>
+                </a:tc>
+                <a:tc>
+                  <a:txBody>
+                    <a:bodyPr/>
+                    <a:lstStyle/>
+                    <a:p>
+                      <a:pPr>
+                        <a:buNone/>
+                      </a:pPr>
+                      <a:r>
+                        <a:rPr lang="en-US" sz="1400" dirty="0"/>
+                        <a:t>Improved Job Performance → Attended Training</a:t>
+                      </a:r>
+                    </a:p>
+                  </a:txBody>
+                  <a:tcPr anchor="ctr"/>
+                </a:tc>
+                <a:tc>
+                  <a:txBody>
+                    <a:bodyPr/>
+                    <a:lstStyle/>
+                    <a:p>
+                      <a:pPr>
+                        <a:buNone/>
+                      </a:pPr>
+                      <a:r>
+                        <a:rPr lang="en-US" sz="1400" dirty="0"/>
+                        <a:t>Performance may improve for unrelated reasons</a:t>
+                      </a:r>
+                    </a:p>
+                  </a:txBody>
+                  <a:tcPr anchor="ctr"/>
+                </a:tc>
+                <a:extLst>
+                  <a:ext uri="{0D108BD9-81ED-4DB2-BD59-A6C34878D82A}">
+                    <a16:rowId xmlns:a16="http://schemas.microsoft.com/office/drawing/2014/main" val="2043656007"/>
+                  </a:ext>
+                </a:extLst>
+              </a:tr>
+            </a:tbl>
+          </a:graphicData>
+        </a:graphic>
+      </p:graphicFrame>
+    </p:spTree>
+    <p:extLst>
+      <p:ext uri="{BB962C8B-B14F-4D97-AF65-F5344CB8AC3E}">
+        <p14:creationId xmlns:p14="http://schemas.microsoft.com/office/powerpoint/2010/main" val="2757035436"/>
+      </p:ext>
+    </p:extLst>
+  </p:cSld>
+  <p:clrMapOvr>
+    <a:masterClrMapping/>
+  </p:clrMapOvr>
+</p:sld>
+</file>
+
+<file path=ppt/slides/slide11.xml><?xml version="1.0" encoding="utf-8"?>
+<p:sld xmlns:a="http://schemas.openxmlformats.org/drawingml/2006/main" xmlns:r="http://schemas.openxmlformats.org/officeDocument/2006/relationships" xmlns:p="http://schemas.openxmlformats.org/presentationml/2006/main">
+  <p:cSld>
+    <p:spTree>
+      <p:nvGrpSpPr>
+        <p:cNvPr id="1" name=""/>
+        <p:cNvGrpSpPr/>
+        <p:nvPr/>
+      </p:nvGrpSpPr>
+      <p:grpSpPr>
+        <a:xfrm>
+          <a:off x="0" y="0"/>
+          <a:ext cx="0" cy="0"/>
+          <a:chOff x="0" y="0"/>
+          <a:chExt cx="0" cy="0"/>
+        </a:xfrm>
+      </p:grpSpPr>
+      <p:sp>
+        <p:nvSpPr>
+          <p:cNvPr id="2" name="Title 1">
+            <a:extLst>
+              <a:ext uri="{FF2B5EF4-FFF2-40B4-BE49-F238E27FC236}">
                 <a16:creationId xmlns:a16="http://schemas.microsoft.com/office/drawing/2014/main" id="{748EBE3E-0A49-2947-0CEC-18B7160B878C}"/>
               </a:ext>
             </a:extLst>
@@ -7033,20 +7967,13 @@
         <p:spPr/>
         <p:txBody>
           <a:bodyPr>
-            <a:normAutofit fontScale="90000"/>
+            <a:normAutofit/>
           </a:bodyPr>
           <a:lstStyle/>
           <a:p>
             <a:r>
               <a:rPr lang="en-US" dirty="0"/>
               <a:t>The Lift Metric </a:t>
-            </a:r>
-            <a:br>
-              <a:rPr lang="en-US" dirty="0"/>
-            </a:br>
-            <a:r>
-              <a:rPr lang="en-US" dirty="0"/>
-              <a:t>Is the co-occurrence of two items is truly meaningful or just due to chance</a:t>
             </a:r>
           </a:p>
         </p:txBody>
@@ -7074,8 +8001,8 @@
           </a:xfrm>
         </p:spPr>
         <p:txBody>
-          <a:bodyPr>
-            <a:normAutofit fontScale="62500" lnSpcReduction="20000"/>
+          <a:bodyPr vert="horz" lIns="91440" tIns="45720" rIns="91440" bIns="45720" rtlCol="0" anchor="t">
+            <a:normAutofit fontScale="55000" lnSpcReduction="20000"/>
           </a:bodyPr>
           <a:lstStyle/>
           <a:p>
@@ -7088,6 +8015,23 @@
             </a:r>
           </a:p>
           <a:p>
+            <a:pPr>
+              <a:buNone/>
+            </a:pPr>
+            <a:r>
+              <a:rPr lang="en-US" dirty="0">
+                <a:latin typeface="Calibri"/>
+                <a:ea typeface="Calibri"/>
+                <a:cs typeface="Calibri"/>
+              </a:rPr>
+              <a:t>The lift metric answers the questions whether this co-occurrence is truly meaningful or it occurred just by change.</a:t>
+            </a:r>
+            <a:endParaRPr lang="en-US" dirty="0">
+              <a:ea typeface="Calibri"/>
+              <a:cs typeface="Calibri"/>
+            </a:endParaRPr>
+          </a:p>
+          <a:p>
             <a:pPr marL="0" indent="0">
               <a:buNone/>
             </a:pPr>
@@ -7096,9 +8040,13 @@
               <a:t>Scenario: </a:t>
             </a:r>
             <a:r>
-              <a:rPr lang="en-US" dirty="0"/>
+              <a:rPr lang="en-US"/>
               <a:t>We analyze 100 transactions at a bakery.</a:t>
             </a:r>
+            <a:endParaRPr lang="en-US" dirty="0">
+              <a:ea typeface="Calibri"/>
+              <a:cs typeface="Calibri"/>
+            </a:endParaRPr>
           </a:p>
           <a:p>
             <a:pPr marL="0" indent="0">
@@ -7286,7 +8234,7 @@
 </p:sld>
 </file>
 
-<file path=ppt/slides/slide11.xml><?xml version="1.0" encoding="utf-8"?>
+<file path=ppt/slides/slide12.xml><?xml version="1.0" encoding="utf-8"?>
 <p:sld xmlns:a="http://schemas.openxmlformats.org/drawingml/2006/main" xmlns:r="http://schemas.openxmlformats.org/officeDocument/2006/relationships" xmlns:p="http://schemas.openxmlformats.org/presentationml/2006/main">
   <p:cSld>
     <p:spTree>
@@ -7402,7 +8350,7 @@
 </p:sld>
 </file>
 
-<file path=ppt/slides/slide12.xml><?xml version="1.0" encoding="utf-8"?>
+<file path=ppt/slides/slide13.xml><?xml version="1.0" encoding="utf-8"?>
 <p:sld xmlns:a="http://schemas.openxmlformats.org/drawingml/2006/main" xmlns:r="http://schemas.openxmlformats.org/officeDocument/2006/relationships" xmlns:p="http://schemas.openxmlformats.org/presentationml/2006/main">
   <p:cSld>
     <p:spTree>
@@ -7442,7 +8390,7 @@
           <a:p>
             <a:r>
               <a:rPr lang="en-US" dirty="0"/>
-              <a:t>Lift Examples - Lift &gt; 1</a:t>
+              <a:t>Lift Examples: Lift &gt; 1</a:t>
             </a:r>
           </a:p>
         </p:txBody>
@@ -7594,7 +8542,7 @@
 </p:sld>
 </file>
 
-<file path=ppt/slides/slide13.xml><?xml version="1.0" encoding="utf-8"?>
+<file path=ppt/slides/slide14.xml><?xml version="1.0" encoding="utf-8"?>
 <p:sld xmlns:a="http://schemas.openxmlformats.org/drawingml/2006/main" xmlns:r="http://schemas.openxmlformats.org/officeDocument/2006/relationships" xmlns:p="http://schemas.openxmlformats.org/presentationml/2006/main">
   <p:cSld>
     <p:spTree>
@@ -7634,7 +8582,7 @@
           <a:p>
             <a:r>
               <a:rPr lang="en-US" dirty="0"/>
-              <a:t>Lift Examples - Lift &lt; 1 – Negative Relationship</a:t>
+              <a:t>Lift Examples: Lift &lt; 1 – Negative Relationship</a:t>
             </a:r>
           </a:p>
         </p:txBody>
@@ -7662,7 +8610,7 @@
           </a:xfrm>
         </p:spPr>
         <p:txBody>
-          <a:bodyPr>
+          <a:bodyPr vert="horz" lIns="91440" tIns="45720" rIns="91440" bIns="45720" rtlCol="0" anchor="t">
             <a:normAutofit fontScale="62500" lnSpcReduction="20000"/>
           </a:bodyPr>
           <a:lstStyle/>
@@ -7671,18 +8619,44 @@
               <a:buNone/>
             </a:pPr>
             <a:r>
-              <a:rPr lang="en-US" dirty="0"/>
-              <a:t>Lift can be 1 in two cases (When the consequent is common like in the bread/butter example and when there is a negative relationship between the antecedent and the consequent as show in the example in this slide).</a:t>
-            </a:r>
+              <a:rPr lang="en-US"/>
+              <a:t>Lift can be less than 1 in two cases:</a:t>
+            </a:r>
+          </a:p>
+          <a:p>
+            <a:pPr marL="342900" indent="-342900"/>
+            <a:r>
+              <a:rPr lang="en-US"/>
+              <a:t>When the consequent is common like in the bread/butter example.</a:t>
+            </a:r>
+            <a:endParaRPr lang="en-US">
+              <a:ea typeface="Calibri" panose="020F0502020204030204"/>
+              <a:cs typeface="Calibri" panose="020F0502020204030204"/>
+            </a:endParaRPr>
+          </a:p>
+          <a:p>
+            <a:pPr marL="342900" indent="-342900"/>
+            <a:r>
+              <a:rPr lang="en-US"/>
+              <a:t>When there is a negative relationship between the antecedent and the consequent as show next.</a:t>
+            </a:r>
+            <a:endParaRPr lang="en-US">
+              <a:ea typeface="Calibri"/>
+              <a:cs typeface="Calibri"/>
+            </a:endParaRPr>
           </a:p>
           <a:p>
             <a:pPr marL="0" indent="0">
               <a:buNone/>
             </a:pPr>
             <a:r>
-              <a:rPr lang="en-US" dirty="0"/>
+              <a:rPr lang="en-US" b="1" dirty="0"/>
               <a:t>Example: Analyzing supermarket transactions.</a:t>
             </a:r>
+            <a:endParaRPr lang="en-US" b="1" dirty="0">
+              <a:ea typeface="Calibri"/>
+              <a:cs typeface="Calibri"/>
+            </a:endParaRPr>
           </a:p>
           <a:p>
             <a:pPr marL="0" indent="0">
@@ -7795,7 +8769,7 @@
 </p:sld>
 </file>
 
-<file path=ppt/slides/slide14.xml><?xml version="1.0" encoding="utf-8"?>
+<file path=ppt/slides/slide15.xml><?xml version="1.0" encoding="utf-8"?>
 <p:sld xmlns:a="http://schemas.openxmlformats.org/drawingml/2006/main" xmlns:r="http://schemas.openxmlformats.org/officeDocument/2006/relationships" xmlns:p="http://schemas.openxmlformats.org/presentationml/2006/main">
   <p:cSld>
     <p:spTree>
@@ -7835,7 +8809,7 @@
           <a:p>
             <a:r>
               <a:rPr lang="en-US" dirty="0"/>
-              <a:t>Lift Examples - Lift = 1</a:t>
+              <a:t>Lift Examples:- Lift = 1</a:t>
             </a:r>
           </a:p>
         </p:txBody>
@@ -7968,7 +8942,7 @@
         <p:spPr>
           <a:xfrm>
             <a:off x="838200" y="5321813"/>
-            <a:ext cx="6094970" cy="1477328"/>
+            <a:ext cx="10015687" cy="861774"/>
           </a:xfrm>
           <a:prstGeom prst="rect">
             <a:avLst/>
@@ -7976,7 +8950,7 @@
           <a:noFill/>
         </p:spPr>
         <p:txBody>
-          <a:bodyPr wrap="square">
+          <a:bodyPr wrap="square" lIns="91440" tIns="45720" rIns="91440" bIns="45720" anchor="t">
             <a:spAutoFit/>
           </a:bodyPr>
           <a:lstStyle/>
@@ -7990,16 +8964,32 @@
             </a:r>
           </a:p>
           <a:p>
-            <a:r>
-              <a:rPr lang="en-US" dirty="0"/>
+            <a:pPr marL="285750" indent="-285750">
+              <a:buFont typeface="Arial"/>
+              <a:buChar char="•"/>
+            </a:pPr>
+            <a:r>
+              <a:rPr lang="en-US" sz="1600" dirty="0"/>
               <a:t>A lift of 1 means people who buy milk are neither more nor less likely to buy bread than the general population.</a:t>
             </a:r>
-          </a:p>
-          <a:p>
-            <a:r>
-              <a:rPr lang="en-US" dirty="0"/>
+            <a:endParaRPr lang="en-US" sz="1600">
+              <a:ea typeface="Calibri" panose="020F0502020204030204"/>
+              <a:cs typeface="Calibri" panose="020F0502020204030204"/>
+            </a:endParaRPr>
+          </a:p>
+          <a:p>
+            <a:pPr marL="285750" indent="-285750">
+              <a:buFont typeface="Arial"/>
+              <a:buChar char="•"/>
+            </a:pPr>
+            <a:r>
+              <a:rPr lang="en-US" sz="1600" dirty="0"/>
               <a:t>This suggests no real association between milk and bread in this dataset.</a:t>
             </a:r>
+            <a:endParaRPr lang="en-US" sz="1600" dirty="0">
+              <a:ea typeface="Calibri" panose="020F0502020204030204"/>
+              <a:cs typeface="Calibri" panose="020F0502020204030204"/>
+            </a:endParaRPr>
           </a:p>
         </p:txBody>
       </p:sp>
@@ -8297,7 +9287,7 @@
 </p:sld>
 </file>
 
-<file path=ppt/slides/slide15.xml><?xml version="1.0" encoding="utf-8"?>
+<file path=ppt/slides/slide16.xml><?xml version="1.0" encoding="utf-8"?>
 <p:sld xmlns:a="http://schemas.openxmlformats.org/drawingml/2006/main" xmlns:r="http://schemas.openxmlformats.org/officeDocument/2006/relationships" xmlns:p="http://schemas.openxmlformats.org/presentationml/2006/main">
   <p:cSld>
     <p:spTree>
@@ -8486,7 +9476,7 @@
 </p:sld>
 </file>
 
-<file path=ppt/slides/slide16.xml><?xml version="1.0" encoding="utf-8"?>
+<file path=ppt/slides/slide17.xml><?xml version="1.0" encoding="utf-8"?>
 <p:sld xmlns:a="http://schemas.openxmlformats.org/drawingml/2006/main" xmlns:r="http://schemas.openxmlformats.org/officeDocument/2006/relationships" xmlns:p="http://schemas.openxmlformats.org/presentationml/2006/main">
   <p:cSld>
     <p:spTree>
@@ -8557,7 +9547,7 @@
         </p:nvSpPr>
         <p:spPr/>
         <p:txBody>
-          <a:bodyPr>
+          <a:bodyPr vert="horz" lIns="91440" tIns="45720" rIns="91440" bIns="45720" rtlCol="0" anchor="t">
             <a:normAutofit fontScale="92500" lnSpcReduction="10000"/>
           </a:bodyPr>
           <a:lstStyle/>
@@ -8645,10 +9635,10 @@
               <a:t> Keep only frequent k-</a:t>
             </a:r>
             <a:r>
-              <a:rPr lang="en-US" dirty="0" err="1"/>
+              <a:rPr lang="en-US" err="1"/>
               <a:t>itemsets</a:t>
             </a:r>
-            <a:endParaRPr lang="en-US" dirty="0"/>
+            <a:endParaRPr lang="en-US"/>
           </a:p>
           <a:p>
             <a:pPr marL="457200" indent="-457200">
@@ -8748,7 +9738,7 @@
 </p:sld>
 </file>
 
-<file path=ppt/slides/slide17.xml><?xml version="1.0" encoding="utf-8"?>
+<file path=ppt/slides/slide18.xml><?xml version="1.0" encoding="utf-8"?>
 <p:sld xmlns:a="http://schemas.openxmlformats.org/drawingml/2006/main" xmlns:r="http://schemas.openxmlformats.org/officeDocument/2006/relationships" xmlns:p="http://schemas.openxmlformats.org/presentationml/2006/main">
   <p:cSld>
     <p:spTree>
@@ -9407,7 +10397,7 @@
 </p:sld>
 </file>
 
-<file path=ppt/slides/slide18.xml><?xml version="1.0" encoding="utf-8"?>
+<file path=ppt/slides/slide19.xml><?xml version="1.0" encoding="utf-8"?>
 <p:sld xmlns:a="http://schemas.openxmlformats.org/drawingml/2006/main" xmlns:r="http://schemas.openxmlformats.org/officeDocument/2006/relationships" xmlns:p="http://schemas.openxmlformats.org/presentationml/2006/main">
   <p:cSld>
     <p:spTree>
@@ -10778,142 +11768,6 @@
     <p:extLst>
       <p:ext uri="{BB962C8B-B14F-4D97-AF65-F5344CB8AC3E}">
         <p14:creationId xmlns:p14="http://schemas.microsoft.com/office/powerpoint/2010/main" val="2617828375"/>
-      </p:ext>
-    </p:extLst>
-  </p:cSld>
-  <p:clrMapOvr>
-    <a:masterClrMapping/>
-  </p:clrMapOvr>
-</p:sld>
-</file>
-
-<file path=ppt/slides/slide19.xml><?xml version="1.0" encoding="utf-8"?>
-<p:sld xmlns:a="http://schemas.openxmlformats.org/drawingml/2006/main" xmlns:r="http://schemas.openxmlformats.org/officeDocument/2006/relationships" xmlns:p="http://schemas.openxmlformats.org/presentationml/2006/main">
-  <p:cSld>
-    <p:spTree>
-      <p:nvGrpSpPr>
-        <p:cNvPr id="1" name="">
-          <a:extLst>
-            <a:ext uri="{FF2B5EF4-FFF2-40B4-BE49-F238E27FC236}">
-              <a16:creationId xmlns:a16="http://schemas.microsoft.com/office/drawing/2014/main" id="{E439A3BD-95DA-C239-F7A5-4EFCBFD449FC}"/>
-            </a:ext>
-          </a:extLst>
-        </p:cNvPr>
-        <p:cNvGrpSpPr/>
-        <p:nvPr/>
-      </p:nvGrpSpPr>
-      <p:grpSpPr>
-        <a:xfrm>
-          <a:off x="0" y="0"/>
-          <a:ext cx="0" cy="0"/>
-          <a:chOff x="0" y="0"/>
-          <a:chExt cx="0" cy="0"/>
-        </a:xfrm>
-      </p:grpSpPr>
-      <p:sp>
-        <p:nvSpPr>
-          <p:cNvPr id="2" name="Title 1">
-            <a:extLst>
-              <a:ext uri="{FF2B5EF4-FFF2-40B4-BE49-F238E27FC236}">
-                <a16:creationId xmlns:a16="http://schemas.microsoft.com/office/drawing/2014/main" id="{470AF467-6CBB-C3C1-F7A2-B0454D6C7ACF}"/>
-              </a:ext>
-            </a:extLst>
-          </p:cNvPr>
-          <p:cNvSpPr>
-            <a:spLocks noGrp="1"/>
-          </p:cNvSpPr>
-          <p:nvPr>
-            <p:ph type="title"/>
-          </p:nvPr>
-        </p:nvSpPr>
-        <p:spPr/>
-        <p:txBody>
-          <a:bodyPr>
-            <a:normAutofit/>
-          </a:bodyPr>
-          <a:lstStyle/>
-          <a:p>
-            <a:r>
-              <a:rPr lang="en-US" dirty="0"/>
-              <a:t>Iteration 2 Results</a:t>
-            </a:r>
-          </a:p>
-        </p:txBody>
-      </p:sp>
-      <p:sp>
-        <p:nvSpPr>
-          <p:cNvPr id="3" name="Content Placeholder 2">
-            <a:extLst>
-              <a:ext uri="{FF2B5EF4-FFF2-40B4-BE49-F238E27FC236}">
-                <a16:creationId xmlns:a16="http://schemas.microsoft.com/office/drawing/2014/main" id="{B9757FC9-2E4F-A35E-E89D-FFF9BD7C348E}"/>
-              </a:ext>
-            </a:extLst>
-          </p:cNvPr>
-          <p:cNvSpPr>
-            <a:spLocks noGrp="1"/>
-          </p:cNvSpPr>
-          <p:nvPr>
-            <p:ph idx="1"/>
-          </p:nvPr>
-        </p:nvSpPr>
-        <p:spPr/>
-        <p:txBody>
-          <a:bodyPr>
-            <a:normAutofit/>
-          </a:bodyPr>
-          <a:lstStyle/>
-          <a:p>
-            <a:pPr marL="0" indent="0">
-              <a:buNone/>
-            </a:pPr>
-            <a:r>
-              <a:rPr lang="en-US" sz="2000" b="1" dirty="0"/>
-              <a:t>L₂ (Frequent 2-itemsets)</a:t>
-            </a:r>
-          </a:p>
-          <a:p>
-            <a:pPr lvl="1"/>
-            <a:r>
-              <a:rPr lang="en-US" sz="1800" dirty="0"/>
-              <a:t>{Bread, Milk} - 40% support {Bread, Butter} - 40% support {Bread, Cheese} - 30% support {Bread, Eggs} - 30% support {Milk, Butter} - 30% support {Milk, Cheese} - 40% support {Butter, Cheese} - 40% support {Cheese, Yogurt} - 40% support</a:t>
-            </a:r>
-          </a:p>
-          <a:p>
-            <a:pPr marL="0" indent="0">
-              <a:buNone/>
-            </a:pPr>
-            <a:r>
-              <a:rPr lang="en-US" sz="2000" b="1" dirty="0"/>
-              <a:t>Key Observations</a:t>
-            </a:r>
-          </a:p>
-          <a:p>
-            <a:r>
-              <a:rPr lang="en-US" sz="2000" dirty="0"/>
-              <a:t>8 frequent pairs out of 15 possible</a:t>
-            </a:r>
-          </a:p>
-          <a:p>
-            <a:r>
-              <a:rPr lang="en-US" sz="2000" dirty="0"/>
-              <a:t>{Bread, Yogurt} has 0% support - strong negative correlation</a:t>
-            </a:r>
-          </a:p>
-          <a:p>
-            <a:r>
-              <a:rPr lang="en-US" sz="2000" dirty="0"/>
-              <a:t>{Butter, Cheese} has highest support (40%) - good combination</a:t>
-            </a:r>
-          </a:p>
-          <a:p>
-            <a:endParaRPr lang="en-US" sz="2000" dirty="0"/>
-          </a:p>
-        </p:txBody>
-      </p:sp>
-    </p:spTree>
-    <p:extLst>
-      <p:ext uri="{BB962C8B-B14F-4D97-AF65-F5344CB8AC3E}">
-        <p14:creationId xmlns:p14="http://schemas.microsoft.com/office/powerpoint/2010/main" val="1812782099"/>
       </p:ext>
     </p:extLst>
   </p:cSld>
@@ -11145,6 +11999,142 @@
         <p:cNvPr id="1" name="">
           <a:extLst>
             <a:ext uri="{FF2B5EF4-FFF2-40B4-BE49-F238E27FC236}">
+              <a16:creationId xmlns:a16="http://schemas.microsoft.com/office/drawing/2014/main" id="{E439A3BD-95DA-C239-F7A5-4EFCBFD449FC}"/>
+            </a:ext>
+          </a:extLst>
+        </p:cNvPr>
+        <p:cNvGrpSpPr/>
+        <p:nvPr/>
+      </p:nvGrpSpPr>
+      <p:grpSpPr>
+        <a:xfrm>
+          <a:off x="0" y="0"/>
+          <a:ext cx="0" cy="0"/>
+          <a:chOff x="0" y="0"/>
+          <a:chExt cx="0" cy="0"/>
+        </a:xfrm>
+      </p:grpSpPr>
+      <p:sp>
+        <p:nvSpPr>
+          <p:cNvPr id="2" name="Title 1">
+            <a:extLst>
+              <a:ext uri="{FF2B5EF4-FFF2-40B4-BE49-F238E27FC236}">
+                <a16:creationId xmlns:a16="http://schemas.microsoft.com/office/drawing/2014/main" id="{470AF467-6CBB-C3C1-F7A2-B0454D6C7ACF}"/>
+              </a:ext>
+            </a:extLst>
+          </p:cNvPr>
+          <p:cNvSpPr>
+            <a:spLocks noGrp="1"/>
+          </p:cNvSpPr>
+          <p:nvPr>
+            <p:ph type="title"/>
+          </p:nvPr>
+        </p:nvSpPr>
+        <p:spPr/>
+        <p:txBody>
+          <a:bodyPr>
+            <a:normAutofit/>
+          </a:bodyPr>
+          <a:lstStyle/>
+          <a:p>
+            <a:r>
+              <a:rPr lang="en-US" dirty="0"/>
+              <a:t>Iteration 2 Results</a:t>
+            </a:r>
+          </a:p>
+        </p:txBody>
+      </p:sp>
+      <p:sp>
+        <p:nvSpPr>
+          <p:cNvPr id="3" name="Content Placeholder 2">
+            <a:extLst>
+              <a:ext uri="{FF2B5EF4-FFF2-40B4-BE49-F238E27FC236}">
+                <a16:creationId xmlns:a16="http://schemas.microsoft.com/office/drawing/2014/main" id="{B9757FC9-2E4F-A35E-E89D-FFF9BD7C348E}"/>
+              </a:ext>
+            </a:extLst>
+          </p:cNvPr>
+          <p:cNvSpPr>
+            <a:spLocks noGrp="1"/>
+          </p:cNvSpPr>
+          <p:nvPr>
+            <p:ph idx="1"/>
+          </p:nvPr>
+        </p:nvSpPr>
+        <p:spPr/>
+        <p:txBody>
+          <a:bodyPr>
+            <a:normAutofit/>
+          </a:bodyPr>
+          <a:lstStyle/>
+          <a:p>
+            <a:pPr marL="0" indent="0">
+              <a:buNone/>
+            </a:pPr>
+            <a:r>
+              <a:rPr lang="en-US" sz="2000" b="1" dirty="0"/>
+              <a:t>L₂ (Frequent 2-itemsets)</a:t>
+            </a:r>
+          </a:p>
+          <a:p>
+            <a:pPr lvl="1"/>
+            <a:r>
+              <a:rPr lang="en-US" sz="1800" dirty="0"/>
+              <a:t>{Bread, Milk} - 40% support {Bread, Butter} - 40% support {Bread, Cheese} - 30% support {Bread, Eggs} - 30% support {Milk, Butter} - 30% support {Milk, Cheese} - 40% support {Butter, Cheese} - 40% support {Cheese, Yogurt} - 40% support</a:t>
+            </a:r>
+          </a:p>
+          <a:p>
+            <a:pPr marL="0" indent="0">
+              <a:buNone/>
+            </a:pPr>
+            <a:r>
+              <a:rPr lang="en-US" sz="2000" b="1" dirty="0"/>
+              <a:t>Key Observations</a:t>
+            </a:r>
+          </a:p>
+          <a:p>
+            <a:r>
+              <a:rPr lang="en-US" sz="2000" dirty="0"/>
+              <a:t>8 frequent pairs out of 15 possible</a:t>
+            </a:r>
+          </a:p>
+          <a:p>
+            <a:r>
+              <a:rPr lang="en-US" sz="2000" dirty="0"/>
+              <a:t>{Bread, Yogurt} has 0% support - strong negative correlation</a:t>
+            </a:r>
+          </a:p>
+          <a:p>
+            <a:r>
+              <a:rPr lang="en-US" sz="2000" dirty="0"/>
+              <a:t>{Butter, Cheese} has highest support (40%) - good combination</a:t>
+            </a:r>
+          </a:p>
+          <a:p>
+            <a:endParaRPr lang="en-US" sz="2000" dirty="0"/>
+          </a:p>
+        </p:txBody>
+      </p:sp>
+    </p:spTree>
+    <p:extLst>
+      <p:ext uri="{BB962C8B-B14F-4D97-AF65-F5344CB8AC3E}">
+        <p14:creationId xmlns:p14="http://schemas.microsoft.com/office/powerpoint/2010/main" val="1812782099"/>
+      </p:ext>
+    </p:extLst>
+  </p:cSld>
+  <p:clrMapOvr>
+    <a:masterClrMapping/>
+  </p:clrMapOvr>
+</p:sld>
+</file>
+
+<file path=ppt/slides/slide21.xml><?xml version="1.0" encoding="utf-8"?>
+<p:sld xmlns:a="http://schemas.openxmlformats.org/drawingml/2006/main" xmlns:r="http://schemas.openxmlformats.org/officeDocument/2006/relationships" xmlns:p="http://schemas.openxmlformats.org/presentationml/2006/main">
+  <p:cSld>
+    <p:spTree>
+      <p:nvGrpSpPr>
+        <p:cNvPr id="1" name="">
+          <a:extLst>
+            <a:ext uri="{FF2B5EF4-FFF2-40B4-BE49-F238E27FC236}">
               <a16:creationId xmlns:a16="http://schemas.microsoft.com/office/drawing/2014/main" id="{2B5614F4-A625-FC54-BE88-0618783C69D7}"/>
             </a:ext>
           </a:extLst>
@@ -11348,7 +12338,7 @@
 </p:sld>
 </file>
 
-<file path=ppt/slides/slide21.xml><?xml version="1.0" encoding="utf-8"?>
+<file path=ppt/slides/slide22.xml><?xml version="1.0" encoding="utf-8"?>
 <p:sld xmlns:a="http://schemas.openxmlformats.org/drawingml/2006/main" xmlns:r="http://schemas.openxmlformats.org/officeDocument/2006/relationships" xmlns:p="http://schemas.openxmlformats.org/presentationml/2006/main">
   <p:cSld>
     <p:spTree>
@@ -12049,7 +13039,7 @@
 </p:sld>
 </file>
 
-<file path=ppt/slides/slide22.xml><?xml version="1.0" encoding="utf-8"?>
+<file path=ppt/slides/slide23.xml><?xml version="1.0" encoding="utf-8"?>
 <p:sld xmlns:a="http://schemas.openxmlformats.org/drawingml/2006/main" xmlns:r="http://schemas.openxmlformats.org/officeDocument/2006/relationships" xmlns:p="http://schemas.openxmlformats.org/presentationml/2006/main">
   <p:cSld>
     <p:spTree>
@@ -12144,7 +13134,7 @@
 </p:sld>
 </file>
 
-<file path=ppt/slides/slide23.xml><?xml version="1.0" encoding="utf-8"?>
+<file path=ppt/slides/slide24.xml><?xml version="1.0" encoding="utf-8"?>
 <p:sld xmlns:a="http://schemas.openxmlformats.org/drawingml/2006/main" xmlns:r="http://schemas.openxmlformats.org/officeDocument/2006/relationships" xmlns:p="http://schemas.openxmlformats.org/presentationml/2006/main">
   <p:cSld>
     <p:spTree>
@@ -12237,7 +13227,7 @@
 </p:sld>
 </file>
 
-<file path=ppt/slides/slide24.xml><?xml version="1.0" encoding="utf-8"?>
+<file path=ppt/slides/slide25.xml><?xml version="1.0" encoding="utf-8"?>
 <p:sld xmlns:a="http://schemas.openxmlformats.org/drawingml/2006/main" xmlns:r="http://schemas.openxmlformats.org/officeDocument/2006/relationships" xmlns:p="http://schemas.openxmlformats.org/presentationml/2006/main">
   <p:cSld>
     <p:spTree>
@@ -12453,7 +13443,7 @@
 </p:sld>
 </file>
 
-<file path=ppt/slides/slide25.xml><?xml version="1.0" encoding="utf-8"?>
+<file path=ppt/slides/slide26.xml><?xml version="1.0" encoding="utf-8"?>
 <p:sld xmlns:a="http://schemas.openxmlformats.org/drawingml/2006/main" xmlns:r="http://schemas.openxmlformats.org/officeDocument/2006/relationships" xmlns:p="http://schemas.openxmlformats.org/presentationml/2006/main">
   <p:cSld>
     <p:spTree>
@@ -12546,7 +13536,7 @@
 </p:sld>
 </file>
 
-<file path=ppt/slides/slide26.xml><?xml version="1.0" encoding="utf-8"?>
+<file path=ppt/slides/slide27.xml><?xml version="1.0" encoding="utf-8"?>
 <p:sld xmlns:a="http://schemas.openxmlformats.org/drawingml/2006/main" xmlns:r="http://schemas.openxmlformats.org/officeDocument/2006/relationships" xmlns:p="http://schemas.openxmlformats.org/presentationml/2006/main">
   <p:cSld>
     <p:spTree>
@@ -12756,7 +13746,7 @@
 </p:sld>
 </file>
 
-<file path=ppt/slides/slide27.xml><?xml version="1.0" encoding="utf-8"?>
+<file path=ppt/slides/slide28.xml><?xml version="1.0" encoding="utf-8"?>
 <p:sld xmlns:a="http://schemas.openxmlformats.org/drawingml/2006/main" xmlns:r="http://schemas.openxmlformats.org/officeDocument/2006/relationships" xmlns:p="http://schemas.openxmlformats.org/presentationml/2006/main">
   <p:cSld>
     <p:spTree>
@@ -13012,7 +14002,7 @@
 </p:sld>
 </file>
 
-<file path=ppt/slides/slide28.xml><?xml version="1.0" encoding="utf-8"?>
+<file path=ppt/slides/slide29.xml><?xml version="1.0" encoding="utf-8"?>
 <p:sld xmlns:a="http://schemas.openxmlformats.org/drawingml/2006/main" xmlns:r="http://schemas.openxmlformats.org/officeDocument/2006/relationships" xmlns:p="http://schemas.openxmlformats.org/presentationml/2006/main">
   <p:cSld>
     <p:spTree>
@@ -13262,288 +14252,6 @@
     <p:extLst>
       <p:ext uri="{BB962C8B-B14F-4D97-AF65-F5344CB8AC3E}">
         <p14:creationId xmlns:p14="http://schemas.microsoft.com/office/powerpoint/2010/main" val="2747417129"/>
-      </p:ext>
-    </p:extLst>
-  </p:cSld>
-  <p:clrMapOvr>
-    <a:masterClrMapping/>
-  </p:clrMapOvr>
-</p:sld>
-</file>
-
-<file path=ppt/slides/slide29.xml><?xml version="1.0" encoding="utf-8"?>
-<p:sld xmlns:a="http://schemas.openxmlformats.org/drawingml/2006/main" xmlns:r="http://schemas.openxmlformats.org/officeDocument/2006/relationships" xmlns:p="http://schemas.openxmlformats.org/presentationml/2006/main">
-  <p:cSld>
-    <p:spTree>
-      <p:nvGrpSpPr>
-        <p:cNvPr id="1" name="">
-          <a:extLst>
-            <a:ext uri="{FF2B5EF4-FFF2-40B4-BE49-F238E27FC236}">
-              <a16:creationId xmlns:a16="http://schemas.microsoft.com/office/drawing/2014/main" id="{C428DA21-E83E-856F-D737-F1A1067A2EB0}"/>
-            </a:ext>
-          </a:extLst>
-        </p:cNvPr>
-        <p:cNvGrpSpPr/>
-        <p:nvPr/>
-      </p:nvGrpSpPr>
-      <p:grpSpPr>
-        <a:xfrm>
-          <a:off x="0" y="0"/>
-          <a:ext cx="0" cy="0"/>
-          <a:chOff x="0" y="0"/>
-          <a:chExt cx="0" cy="0"/>
-        </a:xfrm>
-      </p:grpSpPr>
-      <p:sp>
-        <p:nvSpPr>
-          <p:cNvPr id="2" name="Title 1">
-            <a:extLst>
-              <a:ext uri="{FF2B5EF4-FFF2-40B4-BE49-F238E27FC236}">
-                <a16:creationId xmlns:a16="http://schemas.microsoft.com/office/drawing/2014/main" id="{80E8F853-FCD3-A579-AEB9-A648F1DB23C7}"/>
-              </a:ext>
-            </a:extLst>
-          </p:cNvPr>
-          <p:cNvSpPr>
-            <a:spLocks noGrp="1"/>
-          </p:cNvSpPr>
-          <p:nvPr>
-            <p:ph type="title"/>
-          </p:nvPr>
-        </p:nvSpPr>
-        <p:spPr/>
-        <p:txBody>
-          <a:bodyPr>
-            <a:normAutofit/>
-          </a:bodyPr>
-          <a:lstStyle/>
-          <a:p>
-            <a:r>
-              <a:rPr lang="en-US" b="1" dirty="0"/>
-              <a:t>Next Steps &amp; Advanced Topics</a:t>
-            </a:r>
-            <a:endParaRPr lang="en-US" dirty="0"/>
-          </a:p>
-        </p:txBody>
-      </p:sp>
-      <p:sp>
-        <p:nvSpPr>
-          <p:cNvPr id="3" name="Content Placeholder 2">
-            <a:extLst>
-              <a:ext uri="{FF2B5EF4-FFF2-40B4-BE49-F238E27FC236}">
-                <a16:creationId xmlns:a16="http://schemas.microsoft.com/office/drawing/2014/main" id="{A375DEE9-89C5-A926-94A5-CAA66B30274D}"/>
-              </a:ext>
-            </a:extLst>
-          </p:cNvPr>
-          <p:cNvSpPr>
-            <a:spLocks noGrp="1"/>
-          </p:cNvSpPr>
-          <p:nvPr>
-            <p:ph idx="1"/>
-          </p:nvPr>
-        </p:nvSpPr>
-        <p:spPr/>
-        <p:txBody>
-          <a:bodyPr>
-            <a:normAutofit fontScale="70000" lnSpcReduction="20000"/>
-          </a:bodyPr>
-          <a:lstStyle/>
-          <a:p>
-            <a:pPr marL="0" indent="0">
-              <a:buNone/>
-            </a:pPr>
-            <a:r>
-              <a:rPr lang="en-US" b="1" dirty="0"/>
-              <a:t>Immediate Applications</a:t>
-            </a:r>
-          </a:p>
-          <a:p>
-            <a:r>
-              <a:rPr lang="en-US" b="1" dirty="0"/>
-              <a:t>Implement basic Apriori</a:t>
-            </a:r>
-            <a:r>
-              <a:rPr lang="en-US" dirty="0"/>
-              <a:t> on your own datasets</a:t>
-            </a:r>
-          </a:p>
-          <a:p>
-            <a:r>
-              <a:rPr lang="en-US" b="1" dirty="0"/>
-              <a:t>Experiment with thresholds</a:t>
-            </a:r>
-            <a:r>
-              <a:rPr lang="en-US" dirty="0"/>
-              <a:t> to understand trade-offs</a:t>
-            </a:r>
-          </a:p>
-          <a:p>
-            <a:r>
-              <a:rPr lang="en-US" b="1" dirty="0"/>
-              <a:t>Validate discovered rules</a:t>
-            </a:r>
-            <a:r>
-              <a:rPr lang="en-US" dirty="0"/>
-              <a:t> with domain experts</a:t>
-            </a:r>
-          </a:p>
-          <a:p>
-            <a:pPr marL="0" indent="0">
-              <a:buNone/>
-            </a:pPr>
-            <a:r>
-              <a:rPr lang="en-US" b="1" dirty="0"/>
-              <a:t>Advanced Techniques</a:t>
-            </a:r>
-          </a:p>
-          <a:p>
-            <a:r>
-              <a:rPr lang="en-US" b="1" dirty="0"/>
-              <a:t>Sequential pattern mining:</a:t>
-            </a:r>
-            <a:r>
-              <a:rPr lang="en-US" dirty="0"/>
-              <a:t> Time-ordered associations</a:t>
-            </a:r>
-          </a:p>
-          <a:p>
-            <a:r>
-              <a:rPr lang="en-US" b="1" dirty="0"/>
-              <a:t>Multi-level associations:</a:t>
-            </a:r>
-            <a:r>
-              <a:rPr lang="en-US" dirty="0"/>
-              <a:t> Category hierarchies</a:t>
-            </a:r>
-          </a:p>
-          <a:p>
-            <a:r>
-              <a:rPr lang="en-US" b="1" dirty="0"/>
-              <a:t>Constraint-based mining:</a:t>
-            </a:r>
-            <a:r>
-              <a:rPr lang="en-US" dirty="0"/>
-              <a:t> User-specified business rules</a:t>
-            </a:r>
-          </a:p>
-          <a:p>
-            <a:pPr marL="0" indent="0">
-              <a:buNone/>
-            </a:pPr>
-            <a:r>
-              <a:rPr lang="en-US" b="1" dirty="0"/>
-              <a:t>Modern Developments</a:t>
-            </a:r>
-          </a:p>
-          <a:p>
-            <a:r>
-              <a:rPr lang="en-US" b="1" dirty="0"/>
-              <a:t>Real-time association mining</a:t>
-            </a:r>
-            <a:r>
-              <a:rPr lang="en-US" dirty="0"/>
-              <a:t> for streaming data</a:t>
-            </a:r>
-          </a:p>
-          <a:p>
-            <a:r>
-              <a:rPr lang="en-US" b="1" dirty="0"/>
-              <a:t>Privacy-preserving techniques</a:t>
-            </a:r>
-            <a:r>
-              <a:rPr lang="en-US" dirty="0"/>
-              <a:t> for sensitive data</a:t>
-            </a:r>
-          </a:p>
-          <a:p>
-            <a:r>
-              <a:rPr lang="en-US" b="1" dirty="0"/>
-              <a:t>Deep learning approaches</a:t>
-            </a:r>
-            <a:r>
-              <a:rPr lang="en-US" dirty="0"/>
-              <a:t> for complex pattern discovery</a:t>
-            </a:r>
-          </a:p>
-          <a:p>
-            <a:pPr marL="0" indent="0">
-              <a:buNone/>
-            </a:pPr>
-            <a:r>
-              <a:rPr lang="en-US" b="1" dirty="0"/>
-              <a:t>Tools to Explore</a:t>
-            </a:r>
-          </a:p>
-          <a:p>
-            <a:r>
-              <a:rPr lang="en-US" b="1" dirty="0"/>
-              <a:t>Python:</a:t>
-            </a:r>
-            <a:r>
-              <a:rPr lang="en-US" dirty="0"/>
-              <a:t> </a:t>
-            </a:r>
-            <a:r>
-              <a:rPr lang="en-US" dirty="0" err="1"/>
-              <a:t>mlxtend</a:t>
-            </a:r>
-            <a:r>
-              <a:rPr lang="en-US" dirty="0"/>
-              <a:t>, </a:t>
-            </a:r>
-            <a:r>
-              <a:rPr lang="en-US" dirty="0" err="1"/>
-              <a:t>apyori</a:t>
-            </a:r>
-            <a:r>
-              <a:rPr lang="en-US" dirty="0"/>
-              <a:t> libraries</a:t>
-            </a:r>
-          </a:p>
-          <a:p>
-            <a:r>
-              <a:rPr lang="en-US" b="1" dirty="0"/>
-              <a:t>R:</a:t>
-            </a:r>
-            <a:r>
-              <a:rPr lang="en-US" dirty="0"/>
-              <a:t> </a:t>
-            </a:r>
-            <a:r>
-              <a:rPr lang="en-US" dirty="0" err="1"/>
-              <a:t>arules</a:t>
-            </a:r>
-            <a:r>
-              <a:rPr lang="en-US" dirty="0"/>
-              <a:t>, </a:t>
-            </a:r>
-            <a:r>
-              <a:rPr lang="en-US" dirty="0" err="1"/>
-              <a:t>arulesViz</a:t>
-            </a:r>
-            <a:r>
-              <a:rPr lang="en-US" dirty="0"/>
-              <a:t> packages</a:t>
-            </a:r>
-          </a:p>
-          <a:p>
-            <a:r>
-              <a:rPr lang="en-US" b="1" dirty="0"/>
-              <a:t>Spark:</a:t>
-            </a:r>
-            <a:r>
-              <a:rPr lang="en-US" dirty="0"/>
-              <a:t> MLlib for large-scale mining</a:t>
-            </a:r>
-          </a:p>
-          <a:p>
-            <a:endParaRPr lang="en-US" dirty="0"/>
-          </a:p>
-        </p:txBody>
-      </p:sp>
-    </p:spTree>
-    <p:extLst>
-      <p:ext uri="{BB962C8B-B14F-4D97-AF65-F5344CB8AC3E}">
-        <p14:creationId xmlns:p14="http://schemas.microsoft.com/office/powerpoint/2010/main" val="1798126145"/>
       </p:ext>
     </p:extLst>
   </p:cSld>
@@ -13848,6 +14556,288 @@
     <p:extLst>
       <p:ext uri="{BB962C8B-B14F-4D97-AF65-F5344CB8AC3E}">
         <p14:creationId xmlns:p14="http://schemas.microsoft.com/office/powerpoint/2010/main" val="2426021593"/>
+      </p:ext>
+    </p:extLst>
+  </p:cSld>
+  <p:clrMapOvr>
+    <a:masterClrMapping/>
+  </p:clrMapOvr>
+</p:sld>
+</file>
+
+<file path=ppt/slides/slide30.xml><?xml version="1.0" encoding="utf-8"?>
+<p:sld xmlns:a="http://schemas.openxmlformats.org/drawingml/2006/main" xmlns:r="http://schemas.openxmlformats.org/officeDocument/2006/relationships" xmlns:p="http://schemas.openxmlformats.org/presentationml/2006/main">
+  <p:cSld>
+    <p:spTree>
+      <p:nvGrpSpPr>
+        <p:cNvPr id="1" name="">
+          <a:extLst>
+            <a:ext uri="{FF2B5EF4-FFF2-40B4-BE49-F238E27FC236}">
+              <a16:creationId xmlns:a16="http://schemas.microsoft.com/office/drawing/2014/main" id="{C428DA21-E83E-856F-D737-F1A1067A2EB0}"/>
+            </a:ext>
+          </a:extLst>
+        </p:cNvPr>
+        <p:cNvGrpSpPr/>
+        <p:nvPr/>
+      </p:nvGrpSpPr>
+      <p:grpSpPr>
+        <a:xfrm>
+          <a:off x="0" y="0"/>
+          <a:ext cx="0" cy="0"/>
+          <a:chOff x="0" y="0"/>
+          <a:chExt cx="0" cy="0"/>
+        </a:xfrm>
+      </p:grpSpPr>
+      <p:sp>
+        <p:nvSpPr>
+          <p:cNvPr id="2" name="Title 1">
+            <a:extLst>
+              <a:ext uri="{FF2B5EF4-FFF2-40B4-BE49-F238E27FC236}">
+                <a16:creationId xmlns:a16="http://schemas.microsoft.com/office/drawing/2014/main" id="{80E8F853-FCD3-A579-AEB9-A648F1DB23C7}"/>
+              </a:ext>
+            </a:extLst>
+          </p:cNvPr>
+          <p:cNvSpPr>
+            <a:spLocks noGrp="1"/>
+          </p:cNvSpPr>
+          <p:nvPr>
+            <p:ph type="title"/>
+          </p:nvPr>
+        </p:nvSpPr>
+        <p:spPr/>
+        <p:txBody>
+          <a:bodyPr>
+            <a:normAutofit/>
+          </a:bodyPr>
+          <a:lstStyle/>
+          <a:p>
+            <a:r>
+              <a:rPr lang="en-US" b="1" dirty="0"/>
+              <a:t>Next Steps &amp; Advanced Topics</a:t>
+            </a:r>
+            <a:endParaRPr lang="en-US" dirty="0"/>
+          </a:p>
+        </p:txBody>
+      </p:sp>
+      <p:sp>
+        <p:nvSpPr>
+          <p:cNvPr id="3" name="Content Placeholder 2">
+            <a:extLst>
+              <a:ext uri="{FF2B5EF4-FFF2-40B4-BE49-F238E27FC236}">
+                <a16:creationId xmlns:a16="http://schemas.microsoft.com/office/drawing/2014/main" id="{A375DEE9-89C5-A926-94A5-CAA66B30274D}"/>
+              </a:ext>
+            </a:extLst>
+          </p:cNvPr>
+          <p:cNvSpPr>
+            <a:spLocks noGrp="1"/>
+          </p:cNvSpPr>
+          <p:nvPr>
+            <p:ph idx="1"/>
+          </p:nvPr>
+        </p:nvSpPr>
+        <p:spPr/>
+        <p:txBody>
+          <a:bodyPr>
+            <a:normAutofit fontScale="70000" lnSpcReduction="20000"/>
+          </a:bodyPr>
+          <a:lstStyle/>
+          <a:p>
+            <a:pPr marL="0" indent="0">
+              <a:buNone/>
+            </a:pPr>
+            <a:r>
+              <a:rPr lang="en-US" b="1" dirty="0"/>
+              <a:t>Immediate Applications</a:t>
+            </a:r>
+          </a:p>
+          <a:p>
+            <a:r>
+              <a:rPr lang="en-US" b="1" dirty="0"/>
+              <a:t>Implement basic Apriori</a:t>
+            </a:r>
+            <a:r>
+              <a:rPr lang="en-US" dirty="0"/>
+              <a:t> on your own datasets</a:t>
+            </a:r>
+          </a:p>
+          <a:p>
+            <a:r>
+              <a:rPr lang="en-US" b="1" dirty="0"/>
+              <a:t>Experiment with thresholds</a:t>
+            </a:r>
+            <a:r>
+              <a:rPr lang="en-US" dirty="0"/>
+              <a:t> to understand trade-offs</a:t>
+            </a:r>
+          </a:p>
+          <a:p>
+            <a:r>
+              <a:rPr lang="en-US" b="1" dirty="0"/>
+              <a:t>Validate discovered rules</a:t>
+            </a:r>
+            <a:r>
+              <a:rPr lang="en-US" dirty="0"/>
+              <a:t> with domain experts</a:t>
+            </a:r>
+          </a:p>
+          <a:p>
+            <a:pPr marL="0" indent="0">
+              <a:buNone/>
+            </a:pPr>
+            <a:r>
+              <a:rPr lang="en-US" b="1" dirty="0"/>
+              <a:t>Advanced Techniques</a:t>
+            </a:r>
+          </a:p>
+          <a:p>
+            <a:r>
+              <a:rPr lang="en-US" b="1" dirty="0"/>
+              <a:t>Sequential pattern mining:</a:t>
+            </a:r>
+            <a:r>
+              <a:rPr lang="en-US" dirty="0"/>
+              <a:t> Time-ordered associations</a:t>
+            </a:r>
+          </a:p>
+          <a:p>
+            <a:r>
+              <a:rPr lang="en-US" b="1" dirty="0"/>
+              <a:t>Multi-level associations:</a:t>
+            </a:r>
+            <a:r>
+              <a:rPr lang="en-US" dirty="0"/>
+              <a:t> Category hierarchies</a:t>
+            </a:r>
+          </a:p>
+          <a:p>
+            <a:r>
+              <a:rPr lang="en-US" b="1" dirty="0"/>
+              <a:t>Constraint-based mining:</a:t>
+            </a:r>
+            <a:r>
+              <a:rPr lang="en-US" dirty="0"/>
+              <a:t> User-specified business rules</a:t>
+            </a:r>
+          </a:p>
+          <a:p>
+            <a:pPr marL="0" indent="0">
+              <a:buNone/>
+            </a:pPr>
+            <a:r>
+              <a:rPr lang="en-US" b="1" dirty="0"/>
+              <a:t>Modern Developments</a:t>
+            </a:r>
+          </a:p>
+          <a:p>
+            <a:r>
+              <a:rPr lang="en-US" b="1" dirty="0"/>
+              <a:t>Real-time association mining</a:t>
+            </a:r>
+            <a:r>
+              <a:rPr lang="en-US" dirty="0"/>
+              <a:t> for streaming data</a:t>
+            </a:r>
+          </a:p>
+          <a:p>
+            <a:r>
+              <a:rPr lang="en-US" b="1" dirty="0"/>
+              <a:t>Privacy-preserving techniques</a:t>
+            </a:r>
+            <a:r>
+              <a:rPr lang="en-US" dirty="0"/>
+              <a:t> for sensitive data</a:t>
+            </a:r>
+          </a:p>
+          <a:p>
+            <a:r>
+              <a:rPr lang="en-US" b="1" dirty="0"/>
+              <a:t>Deep learning approaches</a:t>
+            </a:r>
+            <a:r>
+              <a:rPr lang="en-US" dirty="0"/>
+              <a:t> for complex pattern discovery</a:t>
+            </a:r>
+          </a:p>
+          <a:p>
+            <a:pPr marL="0" indent="0">
+              <a:buNone/>
+            </a:pPr>
+            <a:r>
+              <a:rPr lang="en-US" b="1" dirty="0"/>
+              <a:t>Tools to Explore</a:t>
+            </a:r>
+          </a:p>
+          <a:p>
+            <a:r>
+              <a:rPr lang="en-US" b="1" dirty="0"/>
+              <a:t>Python:</a:t>
+            </a:r>
+            <a:r>
+              <a:rPr lang="en-US" dirty="0"/>
+              <a:t> </a:t>
+            </a:r>
+            <a:r>
+              <a:rPr lang="en-US" dirty="0" err="1"/>
+              <a:t>mlxtend</a:t>
+            </a:r>
+            <a:r>
+              <a:rPr lang="en-US" dirty="0"/>
+              <a:t>, </a:t>
+            </a:r>
+            <a:r>
+              <a:rPr lang="en-US" dirty="0" err="1"/>
+              <a:t>apyori</a:t>
+            </a:r>
+            <a:r>
+              <a:rPr lang="en-US" dirty="0"/>
+              <a:t> libraries</a:t>
+            </a:r>
+          </a:p>
+          <a:p>
+            <a:r>
+              <a:rPr lang="en-US" b="1" dirty="0"/>
+              <a:t>R:</a:t>
+            </a:r>
+            <a:r>
+              <a:rPr lang="en-US" dirty="0"/>
+              <a:t> </a:t>
+            </a:r>
+            <a:r>
+              <a:rPr lang="en-US" dirty="0" err="1"/>
+              <a:t>arules</a:t>
+            </a:r>
+            <a:r>
+              <a:rPr lang="en-US" dirty="0"/>
+              <a:t>, </a:t>
+            </a:r>
+            <a:r>
+              <a:rPr lang="en-US" dirty="0" err="1"/>
+              <a:t>arulesViz</a:t>
+            </a:r>
+            <a:r>
+              <a:rPr lang="en-US" dirty="0"/>
+              <a:t> packages</a:t>
+            </a:r>
+          </a:p>
+          <a:p>
+            <a:r>
+              <a:rPr lang="en-US" b="1" dirty="0"/>
+              <a:t>Spark:</a:t>
+            </a:r>
+            <a:r>
+              <a:rPr lang="en-US" dirty="0"/>
+              <a:t> MLlib for large-scale mining</a:t>
+            </a:r>
+          </a:p>
+          <a:p>
+            <a:endParaRPr lang="en-US" dirty="0"/>
+          </a:p>
+        </p:txBody>
+      </p:sp>
+    </p:spTree>
+    <p:extLst>
+      <p:ext uri="{BB962C8B-B14F-4D97-AF65-F5344CB8AC3E}">
+        <p14:creationId xmlns:p14="http://schemas.microsoft.com/office/powerpoint/2010/main" val="1798126145"/>
       </p:ext>
     </p:extLst>
   </p:cSld>

</xml_diff>